<commit_message>
Enlarge diagram slides for presentation readability
</commit_message>
<xml_diff>
--- a/docs/zh/09-Claude Code 使用技巧与注意事项.pptx
+++ b/docs/zh/09-Claude Code 使用技巧与注意事项.pptx
@@ -6901,8 +6901,8 @@
         </p:blipFill>
         <p:spPr>
           <a:xfrm>
-            <a:off x="822960" y="1508760"/>
-            <a:ext cx="10515600" cy="4160520"/>
+            <a:off x="201168" y="1078992"/>
+            <a:ext cx="11795760" cy="5394960"/>
           </a:xfrm>
           <a:prstGeom prst="rect">
             <a:avLst/>
@@ -6911,35 +6911,58 @@
       </p:pic>
       <p:sp>
         <p:nvSpPr>
-          <p:cNvPr id="6" name="TextBox 5"/>
-          <p:cNvSpPr txBox="1"/>
-          <p:nvPr/>
-        </p:nvSpPr>
-        <p:spPr>
-          <a:xfrm>
-            <a:off x="658368" y="6108192"/>
-            <a:ext cx="10881360" cy="320040"/>
-          </a:xfrm>
-          <a:prstGeom prst="rect">
-            <a:avLst/>
-          </a:prstGeom>
-          <a:noFill/>
-        </p:spPr>
-        <p:txBody>
-          <a:bodyPr wrap="square" tIns="12700" bIns="12700" lIns="12700" rIns="12700" anchor="t">
-            <a:spAutoFit/>
-          </a:bodyPr>
-          <a:lstStyle/>
-          <a:p>
-            <a:pPr algn="l"/>
-            <a:r>
-              <a:rPr sz="1100" b="0">
-                <a:solidFill>
-                  <a:srgbClr val="94A3B8"/>
-                </a:solidFill>
-                <a:latin typeface="Arial"/>
-              </a:rPr>
-              <a:t>这张图的重点是：用户输入会沿着 prompt stack（提示词栈）→ turn loop（轮次循环）→ tool pipeline（工具执行流水线）这条主链向下传递。</a:t>
+          <p:cNvPr id="6" name="Rounded Rectangle 5"/>
+          <p:cNvSpPr/>
+          <p:nvPr/>
+        </p:nvSpPr>
+        <p:spPr>
+          <a:xfrm>
+            <a:off x="320040" y="5897880"/>
+            <a:ext cx="11521440" cy="365760"/>
+          </a:xfrm>
+          <a:prstGeom prst="roundRect">
+            <a:avLst/>
+          </a:prstGeom>
+          <a:solidFill>
+            <a:srgbClr val="0F172A"/>
+          </a:solidFill>
+          <a:ln>
+            <a:solidFill>
+              <a:srgbClr val="22D3EE"/>
+            </a:solidFill>
+          </a:ln>
+        </p:spPr>
+        <p:style>
+          <a:lnRef idx="1">
+            <a:schemeClr val="accent1"/>
+          </a:lnRef>
+          <a:fillRef idx="3">
+            <a:schemeClr val="accent1"/>
+          </a:fillRef>
+          <a:effectRef idx="2">
+            <a:schemeClr val="accent1"/>
+          </a:effectRef>
+          <a:fontRef idx="minor">
+            <a:schemeClr val="lt1"/>
+          </a:fontRef>
+        </p:style>
+        <p:txBody>
+          <a:bodyPr rtlCol="0" anchor="t" wrap="square" tIns="50800" bIns="50800" lIns="101600" rIns="101600"/>
+          <a:lstStyle/>
+          <a:p>
+            <a:pPr algn="ctr">
+              <a:spcAft>
+                <a:spcPts val="600"/>
+              </a:spcAft>
+            </a:pPr>
+            <a:r>
+              <a:rPr sz="1200" b="0">
+                <a:solidFill>
+                  <a:srgbClr val="E2E8F0"/>
+                </a:solidFill>
+                <a:latin typeface="Arial"/>
+              </a:rPr>
+              <a:t>重点：用户输入会沿着 prompt stack（提示词栈）→ turn loop（轮次循环）→ tool pipeline（工具执行流水线）这条主链向下传递。</a:t>
             </a:r>
           </a:p>
         </p:txBody>
@@ -8990,8 +9013,8 @@
         </p:blipFill>
         <p:spPr>
           <a:xfrm>
-            <a:off x="868680" y="1554480"/>
-            <a:ext cx="10424160" cy="4251960"/>
+            <a:off x="201168" y="1078992"/>
+            <a:ext cx="11795760" cy="5394960"/>
           </a:xfrm>
           <a:prstGeom prst="rect">
             <a:avLst/>
@@ -9006,8 +9029,8 @@
         </p:nvSpPr>
         <p:spPr>
           <a:xfrm>
-            <a:off x="1097280" y="5650992"/>
-            <a:ext cx="10058400" cy="512064"/>
+            <a:off x="320040" y="5897880"/>
+            <a:ext cx="11521440" cy="365760"/>
           </a:xfrm>
           <a:prstGeom prst="roundRect">
             <a:avLst/>
@@ -9045,7 +9068,7 @@
               </a:spcAft>
             </a:pPr>
             <a:r>
-              <a:rPr sz="1400" b="0">
+              <a:rPr sz="1200" b="0">
                 <a:solidFill>
                   <a:srgbClr val="E2E8F0"/>
                 </a:solidFill>

</xml_diff>

<commit_message>
Redraw presentation diagrams with native shapes
</commit_message>
<xml_diff>
--- a/docs/zh/09-Claude Code 使用技巧与注意事项.pptx
+++ b/docs/zh/09-Claude Code 使用技巧与注意事项.pptx
@@ -6803,7 +6803,7 @@
                 </a:solidFill>
                 <a:latin typeface="Arial"/>
               </a:rPr>
-              <a:t>UML 总览图：Claude Code 的主执行链</a:t>
+              <a:t>结构图：Claude Code 的主执行链</a:t>
             </a:r>
           </a:p>
         </p:txBody>
@@ -6837,7 +6837,7 @@
                 </a:solidFill>
                 <a:latin typeface="Arial"/>
               </a:rPr>
-              <a:t>terminal agent runtime（终端代理运行时）视角</a:t>
+              <a:t>用最少的层说明系统是怎么跑起来的</a:t>
             </a:r>
           </a:p>
         </p:txBody>
@@ -6885,30 +6885,77 @@
           </a:p>
         </p:txBody>
       </p:sp>
-      <p:pic>
-        <p:nvPicPr>
-          <p:cNvPr id="5" name="Picture 4" descr="usage-overview.png"/>
-          <p:cNvPicPr>
-            <a:picLocks noChangeAspect="1"/>
-          </p:cNvPicPr>
-          <p:nvPr/>
-        </p:nvPicPr>
-        <p:blipFill>
-          <a:blip r:embed="rId2"/>
-          <a:stretch>
-            <a:fillRect/>
-          </a:stretch>
-        </p:blipFill>
-        <p:spPr>
-          <a:xfrm>
-            <a:off x="201168" y="1078992"/>
-            <a:ext cx="11795760" cy="5394960"/>
-          </a:xfrm>
-          <a:prstGeom prst="rect">
-            <a:avLst/>
-          </a:prstGeom>
-        </p:spPr>
-      </p:pic>
+      <p:sp>
+        <p:nvSpPr>
+          <p:cNvPr id="5" name="Rounded Rectangle 4"/>
+          <p:cNvSpPr/>
+          <p:nvPr/>
+        </p:nvSpPr>
+        <p:spPr>
+          <a:xfrm>
+            <a:off x="502920" y="1965960"/>
+            <a:ext cx="1828800" cy="1325880"/>
+          </a:xfrm>
+          <a:prstGeom prst="roundRect">
+            <a:avLst/>
+          </a:prstGeom>
+          <a:solidFill>
+            <a:srgbClr val="0A1224"/>
+          </a:solidFill>
+          <a:ln w="22860">
+            <a:solidFill>
+              <a:srgbClr val="22D3EE"/>
+            </a:solidFill>
+          </a:ln>
+        </p:spPr>
+        <p:style>
+          <a:lnRef idx="1">
+            <a:schemeClr val="accent1"/>
+          </a:lnRef>
+          <a:fillRef idx="3">
+            <a:schemeClr val="accent1"/>
+          </a:fillRef>
+          <a:effectRef idx="2">
+            <a:schemeClr val="accent1"/>
+          </a:effectRef>
+          <a:fontRef idx="minor">
+            <a:schemeClr val="lt1"/>
+          </a:fontRef>
+        </p:style>
+        <p:txBody>
+          <a:bodyPr rtlCol="0" anchor="t" wrap="square" tIns="101600" bIns="101600" lIns="152400" rIns="152400"/>
+          <a:lstStyle/>
+          <a:p>
+            <a:pPr algn="ctr"/>
+            <a:r>
+              <a:rPr sz="2000" b="1">
+                <a:solidFill>
+                  <a:srgbClr val="22D3EE"/>
+                </a:solidFill>
+                <a:latin typeface="Arial"/>
+              </a:rPr>
+              <a:t>User Prompt</a:t>
+            </a:r>
+          </a:p>
+          <a:p>
+            <a:pPr algn="ctr">
+              <a:spcBef>
+                <a:spcPts val="600"/>
+              </a:spcBef>
+            </a:pPr>
+            <a:r>
+              <a:rPr sz="1400" b="0">
+                <a:solidFill>
+                  <a:srgbClr val="E2E8F0"/>
+                </a:solidFill>
+                <a:latin typeface="Arial"/>
+              </a:rPr>
+              <a:t>用户输入
+目标 / 范围 / 约束</a:t>
+            </a:r>
+          </a:p>
+        </p:txBody>
+      </p:sp>
       <p:sp>
         <p:nvSpPr>
           <p:cNvPr id="6" name="Rounded Rectangle 5"/>
@@ -6917,8 +6964,748 @@
         </p:nvSpPr>
         <p:spPr>
           <a:xfrm>
-            <a:off x="320040" y="5897880"/>
-            <a:ext cx="11521440" cy="365760"/>
+            <a:off x="2697480" y="1965960"/>
+            <a:ext cx="1965960" cy="1325880"/>
+          </a:xfrm>
+          <a:prstGeom prst="roundRect">
+            <a:avLst/>
+          </a:prstGeom>
+          <a:solidFill>
+            <a:srgbClr val="0A1224"/>
+          </a:solidFill>
+          <a:ln w="22860">
+            <a:solidFill>
+              <a:srgbClr val="22D3EE"/>
+            </a:solidFill>
+          </a:ln>
+        </p:spPr>
+        <p:style>
+          <a:lnRef idx="1">
+            <a:schemeClr val="accent1"/>
+          </a:lnRef>
+          <a:fillRef idx="3">
+            <a:schemeClr val="accent1"/>
+          </a:fillRef>
+          <a:effectRef idx="2">
+            <a:schemeClr val="accent1"/>
+          </a:effectRef>
+          <a:fontRef idx="minor">
+            <a:schemeClr val="lt1"/>
+          </a:fontRef>
+        </p:style>
+        <p:txBody>
+          <a:bodyPr rtlCol="0" anchor="t" wrap="square" tIns="101600" bIns="101600" lIns="152400" rIns="152400"/>
+          <a:lstStyle/>
+          <a:p>
+            <a:pPr algn="ctr"/>
+            <a:r>
+              <a:rPr sz="2000" b="1">
+                <a:solidFill>
+                  <a:srgbClr val="22D3EE"/>
+                </a:solidFill>
+                <a:latin typeface="Arial"/>
+              </a:rPr>
+              <a:t>Prompt Stack</a:t>
+            </a:r>
+          </a:p>
+          <a:p>
+            <a:pPr algn="ctr">
+              <a:spcBef>
+                <a:spcPts val="600"/>
+              </a:spcBef>
+            </a:pPr>
+            <a:r>
+              <a:rPr sz="1400" b="0">
+                <a:solidFill>
+                  <a:srgbClr val="E2E8F0"/>
+                </a:solidFill>
+                <a:latin typeface="Arial"/>
+              </a:rPr>
+              <a:t>提示词栈
+默认行为约束</a:t>
+            </a:r>
+          </a:p>
+        </p:txBody>
+      </p:sp>
+      <p:sp>
+        <p:nvSpPr>
+          <p:cNvPr id="7" name="Rounded Rectangle 6"/>
+          <p:cNvSpPr/>
+          <p:nvPr/>
+        </p:nvSpPr>
+        <p:spPr>
+          <a:xfrm>
+            <a:off x="5029200" y="1965960"/>
+            <a:ext cx="1965960" cy="1325880"/>
+          </a:xfrm>
+          <a:prstGeom prst="roundRect">
+            <a:avLst/>
+          </a:prstGeom>
+          <a:solidFill>
+            <a:srgbClr val="0A1224"/>
+          </a:solidFill>
+          <a:ln w="22860">
+            <a:solidFill>
+              <a:srgbClr val="22D3EE"/>
+            </a:solidFill>
+          </a:ln>
+        </p:spPr>
+        <p:style>
+          <a:lnRef idx="1">
+            <a:schemeClr val="accent1"/>
+          </a:lnRef>
+          <a:fillRef idx="3">
+            <a:schemeClr val="accent1"/>
+          </a:fillRef>
+          <a:effectRef idx="2">
+            <a:schemeClr val="accent1"/>
+          </a:effectRef>
+          <a:fontRef idx="minor">
+            <a:schemeClr val="lt1"/>
+          </a:fontRef>
+        </p:style>
+        <p:txBody>
+          <a:bodyPr rtlCol="0" anchor="t" wrap="square" tIns="101600" bIns="101600" lIns="152400" rIns="152400"/>
+          <a:lstStyle/>
+          <a:p>
+            <a:pPr algn="ctr"/>
+            <a:r>
+              <a:rPr sz="2000" b="1">
+                <a:solidFill>
+                  <a:srgbClr val="22D3EE"/>
+                </a:solidFill>
+                <a:latin typeface="Arial"/>
+              </a:rPr>
+              <a:t>QueryEngine</a:t>
+            </a:r>
+          </a:p>
+          <a:p>
+            <a:pPr algn="ctr">
+              <a:spcBef>
+                <a:spcPts val="600"/>
+              </a:spcBef>
+            </a:pPr>
+            <a:r>
+              <a:rPr sz="1400" b="0">
+                <a:solidFill>
+                  <a:srgbClr val="E2E8F0"/>
+                </a:solidFill>
+                <a:latin typeface="Arial"/>
+              </a:rPr>
+              <a:t>会话宿主
+Conversation Host</a:t>
+            </a:r>
+          </a:p>
+        </p:txBody>
+      </p:sp>
+      <p:sp>
+        <p:nvSpPr>
+          <p:cNvPr id="8" name="Rounded Rectangle 7"/>
+          <p:cNvSpPr/>
+          <p:nvPr/>
+        </p:nvSpPr>
+        <p:spPr>
+          <a:xfrm>
+            <a:off x="7360920" y="1965960"/>
+            <a:ext cx="1965960" cy="1325880"/>
+          </a:xfrm>
+          <a:prstGeom prst="roundRect">
+            <a:avLst/>
+          </a:prstGeom>
+          <a:solidFill>
+            <a:srgbClr val="0A1224"/>
+          </a:solidFill>
+          <a:ln w="22860">
+            <a:solidFill>
+              <a:srgbClr val="22D3EE"/>
+            </a:solidFill>
+          </a:ln>
+        </p:spPr>
+        <p:style>
+          <a:lnRef idx="1">
+            <a:schemeClr val="accent1"/>
+          </a:lnRef>
+          <a:fillRef idx="3">
+            <a:schemeClr val="accent1"/>
+          </a:fillRef>
+          <a:effectRef idx="2">
+            <a:schemeClr val="accent1"/>
+          </a:effectRef>
+          <a:fontRef idx="minor">
+            <a:schemeClr val="lt1"/>
+          </a:fontRef>
+        </p:style>
+        <p:txBody>
+          <a:bodyPr rtlCol="0" anchor="t" wrap="square" tIns="101600" bIns="101600" lIns="152400" rIns="152400"/>
+          <a:lstStyle/>
+          <a:p>
+            <a:pPr algn="ctr"/>
+            <a:r>
+              <a:rPr sz="2000" b="1">
+                <a:solidFill>
+                  <a:srgbClr val="22D3EE"/>
+                </a:solidFill>
+                <a:latin typeface="Arial"/>
+              </a:rPr>
+              <a:t>query.ts</a:t>
+            </a:r>
+          </a:p>
+          <a:p>
+            <a:pPr algn="ctr">
+              <a:spcBef>
+                <a:spcPts val="600"/>
+              </a:spcBef>
+            </a:pPr>
+            <a:r>
+              <a:rPr sz="1400" b="0">
+                <a:solidFill>
+                  <a:srgbClr val="E2E8F0"/>
+                </a:solidFill>
+                <a:latin typeface="Arial"/>
+              </a:rPr>
+              <a:t>轮次循环
+Turn Loop</a:t>
+            </a:r>
+          </a:p>
+        </p:txBody>
+      </p:sp>
+      <p:sp>
+        <p:nvSpPr>
+          <p:cNvPr id="9" name="Rounded Rectangle 8"/>
+          <p:cNvSpPr/>
+          <p:nvPr/>
+        </p:nvSpPr>
+        <p:spPr>
+          <a:xfrm>
+            <a:off x="9692640" y="1965960"/>
+            <a:ext cx="1965960" cy="1325880"/>
+          </a:xfrm>
+          <a:prstGeom prst="roundRect">
+            <a:avLst/>
+          </a:prstGeom>
+          <a:solidFill>
+            <a:srgbClr val="0A1224"/>
+          </a:solidFill>
+          <a:ln w="22860">
+            <a:solidFill>
+              <a:srgbClr val="22D3EE"/>
+            </a:solidFill>
+          </a:ln>
+        </p:spPr>
+        <p:style>
+          <a:lnRef idx="1">
+            <a:schemeClr val="accent1"/>
+          </a:lnRef>
+          <a:fillRef idx="3">
+            <a:schemeClr val="accent1"/>
+          </a:fillRef>
+          <a:effectRef idx="2">
+            <a:schemeClr val="accent1"/>
+          </a:effectRef>
+          <a:fontRef idx="minor">
+            <a:schemeClr val="lt1"/>
+          </a:fontRef>
+        </p:style>
+        <p:txBody>
+          <a:bodyPr rtlCol="0" anchor="t" wrap="square" tIns="101600" bIns="101600" lIns="152400" rIns="152400"/>
+          <a:lstStyle/>
+          <a:p>
+            <a:pPr algn="ctr"/>
+            <a:r>
+              <a:rPr sz="2000" b="1">
+                <a:solidFill>
+                  <a:srgbClr val="22D3EE"/>
+                </a:solidFill>
+                <a:latin typeface="Arial"/>
+              </a:rPr>
+              <a:t>Tool Pipeline</a:t>
+            </a:r>
+          </a:p>
+          <a:p>
+            <a:pPr algn="ctr">
+              <a:spcBef>
+                <a:spcPts val="600"/>
+              </a:spcBef>
+            </a:pPr>
+            <a:r>
+              <a:rPr sz="1400" b="0">
+                <a:solidFill>
+                  <a:srgbClr val="E2E8F0"/>
+                </a:solidFill>
+                <a:latin typeface="Arial"/>
+              </a:rPr>
+              <a:t>工具执行流水线</a:t>
+            </a:r>
+          </a:p>
+        </p:txBody>
+      </p:sp>
+      <p:cxnSp>
+        <p:nvCxnSpPr>
+          <p:cNvPr id="10" name="Connector 9"/>
+          <p:cNvCxnSpPr/>
+          <p:nvPr/>
+        </p:nvCxnSpPr>
+        <p:spPr>
+          <a:xfrm>
+            <a:off x="2331720" y="2633472"/>
+            <a:ext cx="365760" cy="0"/>
+          </a:xfrm>
+          <a:prstGeom prst="line">
+            <a:avLst/>
+          </a:prstGeom>
+          <a:ln w="15875">
+            <a:solidFill>
+              <a:srgbClr val="22D3EE"/>
+            </a:solidFill>
+          </a:ln>
+        </p:spPr>
+        <p:style>
+          <a:lnRef idx="2">
+            <a:schemeClr val="accent1"/>
+          </a:lnRef>
+          <a:fillRef idx="0">
+            <a:schemeClr val="accent1"/>
+          </a:fillRef>
+          <a:effectRef idx="1">
+            <a:schemeClr val="accent1"/>
+          </a:effectRef>
+          <a:fontRef idx="minor">
+            <a:schemeClr val="tx1"/>
+          </a:fontRef>
+        </p:style>
+      </p:cxnSp>
+      <p:cxnSp>
+        <p:nvCxnSpPr>
+          <p:cNvPr id="11" name="Connector 10"/>
+          <p:cNvCxnSpPr/>
+          <p:nvPr/>
+        </p:nvCxnSpPr>
+        <p:spPr>
+          <a:xfrm>
+            <a:off x="4663440" y="2633472"/>
+            <a:ext cx="365760" cy="0"/>
+          </a:xfrm>
+          <a:prstGeom prst="line">
+            <a:avLst/>
+          </a:prstGeom>
+          <a:ln w="15875">
+            <a:solidFill>
+              <a:srgbClr val="22D3EE"/>
+            </a:solidFill>
+          </a:ln>
+        </p:spPr>
+        <p:style>
+          <a:lnRef idx="2">
+            <a:schemeClr val="accent1"/>
+          </a:lnRef>
+          <a:fillRef idx="0">
+            <a:schemeClr val="accent1"/>
+          </a:fillRef>
+          <a:effectRef idx="1">
+            <a:schemeClr val="accent1"/>
+          </a:effectRef>
+          <a:fontRef idx="minor">
+            <a:schemeClr val="tx1"/>
+          </a:fontRef>
+        </p:style>
+      </p:cxnSp>
+      <p:cxnSp>
+        <p:nvCxnSpPr>
+          <p:cNvPr id="12" name="Connector 11"/>
+          <p:cNvCxnSpPr/>
+          <p:nvPr/>
+        </p:nvCxnSpPr>
+        <p:spPr>
+          <a:xfrm>
+            <a:off x="6995160" y="2633472"/>
+            <a:ext cx="365760" cy="0"/>
+          </a:xfrm>
+          <a:prstGeom prst="line">
+            <a:avLst/>
+          </a:prstGeom>
+          <a:ln w="15875">
+            <a:solidFill>
+              <a:srgbClr val="22D3EE"/>
+            </a:solidFill>
+          </a:ln>
+        </p:spPr>
+        <p:style>
+          <a:lnRef idx="2">
+            <a:schemeClr val="accent1"/>
+          </a:lnRef>
+          <a:fillRef idx="0">
+            <a:schemeClr val="accent1"/>
+          </a:fillRef>
+          <a:effectRef idx="1">
+            <a:schemeClr val="accent1"/>
+          </a:effectRef>
+          <a:fontRef idx="minor">
+            <a:schemeClr val="tx1"/>
+          </a:fontRef>
+        </p:style>
+      </p:cxnSp>
+      <p:cxnSp>
+        <p:nvCxnSpPr>
+          <p:cNvPr id="13" name="Connector 12"/>
+          <p:cNvCxnSpPr/>
+          <p:nvPr/>
+        </p:nvCxnSpPr>
+        <p:spPr>
+          <a:xfrm>
+            <a:off x="9326880" y="2633472"/>
+            <a:ext cx="365760" cy="0"/>
+          </a:xfrm>
+          <a:prstGeom prst="line">
+            <a:avLst/>
+          </a:prstGeom>
+          <a:ln w="15875">
+            <a:solidFill>
+              <a:srgbClr val="22D3EE"/>
+            </a:solidFill>
+          </a:ln>
+        </p:spPr>
+        <p:style>
+          <a:lnRef idx="2">
+            <a:schemeClr val="accent1"/>
+          </a:lnRef>
+          <a:fillRef idx="0">
+            <a:schemeClr val="accent1"/>
+          </a:fillRef>
+          <a:effectRef idx="1">
+            <a:schemeClr val="accent1"/>
+          </a:effectRef>
+          <a:fontRef idx="minor">
+            <a:schemeClr val="tx1"/>
+          </a:fontRef>
+        </p:style>
+      </p:cxnSp>
+      <p:sp>
+        <p:nvSpPr>
+          <p:cNvPr id="14" name="Rounded Rectangle 13"/>
+          <p:cNvSpPr/>
+          <p:nvPr/>
+        </p:nvSpPr>
+        <p:spPr>
+          <a:xfrm>
+            <a:off x="2148840" y="4160520"/>
+            <a:ext cx="2926080" cy="1280160"/>
+          </a:xfrm>
+          <a:prstGeom prst="roundRect">
+            <a:avLst/>
+          </a:prstGeom>
+          <a:solidFill>
+            <a:srgbClr val="0A1224"/>
+          </a:solidFill>
+          <a:ln w="22860">
+            <a:solidFill>
+              <a:srgbClr val="22D3EE"/>
+            </a:solidFill>
+          </a:ln>
+        </p:spPr>
+        <p:style>
+          <a:lnRef idx="1">
+            <a:schemeClr val="accent1"/>
+          </a:lnRef>
+          <a:fillRef idx="3">
+            <a:schemeClr val="accent1"/>
+          </a:fillRef>
+          <a:effectRef idx="2">
+            <a:schemeClr val="accent1"/>
+          </a:effectRef>
+          <a:fontRef idx="minor">
+            <a:schemeClr val="lt1"/>
+          </a:fontRef>
+        </p:style>
+        <p:txBody>
+          <a:bodyPr rtlCol="0" anchor="t" wrap="square" tIns="101600" bIns="101600" lIns="152400" rIns="152400"/>
+          <a:lstStyle/>
+          <a:p>
+            <a:pPr algn="ctr"/>
+            <a:r>
+              <a:rPr sz="2000" b="1">
+                <a:solidFill>
+                  <a:srgbClr val="22D3EE"/>
+                </a:solidFill>
+                <a:latin typeface="Arial"/>
+              </a:rPr>
+              <a:t>Tools / Tasks</a:t>
+            </a:r>
+          </a:p>
+          <a:p>
+            <a:pPr algn="ctr">
+              <a:spcBef>
+                <a:spcPts val="600"/>
+              </a:spcBef>
+            </a:pPr>
+            <a:r>
+              <a:rPr sz="1400" b="0">
+                <a:solidFill>
+                  <a:srgbClr val="E2E8F0"/>
+                </a:solidFill>
+                <a:latin typeface="Arial"/>
+              </a:rPr>
+              <a:t>Bash / Read / Edit
+Subagents / Mailbox</a:t>
+            </a:r>
+          </a:p>
+        </p:txBody>
+      </p:sp>
+      <p:sp>
+        <p:nvSpPr>
+          <p:cNvPr id="15" name="Rounded Rectangle 14"/>
+          <p:cNvSpPr/>
+          <p:nvPr/>
+        </p:nvSpPr>
+        <p:spPr>
+          <a:xfrm>
+            <a:off x="5486400" y="4160520"/>
+            <a:ext cx="2194560" cy="1280160"/>
+          </a:xfrm>
+          <a:prstGeom prst="roundRect">
+            <a:avLst/>
+          </a:prstGeom>
+          <a:solidFill>
+            <a:srgbClr val="0A1224"/>
+          </a:solidFill>
+          <a:ln w="22860">
+            <a:solidFill>
+              <a:srgbClr val="22D3EE"/>
+            </a:solidFill>
+          </a:ln>
+        </p:spPr>
+        <p:style>
+          <a:lnRef idx="1">
+            <a:schemeClr val="accent1"/>
+          </a:lnRef>
+          <a:fillRef idx="3">
+            <a:schemeClr val="accent1"/>
+          </a:fillRef>
+          <a:effectRef idx="2">
+            <a:schemeClr val="accent1"/>
+          </a:effectRef>
+          <a:fontRef idx="minor">
+            <a:schemeClr val="lt1"/>
+          </a:fontRef>
+        </p:style>
+        <p:txBody>
+          <a:bodyPr rtlCol="0" anchor="t" wrap="square" tIns="101600" bIns="101600" lIns="152400" rIns="152400"/>
+          <a:lstStyle/>
+          <a:p>
+            <a:pPr algn="ctr"/>
+            <a:r>
+              <a:rPr sz="2000" b="1">
+                <a:solidFill>
+                  <a:srgbClr val="22D3EE"/>
+                </a:solidFill>
+                <a:latin typeface="Arial"/>
+              </a:rPr>
+              <a:t>Environment</a:t>
+            </a:r>
+          </a:p>
+          <a:p>
+            <a:pPr algn="ctr">
+              <a:spcBef>
+                <a:spcPts val="600"/>
+              </a:spcBef>
+            </a:pPr>
+            <a:r>
+              <a:rPr sz="1400" b="0">
+                <a:solidFill>
+                  <a:srgbClr val="E2E8F0"/>
+                </a:solidFill>
+                <a:latin typeface="Arial"/>
+              </a:rPr>
+              <a:t>Filesystem / Shell
+MCP</a:t>
+            </a:r>
+          </a:p>
+        </p:txBody>
+      </p:sp>
+      <p:sp>
+        <p:nvSpPr>
+          <p:cNvPr id="16" name="Rounded Rectangle 15"/>
+          <p:cNvSpPr/>
+          <p:nvPr/>
+        </p:nvSpPr>
+        <p:spPr>
+          <a:xfrm>
+            <a:off x="8092440" y="4160520"/>
+            <a:ext cx="2743200" cy="1280160"/>
+          </a:xfrm>
+          <a:prstGeom prst="roundRect">
+            <a:avLst/>
+          </a:prstGeom>
+          <a:solidFill>
+            <a:srgbClr val="0A1224"/>
+          </a:solidFill>
+          <a:ln w="22860">
+            <a:solidFill>
+              <a:srgbClr val="22D3EE"/>
+            </a:solidFill>
+          </a:ln>
+        </p:spPr>
+        <p:style>
+          <a:lnRef idx="1">
+            <a:schemeClr val="accent1"/>
+          </a:lnRef>
+          <a:fillRef idx="3">
+            <a:schemeClr val="accent1"/>
+          </a:fillRef>
+          <a:effectRef idx="2">
+            <a:schemeClr val="accent1"/>
+          </a:effectRef>
+          <a:fontRef idx="minor">
+            <a:schemeClr val="lt1"/>
+          </a:fontRef>
+        </p:style>
+        <p:txBody>
+          <a:bodyPr rtlCol="0" anchor="t" wrap="square" tIns="101600" bIns="101600" lIns="152400" rIns="152400"/>
+          <a:lstStyle/>
+          <a:p>
+            <a:pPr algn="ctr"/>
+            <a:r>
+              <a:rPr sz="2000" b="1">
+                <a:solidFill>
+                  <a:srgbClr val="22D3EE"/>
+                </a:solidFill>
+                <a:latin typeface="Arial"/>
+              </a:rPr>
+              <a:t>Control Plane</a:t>
+            </a:r>
+          </a:p>
+          <a:p>
+            <a:pPr algn="ctr">
+              <a:spcBef>
+                <a:spcPts val="600"/>
+              </a:spcBef>
+            </a:pPr>
+            <a:r>
+              <a:rPr sz="1400" b="0">
+                <a:solidFill>
+                  <a:srgbClr val="E2E8F0"/>
+                </a:solidFill>
+                <a:latin typeface="Arial"/>
+              </a:rPr>
+              <a:t>Settings / Auth / Policy</a:t>
+            </a:r>
+          </a:p>
+        </p:txBody>
+      </p:sp>
+      <p:cxnSp>
+        <p:nvCxnSpPr>
+          <p:cNvPr id="17" name="Connector 16"/>
+          <p:cNvCxnSpPr/>
+          <p:nvPr/>
+        </p:nvCxnSpPr>
+        <p:spPr>
+          <a:xfrm flipH="1">
+            <a:off x="9281160" y="3291840"/>
+            <a:ext cx="1371600" cy="868680"/>
+          </a:xfrm>
+          <a:prstGeom prst="line">
+            <a:avLst/>
+          </a:prstGeom>
+          <a:ln w="15875">
+            <a:solidFill>
+              <a:srgbClr val="22D3EE"/>
+            </a:solidFill>
+          </a:ln>
+        </p:spPr>
+        <p:style>
+          <a:lnRef idx="2">
+            <a:schemeClr val="accent1"/>
+          </a:lnRef>
+          <a:fillRef idx="0">
+            <a:schemeClr val="accent1"/>
+          </a:fillRef>
+          <a:effectRef idx="1">
+            <a:schemeClr val="accent1"/>
+          </a:effectRef>
+          <a:fontRef idx="minor">
+            <a:schemeClr val="tx1"/>
+          </a:fontRef>
+        </p:style>
+      </p:cxnSp>
+      <p:cxnSp>
+        <p:nvCxnSpPr>
+          <p:cNvPr id="18" name="Connector 17"/>
+          <p:cNvCxnSpPr/>
+          <p:nvPr/>
+        </p:nvCxnSpPr>
+        <p:spPr>
+          <a:xfrm>
+            <a:off x="5074920" y="4800600"/>
+            <a:ext cx="411480" cy="0"/>
+          </a:xfrm>
+          <a:prstGeom prst="line">
+            <a:avLst/>
+          </a:prstGeom>
+          <a:ln w="15875">
+            <a:solidFill>
+              <a:srgbClr val="22D3EE"/>
+            </a:solidFill>
+          </a:ln>
+        </p:spPr>
+        <p:style>
+          <a:lnRef idx="2">
+            <a:schemeClr val="accent1"/>
+          </a:lnRef>
+          <a:fillRef idx="0">
+            <a:schemeClr val="accent1"/>
+          </a:fillRef>
+          <a:effectRef idx="1">
+            <a:schemeClr val="accent1"/>
+          </a:effectRef>
+          <a:fontRef idx="minor">
+            <a:schemeClr val="tx1"/>
+          </a:fontRef>
+        </p:style>
+      </p:cxnSp>
+      <p:cxnSp>
+        <p:nvCxnSpPr>
+          <p:cNvPr id="19" name="Connector 18"/>
+          <p:cNvCxnSpPr/>
+          <p:nvPr/>
+        </p:nvCxnSpPr>
+        <p:spPr>
+          <a:xfrm>
+            <a:off x="7680960" y="4800600"/>
+            <a:ext cx="411480" cy="0"/>
+          </a:xfrm>
+          <a:prstGeom prst="line">
+            <a:avLst/>
+          </a:prstGeom>
+          <a:ln w="15875">
+            <a:solidFill>
+              <a:srgbClr val="22D3EE"/>
+            </a:solidFill>
+          </a:ln>
+        </p:spPr>
+        <p:style>
+          <a:lnRef idx="2">
+            <a:schemeClr val="accent1"/>
+          </a:lnRef>
+          <a:fillRef idx="0">
+            <a:schemeClr val="accent1"/>
+          </a:fillRef>
+          <a:effectRef idx="1">
+            <a:schemeClr val="accent1"/>
+          </a:effectRef>
+          <a:fontRef idx="minor">
+            <a:schemeClr val="tx1"/>
+          </a:fontRef>
+        </p:style>
+      </p:cxnSp>
+      <p:sp>
+        <p:nvSpPr>
+          <p:cNvPr id="20" name="Rounded Rectangle 19"/>
+          <p:cNvSpPr/>
+          <p:nvPr/>
+        </p:nvSpPr>
+        <p:spPr>
+          <a:xfrm>
+            <a:off x="685800" y="5806440"/>
+            <a:ext cx="10972800" cy="384048"/>
           </a:xfrm>
           <a:prstGeom prst="roundRect">
             <a:avLst/>
@@ -6956,13 +7743,13 @@
               </a:spcAft>
             </a:pPr>
             <a:r>
-              <a:rPr sz="1200" b="0">
+              <a:rPr sz="1300" b="0">
                 <a:solidFill>
                   <a:srgbClr val="E2E8F0"/>
                 </a:solidFill>
                 <a:latin typeface="Arial"/>
               </a:rPr>
-              <a:t>重点：用户输入会沿着 prompt stack（提示词栈）→ turn loop（轮次循环）→ tool pipeline（工具执行流水线）这条主链向下传递。</a:t>
+              <a:t>重点：用户技巧之所以有效，是因为它们会直接影响 Prompt Stack、Turn Loop 和 Tool Pipeline 这条主链。</a:t>
             </a:r>
           </a:p>
         </p:txBody>
@@ -8997,46 +9784,582 @@
           </a:p>
         </p:txBody>
       </p:sp>
-      <p:pic>
-        <p:nvPicPr>
-          <p:cNvPr id="5" name="Picture 4" descr="usage-sequence.png"/>
-          <p:cNvPicPr>
-            <a:picLocks noChangeAspect="1"/>
-          </p:cNvPicPr>
-          <p:nvPr/>
-        </p:nvPicPr>
-        <p:blipFill>
-          <a:blip r:embed="rId2"/>
-          <a:stretch>
-            <a:fillRect/>
-          </a:stretch>
-        </p:blipFill>
-        <p:spPr>
-          <a:xfrm>
-            <a:off x="201168" y="1078992"/>
-            <a:ext cx="11795760" cy="5394960"/>
-          </a:xfrm>
-          <a:prstGeom prst="rect">
-            <a:avLst/>
-          </a:prstGeom>
-        </p:spPr>
-      </p:pic>
-      <p:sp>
-        <p:nvSpPr>
-          <p:cNvPr id="6" name="Rounded Rectangle 5"/>
+      <p:sp>
+        <p:nvSpPr>
+          <p:cNvPr id="5" name="Rounded Rectangle 4"/>
           <p:cNvSpPr/>
           <p:nvPr/>
         </p:nvSpPr>
         <p:spPr>
           <a:xfrm>
-            <a:off x="320040" y="5897880"/>
-            <a:ext cx="11521440" cy="365760"/>
+            <a:off x="914400" y="1572768"/>
+            <a:ext cx="1508760" cy="749808"/>
           </a:xfrm>
           <a:prstGeom prst="roundRect">
             <a:avLst/>
           </a:prstGeom>
           <a:solidFill>
-            <a:srgbClr val="0F172A"/>
+            <a:srgbClr val="0A1224"/>
+          </a:solidFill>
+          <a:ln w="22860">
+            <a:solidFill>
+              <a:srgbClr val="22D3EE"/>
+            </a:solidFill>
+          </a:ln>
+        </p:spPr>
+        <p:style>
+          <a:lnRef idx="1">
+            <a:schemeClr val="accent1"/>
+          </a:lnRef>
+          <a:fillRef idx="3">
+            <a:schemeClr val="accent1"/>
+          </a:fillRef>
+          <a:effectRef idx="2">
+            <a:schemeClr val="accent1"/>
+          </a:effectRef>
+          <a:fontRef idx="minor">
+            <a:schemeClr val="lt1"/>
+          </a:fontRef>
+        </p:style>
+        <p:txBody>
+          <a:bodyPr rtlCol="0" anchor="t" wrap="square" tIns="101600" bIns="101600" lIns="152400" rIns="152400"/>
+          <a:lstStyle/>
+          <a:p>
+            <a:pPr algn="ctr"/>
+            <a:r>
+              <a:rPr sz="2000" b="1">
+                <a:solidFill>
+                  <a:srgbClr val="22D3EE"/>
+                </a:solidFill>
+                <a:latin typeface="Arial"/>
+              </a:rPr>
+              <a:t>User</a:t>
+            </a:r>
+          </a:p>
+          <a:p>
+            <a:pPr algn="ctr">
+              <a:spcBef>
+                <a:spcPts val="600"/>
+              </a:spcBef>
+            </a:pPr>
+            <a:r>
+              <a:rPr sz="1400" b="0">
+                <a:solidFill>
+                  <a:srgbClr val="E2E8F0"/>
+                </a:solidFill>
+                <a:latin typeface="Arial"/>
+              </a:rPr>
+              <a:t/>
+            </a:r>
+          </a:p>
+        </p:txBody>
+      </p:sp>
+      <p:cxnSp>
+        <p:nvCxnSpPr>
+          <p:cNvPr id="6" name="Connector 5"/>
+          <p:cNvCxnSpPr/>
+          <p:nvPr/>
+        </p:nvCxnSpPr>
+        <p:spPr>
+          <a:xfrm>
+            <a:off x="1668780" y="2322576"/>
+            <a:ext cx="0" cy="3163824"/>
+          </a:xfrm>
+          <a:prstGeom prst="line">
+            <a:avLst/>
+          </a:prstGeom>
+          <a:ln w="15240">
+            <a:solidFill>
+              <a:srgbClr val="1E293B"/>
+            </a:solidFill>
+          </a:ln>
+        </p:spPr>
+        <p:style>
+          <a:lnRef idx="2">
+            <a:schemeClr val="accent1"/>
+          </a:lnRef>
+          <a:fillRef idx="0">
+            <a:schemeClr val="accent1"/>
+          </a:fillRef>
+          <a:effectRef idx="1">
+            <a:schemeClr val="accent1"/>
+          </a:effectRef>
+          <a:fontRef idx="minor">
+            <a:schemeClr val="tx1"/>
+          </a:fontRef>
+        </p:style>
+      </p:cxnSp>
+      <p:sp>
+        <p:nvSpPr>
+          <p:cNvPr id="7" name="Rounded Rectangle 6"/>
+          <p:cNvSpPr/>
+          <p:nvPr/>
+        </p:nvSpPr>
+        <p:spPr>
+          <a:xfrm>
+            <a:off x="3063240" y="1572768"/>
+            <a:ext cx="1508760" cy="749808"/>
+          </a:xfrm>
+          <a:prstGeom prst="roundRect">
+            <a:avLst/>
+          </a:prstGeom>
+          <a:solidFill>
+            <a:srgbClr val="0A1224"/>
+          </a:solidFill>
+          <a:ln w="22860">
+            <a:solidFill>
+              <a:srgbClr val="22D3EE"/>
+            </a:solidFill>
+          </a:ln>
+        </p:spPr>
+        <p:style>
+          <a:lnRef idx="1">
+            <a:schemeClr val="accent1"/>
+          </a:lnRef>
+          <a:fillRef idx="3">
+            <a:schemeClr val="accent1"/>
+          </a:fillRef>
+          <a:effectRef idx="2">
+            <a:schemeClr val="accent1"/>
+          </a:effectRef>
+          <a:fontRef idx="minor">
+            <a:schemeClr val="lt1"/>
+          </a:fontRef>
+        </p:style>
+        <p:txBody>
+          <a:bodyPr rtlCol="0" anchor="t" wrap="square" tIns="101600" bIns="101600" lIns="152400" rIns="152400"/>
+          <a:lstStyle/>
+          <a:p>
+            <a:pPr algn="ctr"/>
+            <a:r>
+              <a:rPr sz="2000" b="1">
+                <a:solidFill>
+                  <a:srgbClr val="22D3EE"/>
+                </a:solidFill>
+                <a:latin typeface="Arial"/>
+              </a:rPr>
+              <a:t>Prompt Stack</a:t>
+            </a:r>
+          </a:p>
+          <a:p>
+            <a:pPr algn="ctr">
+              <a:spcBef>
+                <a:spcPts val="600"/>
+              </a:spcBef>
+            </a:pPr>
+            <a:r>
+              <a:rPr sz="1400" b="0">
+                <a:solidFill>
+                  <a:srgbClr val="E2E8F0"/>
+                </a:solidFill>
+                <a:latin typeface="Arial"/>
+              </a:rPr>
+              <a:t/>
+            </a:r>
+          </a:p>
+        </p:txBody>
+      </p:sp>
+      <p:cxnSp>
+        <p:nvCxnSpPr>
+          <p:cNvPr id="8" name="Connector 7"/>
+          <p:cNvCxnSpPr/>
+          <p:nvPr/>
+        </p:nvCxnSpPr>
+        <p:spPr>
+          <a:xfrm>
+            <a:off x="3817620" y="2322576"/>
+            <a:ext cx="0" cy="3163824"/>
+          </a:xfrm>
+          <a:prstGeom prst="line">
+            <a:avLst/>
+          </a:prstGeom>
+          <a:ln w="15240">
+            <a:solidFill>
+              <a:srgbClr val="1E293B"/>
+            </a:solidFill>
+          </a:ln>
+        </p:spPr>
+        <p:style>
+          <a:lnRef idx="2">
+            <a:schemeClr val="accent1"/>
+          </a:lnRef>
+          <a:fillRef idx="0">
+            <a:schemeClr val="accent1"/>
+          </a:fillRef>
+          <a:effectRef idx="1">
+            <a:schemeClr val="accent1"/>
+          </a:effectRef>
+          <a:fontRef idx="minor">
+            <a:schemeClr val="tx1"/>
+          </a:fontRef>
+        </p:style>
+      </p:cxnSp>
+      <p:sp>
+        <p:nvSpPr>
+          <p:cNvPr id="9" name="Rounded Rectangle 8"/>
+          <p:cNvSpPr/>
+          <p:nvPr/>
+        </p:nvSpPr>
+        <p:spPr>
+          <a:xfrm>
+            <a:off x="5212080" y="1572768"/>
+            <a:ext cx="1508760" cy="749808"/>
+          </a:xfrm>
+          <a:prstGeom prst="roundRect">
+            <a:avLst/>
+          </a:prstGeom>
+          <a:solidFill>
+            <a:srgbClr val="0A1224"/>
+          </a:solidFill>
+          <a:ln w="22860">
+            <a:solidFill>
+              <a:srgbClr val="22D3EE"/>
+            </a:solidFill>
+          </a:ln>
+        </p:spPr>
+        <p:style>
+          <a:lnRef idx="1">
+            <a:schemeClr val="accent1"/>
+          </a:lnRef>
+          <a:fillRef idx="3">
+            <a:schemeClr val="accent1"/>
+          </a:fillRef>
+          <a:effectRef idx="2">
+            <a:schemeClr val="accent1"/>
+          </a:effectRef>
+          <a:fontRef idx="minor">
+            <a:schemeClr val="lt1"/>
+          </a:fontRef>
+        </p:style>
+        <p:txBody>
+          <a:bodyPr rtlCol="0" anchor="t" wrap="square" tIns="101600" bIns="101600" lIns="152400" rIns="152400"/>
+          <a:lstStyle/>
+          <a:p>
+            <a:pPr algn="ctr"/>
+            <a:r>
+              <a:rPr sz="2000" b="1">
+                <a:solidFill>
+                  <a:srgbClr val="22D3EE"/>
+                </a:solidFill>
+                <a:latin typeface="Arial"/>
+              </a:rPr>
+              <a:t>QueryEngine</a:t>
+            </a:r>
+          </a:p>
+          <a:p>
+            <a:pPr algn="ctr">
+              <a:spcBef>
+                <a:spcPts val="600"/>
+              </a:spcBef>
+            </a:pPr>
+            <a:r>
+              <a:rPr sz="1400" b="0">
+                <a:solidFill>
+                  <a:srgbClr val="E2E8F0"/>
+                </a:solidFill>
+                <a:latin typeface="Arial"/>
+              </a:rPr>
+              <a:t/>
+            </a:r>
+          </a:p>
+        </p:txBody>
+      </p:sp>
+      <p:cxnSp>
+        <p:nvCxnSpPr>
+          <p:cNvPr id="10" name="Connector 9"/>
+          <p:cNvCxnSpPr/>
+          <p:nvPr/>
+        </p:nvCxnSpPr>
+        <p:spPr>
+          <a:xfrm>
+            <a:off x="5966460" y="2322576"/>
+            <a:ext cx="0" cy="3163824"/>
+          </a:xfrm>
+          <a:prstGeom prst="line">
+            <a:avLst/>
+          </a:prstGeom>
+          <a:ln w="15240">
+            <a:solidFill>
+              <a:srgbClr val="1E293B"/>
+            </a:solidFill>
+          </a:ln>
+        </p:spPr>
+        <p:style>
+          <a:lnRef idx="2">
+            <a:schemeClr val="accent1"/>
+          </a:lnRef>
+          <a:fillRef idx="0">
+            <a:schemeClr val="accent1"/>
+          </a:fillRef>
+          <a:effectRef idx="1">
+            <a:schemeClr val="accent1"/>
+          </a:effectRef>
+          <a:fontRef idx="minor">
+            <a:schemeClr val="tx1"/>
+          </a:fontRef>
+        </p:style>
+      </p:cxnSp>
+      <p:sp>
+        <p:nvSpPr>
+          <p:cNvPr id="11" name="Rounded Rectangle 10"/>
+          <p:cNvSpPr/>
+          <p:nvPr/>
+        </p:nvSpPr>
+        <p:spPr>
+          <a:xfrm>
+            <a:off x="7360920" y="1572768"/>
+            <a:ext cx="1508760" cy="749808"/>
+          </a:xfrm>
+          <a:prstGeom prst="roundRect">
+            <a:avLst/>
+          </a:prstGeom>
+          <a:solidFill>
+            <a:srgbClr val="0A1224"/>
+          </a:solidFill>
+          <a:ln w="22860">
+            <a:solidFill>
+              <a:srgbClr val="22D3EE"/>
+            </a:solidFill>
+          </a:ln>
+        </p:spPr>
+        <p:style>
+          <a:lnRef idx="1">
+            <a:schemeClr val="accent1"/>
+          </a:lnRef>
+          <a:fillRef idx="3">
+            <a:schemeClr val="accent1"/>
+          </a:fillRef>
+          <a:effectRef idx="2">
+            <a:schemeClr val="accent1"/>
+          </a:effectRef>
+          <a:fontRef idx="minor">
+            <a:schemeClr val="lt1"/>
+          </a:fontRef>
+        </p:style>
+        <p:txBody>
+          <a:bodyPr rtlCol="0" anchor="t" wrap="square" tIns="101600" bIns="101600" lIns="152400" rIns="152400"/>
+          <a:lstStyle/>
+          <a:p>
+            <a:pPr algn="ctr"/>
+            <a:r>
+              <a:rPr sz="2000" b="1">
+                <a:solidFill>
+                  <a:srgbClr val="22D3EE"/>
+                </a:solidFill>
+                <a:latin typeface="Arial"/>
+              </a:rPr>
+              <a:t>query.ts</a:t>
+            </a:r>
+          </a:p>
+          <a:p>
+            <a:pPr algn="ctr">
+              <a:spcBef>
+                <a:spcPts val="600"/>
+              </a:spcBef>
+            </a:pPr>
+            <a:r>
+              <a:rPr sz="1400" b="0">
+                <a:solidFill>
+                  <a:srgbClr val="E2E8F0"/>
+                </a:solidFill>
+                <a:latin typeface="Arial"/>
+              </a:rPr>
+              <a:t/>
+            </a:r>
+          </a:p>
+        </p:txBody>
+      </p:sp>
+      <p:cxnSp>
+        <p:nvCxnSpPr>
+          <p:cNvPr id="12" name="Connector 11"/>
+          <p:cNvCxnSpPr/>
+          <p:nvPr/>
+        </p:nvCxnSpPr>
+        <p:spPr>
+          <a:xfrm>
+            <a:off x="8115300" y="2322576"/>
+            <a:ext cx="0" cy="3163824"/>
+          </a:xfrm>
+          <a:prstGeom prst="line">
+            <a:avLst/>
+          </a:prstGeom>
+          <a:ln w="15240">
+            <a:solidFill>
+              <a:srgbClr val="1E293B"/>
+            </a:solidFill>
+          </a:ln>
+        </p:spPr>
+        <p:style>
+          <a:lnRef idx="2">
+            <a:schemeClr val="accent1"/>
+          </a:lnRef>
+          <a:fillRef idx="0">
+            <a:schemeClr val="accent1"/>
+          </a:fillRef>
+          <a:effectRef idx="1">
+            <a:schemeClr val="accent1"/>
+          </a:effectRef>
+          <a:fontRef idx="minor">
+            <a:schemeClr val="tx1"/>
+          </a:fontRef>
+        </p:style>
+      </p:cxnSp>
+      <p:sp>
+        <p:nvSpPr>
+          <p:cNvPr id="13" name="Rounded Rectangle 12"/>
+          <p:cNvSpPr/>
+          <p:nvPr/>
+        </p:nvSpPr>
+        <p:spPr>
+          <a:xfrm>
+            <a:off x="9464040" y="1572768"/>
+            <a:ext cx="1508760" cy="749808"/>
+          </a:xfrm>
+          <a:prstGeom prst="roundRect">
+            <a:avLst/>
+          </a:prstGeom>
+          <a:solidFill>
+            <a:srgbClr val="0A1224"/>
+          </a:solidFill>
+          <a:ln w="22860">
+            <a:solidFill>
+              <a:srgbClr val="22D3EE"/>
+            </a:solidFill>
+          </a:ln>
+        </p:spPr>
+        <p:style>
+          <a:lnRef idx="1">
+            <a:schemeClr val="accent1"/>
+          </a:lnRef>
+          <a:fillRef idx="3">
+            <a:schemeClr val="accent1"/>
+          </a:fillRef>
+          <a:effectRef idx="2">
+            <a:schemeClr val="accent1"/>
+          </a:effectRef>
+          <a:fontRef idx="minor">
+            <a:schemeClr val="lt1"/>
+          </a:fontRef>
+        </p:style>
+        <p:txBody>
+          <a:bodyPr rtlCol="0" anchor="t" wrap="square" tIns="101600" bIns="101600" lIns="152400" rIns="152400"/>
+          <a:lstStyle/>
+          <a:p>
+            <a:pPr algn="ctr"/>
+            <a:r>
+              <a:rPr sz="2000" b="1">
+                <a:solidFill>
+                  <a:srgbClr val="22D3EE"/>
+                </a:solidFill>
+                <a:latin typeface="Arial"/>
+              </a:rPr>
+              <a:t>Tool Pipeline</a:t>
+            </a:r>
+          </a:p>
+          <a:p>
+            <a:pPr algn="ctr">
+              <a:spcBef>
+                <a:spcPts val="600"/>
+              </a:spcBef>
+            </a:pPr>
+            <a:r>
+              <a:rPr sz="1400" b="0">
+                <a:solidFill>
+                  <a:srgbClr val="E2E8F0"/>
+                </a:solidFill>
+                <a:latin typeface="Arial"/>
+              </a:rPr>
+              <a:t/>
+            </a:r>
+          </a:p>
+        </p:txBody>
+      </p:sp>
+      <p:cxnSp>
+        <p:nvCxnSpPr>
+          <p:cNvPr id="14" name="Connector 13"/>
+          <p:cNvCxnSpPr/>
+          <p:nvPr/>
+        </p:nvCxnSpPr>
+        <p:spPr>
+          <a:xfrm>
+            <a:off x="10218419" y="2322576"/>
+            <a:ext cx="0" cy="3163824"/>
+          </a:xfrm>
+          <a:prstGeom prst="line">
+            <a:avLst/>
+          </a:prstGeom>
+          <a:ln w="15240">
+            <a:solidFill>
+              <a:srgbClr val="1E293B"/>
+            </a:solidFill>
+          </a:ln>
+        </p:spPr>
+        <p:style>
+          <a:lnRef idx="2">
+            <a:schemeClr val="accent1"/>
+          </a:lnRef>
+          <a:fillRef idx="0">
+            <a:schemeClr val="accent1"/>
+          </a:fillRef>
+          <a:effectRef idx="1">
+            <a:schemeClr val="accent1"/>
+          </a:effectRef>
+          <a:fontRef idx="minor">
+            <a:schemeClr val="tx1"/>
+          </a:fontRef>
+        </p:style>
+      </p:cxnSp>
+      <p:cxnSp>
+        <p:nvCxnSpPr>
+          <p:cNvPr id="15" name="Connector 14"/>
+          <p:cNvCxnSpPr/>
+          <p:nvPr/>
+        </p:nvCxnSpPr>
+        <p:spPr>
+          <a:xfrm>
+            <a:off x="1664208" y="2697480"/>
+            <a:ext cx="2148840" cy="0"/>
+          </a:xfrm>
+          <a:prstGeom prst="line">
+            <a:avLst/>
+          </a:prstGeom>
+          <a:ln w="15875">
+            <a:solidFill>
+              <a:srgbClr val="22D3EE"/>
+            </a:solidFill>
+          </a:ln>
+        </p:spPr>
+        <p:style>
+          <a:lnRef idx="2">
+            <a:schemeClr val="accent1"/>
+          </a:lnRef>
+          <a:fillRef idx="0">
+            <a:schemeClr val="accent1"/>
+          </a:fillRef>
+          <a:effectRef idx="1">
+            <a:schemeClr val="accent1"/>
+          </a:effectRef>
+          <a:fontRef idx="minor">
+            <a:schemeClr val="tx1"/>
+          </a:fontRef>
+        </p:style>
+      </p:cxnSp>
+      <p:sp>
+        <p:nvSpPr>
+          <p:cNvPr id="16" name="Rounded Rectangle 15"/>
+          <p:cNvSpPr/>
+          <p:nvPr/>
+        </p:nvSpPr>
+        <p:spPr>
+          <a:xfrm>
+            <a:off x="1773936" y="2569464"/>
+            <a:ext cx="1929383" cy="274320"/>
+          </a:xfrm>
+          <a:prstGeom prst="roundRect">
+            <a:avLst/>
+          </a:prstGeom>
+          <a:solidFill>
+            <a:srgbClr val="0C1E38"/>
           </a:solidFill>
           <a:ln>
             <a:solidFill>
@@ -9068,7 +10391,530 @@
               </a:spcAft>
             </a:pPr>
             <a:r>
-              <a:rPr sz="1200" b="0">
+              <a:rPr sz="1150" b="0">
+                <a:solidFill>
+                  <a:srgbClr val="E2E8F0"/>
+                </a:solidFill>
+                <a:latin typeface="Arial"/>
+              </a:rPr>
+              <a:t>任务输入 / 约束</a:t>
+            </a:r>
+          </a:p>
+        </p:txBody>
+      </p:sp>
+      <p:cxnSp>
+        <p:nvCxnSpPr>
+          <p:cNvPr id="17" name="Connector 16"/>
+          <p:cNvCxnSpPr/>
+          <p:nvPr/>
+        </p:nvCxnSpPr>
+        <p:spPr>
+          <a:xfrm>
+            <a:off x="3813048" y="3154680"/>
+            <a:ext cx="2148840" cy="0"/>
+          </a:xfrm>
+          <a:prstGeom prst="line">
+            <a:avLst/>
+          </a:prstGeom>
+          <a:ln w="15875">
+            <a:solidFill>
+              <a:srgbClr val="22D3EE"/>
+            </a:solidFill>
+          </a:ln>
+        </p:spPr>
+        <p:style>
+          <a:lnRef idx="2">
+            <a:schemeClr val="accent1"/>
+          </a:lnRef>
+          <a:fillRef idx="0">
+            <a:schemeClr val="accent1"/>
+          </a:fillRef>
+          <a:effectRef idx="1">
+            <a:schemeClr val="accent1"/>
+          </a:effectRef>
+          <a:fontRef idx="minor">
+            <a:schemeClr val="tx1"/>
+          </a:fontRef>
+        </p:style>
+      </p:cxnSp>
+      <p:sp>
+        <p:nvSpPr>
+          <p:cNvPr id="18" name="Rounded Rectangle 17"/>
+          <p:cNvSpPr/>
+          <p:nvPr/>
+        </p:nvSpPr>
+        <p:spPr>
+          <a:xfrm>
+            <a:off x="3922776" y="3026664"/>
+            <a:ext cx="1929383" cy="274320"/>
+          </a:xfrm>
+          <a:prstGeom prst="roundRect">
+            <a:avLst/>
+          </a:prstGeom>
+          <a:solidFill>
+            <a:srgbClr val="0C1E38"/>
+          </a:solidFill>
+          <a:ln>
+            <a:solidFill>
+              <a:srgbClr val="22D3EE"/>
+            </a:solidFill>
+          </a:ln>
+        </p:spPr>
+        <p:style>
+          <a:lnRef idx="1">
+            <a:schemeClr val="accent1"/>
+          </a:lnRef>
+          <a:fillRef idx="3">
+            <a:schemeClr val="accent1"/>
+          </a:fillRef>
+          <a:effectRef idx="2">
+            <a:schemeClr val="accent1"/>
+          </a:effectRef>
+          <a:fontRef idx="minor">
+            <a:schemeClr val="lt1"/>
+          </a:fontRef>
+        </p:style>
+        <p:txBody>
+          <a:bodyPr rtlCol="0" anchor="t" wrap="square" tIns="50800" bIns="50800" lIns="101600" rIns="101600"/>
+          <a:lstStyle/>
+          <a:p>
+            <a:pPr algn="ctr">
+              <a:spcAft>
+                <a:spcPts val="600"/>
+              </a:spcAft>
+            </a:pPr>
+            <a:r>
+              <a:rPr sz="1150" b="0">
+                <a:solidFill>
+                  <a:srgbClr val="E2E8F0"/>
+                </a:solidFill>
+                <a:latin typeface="Arial"/>
+              </a:rPr>
+              <a:t>组装 prompt 与 context</a:t>
+            </a:r>
+          </a:p>
+        </p:txBody>
+      </p:sp>
+      <p:cxnSp>
+        <p:nvCxnSpPr>
+          <p:cNvPr id="19" name="Connector 18"/>
+          <p:cNvCxnSpPr/>
+          <p:nvPr/>
+        </p:nvCxnSpPr>
+        <p:spPr>
+          <a:xfrm>
+            <a:off x="5961888" y="3611880"/>
+            <a:ext cx="2148839" cy="0"/>
+          </a:xfrm>
+          <a:prstGeom prst="line">
+            <a:avLst/>
+          </a:prstGeom>
+          <a:ln w="15875">
+            <a:solidFill>
+              <a:srgbClr val="22D3EE"/>
+            </a:solidFill>
+          </a:ln>
+        </p:spPr>
+        <p:style>
+          <a:lnRef idx="2">
+            <a:schemeClr val="accent1"/>
+          </a:lnRef>
+          <a:fillRef idx="0">
+            <a:schemeClr val="accent1"/>
+          </a:fillRef>
+          <a:effectRef idx="1">
+            <a:schemeClr val="accent1"/>
+          </a:effectRef>
+          <a:fontRef idx="minor">
+            <a:schemeClr val="tx1"/>
+          </a:fontRef>
+        </p:style>
+      </p:cxnSp>
+      <p:sp>
+        <p:nvSpPr>
+          <p:cNvPr id="20" name="Rounded Rectangle 19"/>
+          <p:cNvSpPr/>
+          <p:nvPr/>
+        </p:nvSpPr>
+        <p:spPr>
+          <a:xfrm>
+            <a:off x="6071616" y="3483864"/>
+            <a:ext cx="1929383" cy="274320"/>
+          </a:xfrm>
+          <a:prstGeom prst="roundRect">
+            <a:avLst/>
+          </a:prstGeom>
+          <a:solidFill>
+            <a:srgbClr val="0C1E38"/>
+          </a:solidFill>
+          <a:ln>
+            <a:solidFill>
+              <a:srgbClr val="22D3EE"/>
+            </a:solidFill>
+          </a:ln>
+        </p:spPr>
+        <p:style>
+          <a:lnRef idx="1">
+            <a:schemeClr val="accent1"/>
+          </a:lnRef>
+          <a:fillRef idx="3">
+            <a:schemeClr val="accent1"/>
+          </a:fillRef>
+          <a:effectRef idx="2">
+            <a:schemeClr val="accent1"/>
+          </a:effectRef>
+          <a:fontRef idx="minor">
+            <a:schemeClr val="lt1"/>
+          </a:fontRef>
+        </p:style>
+        <p:txBody>
+          <a:bodyPr rtlCol="0" anchor="t" wrap="square" tIns="50800" bIns="50800" lIns="101600" rIns="101600"/>
+          <a:lstStyle/>
+          <a:p>
+            <a:pPr algn="ctr">
+              <a:spcAft>
+                <a:spcPts val="600"/>
+              </a:spcAft>
+            </a:pPr>
+            <a:r>
+              <a:rPr sz="1150" b="0">
+                <a:solidFill>
+                  <a:srgbClr val="E2E8F0"/>
+                </a:solidFill>
+                <a:latin typeface="Arial"/>
+              </a:rPr>
+              <a:t>启动 turn loop</a:t>
+            </a:r>
+          </a:p>
+        </p:txBody>
+      </p:sp>
+      <p:cxnSp>
+        <p:nvCxnSpPr>
+          <p:cNvPr id="21" name="Connector 20"/>
+          <p:cNvCxnSpPr/>
+          <p:nvPr/>
+        </p:nvCxnSpPr>
+        <p:spPr>
+          <a:xfrm>
+            <a:off x="8110727" y="4069080"/>
+            <a:ext cx="2103121" cy="0"/>
+          </a:xfrm>
+          <a:prstGeom prst="line">
+            <a:avLst/>
+          </a:prstGeom>
+          <a:ln w="15875">
+            <a:solidFill>
+              <a:srgbClr val="22D3EE"/>
+            </a:solidFill>
+          </a:ln>
+        </p:spPr>
+        <p:style>
+          <a:lnRef idx="2">
+            <a:schemeClr val="accent1"/>
+          </a:lnRef>
+          <a:fillRef idx="0">
+            <a:schemeClr val="accent1"/>
+          </a:fillRef>
+          <a:effectRef idx="1">
+            <a:schemeClr val="accent1"/>
+          </a:effectRef>
+          <a:fontRef idx="minor">
+            <a:schemeClr val="tx1"/>
+          </a:fontRef>
+        </p:style>
+      </p:cxnSp>
+      <p:sp>
+        <p:nvSpPr>
+          <p:cNvPr id="22" name="Rounded Rectangle 21"/>
+          <p:cNvSpPr/>
+          <p:nvPr/>
+        </p:nvSpPr>
+        <p:spPr>
+          <a:xfrm>
+            <a:off x="8220455" y="3941064"/>
+            <a:ext cx="1883664" cy="274320"/>
+          </a:xfrm>
+          <a:prstGeom prst="roundRect">
+            <a:avLst/>
+          </a:prstGeom>
+          <a:solidFill>
+            <a:srgbClr val="0C1E38"/>
+          </a:solidFill>
+          <a:ln>
+            <a:solidFill>
+              <a:srgbClr val="22D3EE"/>
+            </a:solidFill>
+          </a:ln>
+        </p:spPr>
+        <p:style>
+          <a:lnRef idx="1">
+            <a:schemeClr val="accent1"/>
+          </a:lnRef>
+          <a:fillRef idx="3">
+            <a:schemeClr val="accent1"/>
+          </a:fillRef>
+          <a:effectRef idx="2">
+            <a:schemeClr val="accent1"/>
+          </a:effectRef>
+          <a:fontRef idx="minor">
+            <a:schemeClr val="lt1"/>
+          </a:fontRef>
+        </p:style>
+        <p:txBody>
+          <a:bodyPr rtlCol="0" anchor="t" wrap="square" tIns="50800" bIns="50800" lIns="101600" rIns="101600"/>
+          <a:lstStyle/>
+          <a:p>
+            <a:pPr algn="ctr">
+              <a:spcAft>
+                <a:spcPts val="600"/>
+              </a:spcAft>
+            </a:pPr>
+            <a:r>
+              <a:rPr sz="1150" b="0">
+                <a:solidFill>
+                  <a:srgbClr val="E2E8F0"/>
+                </a:solidFill>
+                <a:latin typeface="Arial"/>
+              </a:rPr>
+              <a:t>决定是否调用工具</a:t>
+            </a:r>
+          </a:p>
+        </p:txBody>
+      </p:sp>
+      <p:cxnSp>
+        <p:nvCxnSpPr>
+          <p:cNvPr id="23" name="Connector 22"/>
+          <p:cNvCxnSpPr/>
+          <p:nvPr/>
+        </p:nvCxnSpPr>
+        <p:spPr>
+          <a:xfrm flipH="1">
+            <a:off x="8110727" y="4526280"/>
+            <a:ext cx="2103121" cy="0"/>
+          </a:xfrm>
+          <a:prstGeom prst="line">
+            <a:avLst/>
+          </a:prstGeom>
+          <a:ln w="15875">
+            <a:solidFill>
+              <a:srgbClr val="22D3EE"/>
+            </a:solidFill>
+          </a:ln>
+        </p:spPr>
+        <p:style>
+          <a:lnRef idx="2">
+            <a:schemeClr val="accent1"/>
+          </a:lnRef>
+          <a:fillRef idx="0">
+            <a:schemeClr val="accent1"/>
+          </a:fillRef>
+          <a:effectRef idx="1">
+            <a:schemeClr val="accent1"/>
+          </a:effectRef>
+          <a:fontRef idx="minor">
+            <a:schemeClr val="tx1"/>
+          </a:fontRef>
+        </p:style>
+      </p:cxnSp>
+      <p:sp>
+        <p:nvSpPr>
+          <p:cNvPr id="24" name="Rounded Rectangle 23"/>
+          <p:cNvSpPr/>
+          <p:nvPr/>
+        </p:nvSpPr>
+        <p:spPr>
+          <a:xfrm>
+            <a:off x="8220455" y="4398264"/>
+            <a:ext cx="1883664" cy="274320"/>
+          </a:xfrm>
+          <a:prstGeom prst="roundRect">
+            <a:avLst/>
+          </a:prstGeom>
+          <a:solidFill>
+            <a:srgbClr val="0C1E38"/>
+          </a:solidFill>
+          <a:ln>
+            <a:solidFill>
+              <a:srgbClr val="22D3EE"/>
+            </a:solidFill>
+          </a:ln>
+        </p:spPr>
+        <p:style>
+          <a:lnRef idx="1">
+            <a:schemeClr val="accent1"/>
+          </a:lnRef>
+          <a:fillRef idx="3">
+            <a:schemeClr val="accent1"/>
+          </a:fillRef>
+          <a:effectRef idx="2">
+            <a:schemeClr val="accent1"/>
+          </a:effectRef>
+          <a:fontRef idx="minor">
+            <a:schemeClr val="lt1"/>
+          </a:fontRef>
+        </p:style>
+        <p:txBody>
+          <a:bodyPr rtlCol="0" anchor="t" wrap="square" tIns="50800" bIns="50800" lIns="101600" rIns="101600"/>
+          <a:lstStyle/>
+          <a:p>
+            <a:pPr algn="ctr">
+              <a:spcAft>
+                <a:spcPts val="600"/>
+              </a:spcAft>
+            </a:pPr>
+            <a:r>
+              <a:rPr sz="1150" b="0">
+                <a:solidFill>
+                  <a:srgbClr val="E2E8F0"/>
+                </a:solidFill>
+                <a:latin typeface="Arial"/>
+              </a:rPr>
+              <a:t>tool result 回灌</a:t>
+            </a:r>
+          </a:p>
+        </p:txBody>
+      </p:sp>
+      <p:cxnSp>
+        <p:nvCxnSpPr>
+          <p:cNvPr id="25" name="Connector 24"/>
+          <p:cNvCxnSpPr/>
+          <p:nvPr/>
+        </p:nvCxnSpPr>
+        <p:spPr>
+          <a:xfrm flipH="1">
+            <a:off x="5961888" y="4983480"/>
+            <a:ext cx="2148839" cy="0"/>
+          </a:xfrm>
+          <a:prstGeom prst="line">
+            <a:avLst/>
+          </a:prstGeom>
+          <a:ln w="15875">
+            <a:solidFill>
+              <a:srgbClr val="22D3EE"/>
+            </a:solidFill>
+          </a:ln>
+        </p:spPr>
+        <p:style>
+          <a:lnRef idx="2">
+            <a:schemeClr val="accent1"/>
+          </a:lnRef>
+          <a:fillRef idx="0">
+            <a:schemeClr val="accent1"/>
+          </a:fillRef>
+          <a:effectRef idx="1">
+            <a:schemeClr val="accent1"/>
+          </a:effectRef>
+          <a:fontRef idx="minor">
+            <a:schemeClr val="tx1"/>
+          </a:fontRef>
+        </p:style>
+      </p:cxnSp>
+      <p:sp>
+        <p:nvSpPr>
+          <p:cNvPr id="26" name="Rounded Rectangle 25"/>
+          <p:cNvSpPr/>
+          <p:nvPr/>
+        </p:nvSpPr>
+        <p:spPr>
+          <a:xfrm>
+            <a:off x="6071616" y="4855464"/>
+            <a:ext cx="1929383" cy="274320"/>
+          </a:xfrm>
+          <a:prstGeom prst="roundRect">
+            <a:avLst/>
+          </a:prstGeom>
+          <a:solidFill>
+            <a:srgbClr val="0C1E38"/>
+          </a:solidFill>
+          <a:ln>
+            <a:solidFill>
+              <a:srgbClr val="22D3EE"/>
+            </a:solidFill>
+          </a:ln>
+        </p:spPr>
+        <p:style>
+          <a:lnRef idx="1">
+            <a:schemeClr val="accent1"/>
+          </a:lnRef>
+          <a:fillRef idx="3">
+            <a:schemeClr val="accent1"/>
+          </a:fillRef>
+          <a:effectRef idx="2">
+            <a:schemeClr val="accent1"/>
+          </a:effectRef>
+          <a:fontRef idx="minor">
+            <a:schemeClr val="lt1"/>
+          </a:fontRef>
+        </p:style>
+        <p:txBody>
+          <a:bodyPr rtlCol="0" anchor="t" wrap="square" tIns="50800" bIns="50800" lIns="101600" rIns="101600"/>
+          <a:lstStyle/>
+          <a:p>
+            <a:pPr algn="ctr">
+              <a:spcAft>
+                <a:spcPts val="600"/>
+              </a:spcAft>
+            </a:pPr>
+            <a:r>
+              <a:rPr sz="1150" b="0">
+                <a:solidFill>
+                  <a:srgbClr val="E2E8F0"/>
+                </a:solidFill>
+                <a:latin typeface="Arial"/>
+              </a:rPr>
+              <a:t>继续 / 收敛</a:t>
+            </a:r>
+          </a:p>
+        </p:txBody>
+      </p:sp>
+      <p:sp>
+        <p:nvSpPr>
+          <p:cNvPr id="27" name="Rounded Rectangle 26"/>
+          <p:cNvSpPr/>
+          <p:nvPr/>
+        </p:nvSpPr>
+        <p:spPr>
+          <a:xfrm>
+            <a:off x="685800" y="5806440"/>
+            <a:ext cx="10972800" cy="384048"/>
+          </a:xfrm>
+          <a:prstGeom prst="roundRect">
+            <a:avLst/>
+          </a:prstGeom>
+          <a:solidFill>
+            <a:srgbClr val="0F172A"/>
+          </a:solidFill>
+          <a:ln>
+            <a:solidFill>
+              <a:srgbClr val="22D3EE"/>
+            </a:solidFill>
+          </a:ln>
+        </p:spPr>
+        <p:style>
+          <a:lnRef idx="1">
+            <a:schemeClr val="accent1"/>
+          </a:lnRef>
+          <a:fillRef idx="3">
+            <a:schemeClr val="accent1"/>
+          </a:fillRef>
+          <a:effectRef idx="2">
+            <a:schemeClr val="accent1"/>
+          </a:effectRef>
+          <a:fontRef idx="minor">
+            <a:schemeClr val="lt1"/>
+          </a:fontRef>
+        </p:style>
+        <p:txBody>
+          <a:bodyPr rtlCol="0" anchor="t" wrap="square" tIns="50800" bIns="50800" lIns="101600" rIns="101600"/>
+          <a:lstStyle/>
+          <a:p>
+            <a:pPr algn="ctr">
+              <a:spcAft>
+                <a:spcPts val="600"/>
+              </a:spcAft>
+            </a:pPr>
+            <a:r>
+              <a:rPr sz="1300" b="0">
                 <a:solidFill>
                   <a:srgbClr val="E2E8F0"/>
                 </a:solidFill>

</xml_diff>

<commit_message>
Enrich presentation cover slide
</commit_message>
<xml_diff>
--- a/docs/zh/09-Claude Code 使用技巧与注意事项.pptx
+++ b/docs/zh/09-Claude Code 使用技巧与注意事项.pptx
@@ -3173,82 +3173,27 @@
                 </a:solidFill>
                 <a:latin typeface="Arial"/>
               </a:rPr>
-              <a:t>使用建议与源码依据</a:t>
-            </a:r>
-          </a:p>
-        </p:txBody>
-      </p:sp>
-      <p:sp>
-        <p:nvSpPr>
-          <p:cNvPr id="4" name="TextBox 3"/>
-          <p:cNvSpPr txBox="1"/>
-          <p:nvPr/>
-        </p:nvSpPr>
-        <p:spPr>
-          <a:xfrm>
-            <a:off x="822960" y="1874519"/>
-            <a:ext cx="10424160" cy="1645920"/>
-          </a:xfrm>
-          <a:prstGeom prst="rect">
-            <a:avLst/>
-          </a:prstGeom>
-          <a:noFill/>
-        </p:spPr>
-        <p:txBody>
-          <a:bodyPr wrap="square" tIns="50800" bIns="50800" lIns="101600" rIns="101600" anchor="t">
-            <a:spAutoFit/>
-          </a:bodyPr>
-          <a:lstStyle/>
-          <a:p>
-            <a:pPr>
-              <a:spcAft>
-                <a:spcPts val="800"/>
-              </a:spcAft>
-            </a:pPr>
-            <a:r>
-              <a:rPr sz="1800" b="0">
-                <a:solidFill>
-                  <a:srgbClr val="FFFFFF"/>
-                </a:solidFill>
-                <a:latin typeface="Arial"/>
-              </a:rPr>
-              <a:t>先说明 Claude Code 从工程上是什么，再解释怎样用会更稳</a:t>
-            </a:r>
-          </a:p>
-          <a:p>
-            <a:pPr>
-              <a:spcAft>
-                <a:spcPts val="800"/>
-              </a:spcAft>
-            </a:pPr>
-            <a:r>
-              <a:rPr sz="1800" b="0">
-                <a:solidFill>
-                  <a:srgbClr val="FFFFFF"/>
-                </a:solidFill>
-                <a:latin typeface="Arial"/>
-              </a:rPr>
-              <a:t>每条技巧都附架构支撑、源码依据和关键代码片段</a:t>
-            </a:r>
-          </a:p>
-        </p:txBody>
-      </p:sp>
-      <p:sp>
-        <p:nvSpPr>
-          <p:cNvPr id="5" name="Rounded Rectangle 4"/>
+              <a:t>从源码反推：怎样用得更稳、更准、更像专业工程协作</a:t>
+            </a:r>
+          </a:p>
+        </p:txBody>
+      </p:sp>
+      <p:sp>
+        <p:nvSpPr>
+          <p:cNvPr id="4" name="Rounded Rectangle 3"/>
           <p:cNvSpPr/>
           <p:nvPr/>
         </p:nvSpPr>
         <p:spPr>
           <a:xfrm>
-            <a:off x="868680" y="3840480"/>
-            <a:ext cx="1417320" cy="347472"/>
+            <a:off x="822960" y="1828800"/>
+            <a:ext cx="4983480" cy="2057400"/>
           </a:xfrm>
           <a:prstGeom prst="roundRect">
             <a:avLst/>
           </a:prstGeom>
           <a:solidFill>
-            <a:srgbClr val="0F172A"/>
+            <a:srgbClr val="0C1426"/>
           </a:solidFill>
           <a:ln>
             <a:solidFill>
@@ -3271,38 +3216,90 @@
           </a:fontRef>
         </p:style>
         <p:txBody>
-          <a:bodyPr rtlCol="0" anchor="t" wrap="square" tIns="12700" bIns="12700" lIns="50800" rIns="50800"/>
-          <a:lstStyle/>
-          <a:p>
-            <a:pPr algn="ctr"/>
-            <a:r>
-              <a:rPr sz="1100" b="1">
-                <a:solidFill>
-                  <a:srgbClr val="22D3EE"/>
-                </a:solidFill>
-                <a:latin typeface="Arial"/>
-              </a:rPr>
-              <a:t>源码依据</a:t>
-            </a:r>
-          </a:p>
-        </p:txBody>
-      </p:sp>
-      <p:sp>
-        <p:nvSpPr>
-          <p:cNvPr id="6" name="Rounded Rectangle 5"/>
+          <a:bodyPr rtlCol="0" anchor="t" wrap="square" tIns="50800" bIns="50800" lIns="101600" rIns="101600"/>
+          <a:lstStyle/>
+          <a:p>
+            <a:pPr algn="ctr">
+              <a:spcAft>
+                <a:spcPts val="600"/>
+              </a:spcAft>
+            </a:pPr>
+            <a:r>
+              <a:rPr sz="1700" b="0">
+                <a:solidFill>
+                  <a:srgbClr val="E2E8F0"/>
+                </a:solidFill>
+                <a:latin typeface="Arial"/>
+              </a:rPr>
+              <a:t>这份分享回答三个问题：</a:t>
+            </a:r>
+          </a:p>
+          <a:p>
+            <a:pPr>
+              <a:spcAft>
+                <a:spcPts val="600"/>
+              </a:spcAft>
+            </a:pPr>
+            <a:r>
+              <a:rPr sz="1700" b="0">
+                <a:solidFill>
+                  <a:srgbClr val="E2E8F0"/>
+                </a:solidFill>
+                <a:latin typeface="Arial"/>
+              </a:rPr>
+              <a:t>1. Claude Code 从工程上到底是什么</a:t>
+            </a:r>
+          </a:p>
+          <a:p>
+            <a:pPr>
+              <a:spcAft>
+                <a:spcPts val="600"/>
+              </a:spcAft>
+            </a:pPr>
+            <a:r>
+              <a:rPr sz="1700" b="0">
+                <a:solidFill>
+                  <a:srgbClr val="E2E8F0"/>
+                </a:solidFill>
+                <a:latin typeface="Arial"/>
+              </a:rPr>
+              <a:t>2. 为什么有些提示方式更稳定</a:t>
+            </a:r>
+          </a:p>
+          <a:p>
+            <a:pPr>
+              <a:spcAft>
+                <a:spcPts val="600"/>
+              </a:spcAft>
+            </a:pPr>
+            <a:r>
+              <a:rPr sz="1700" b="0">
+                <a:solidFill>
+                  <a:srgbClr val="E2E8F0"/>
+                </a:solidFill>
+                <a:latin typeface="Arial"/>
+              </a:rPr>
+              <a:t>3. 用户应该怎样提需求、控边界、做验证</a:t>
+            </a:r>
+          </a:p>
+        </p:txBody>
+      </p:sp>
+      <p:sp>
+        <p:nvSpPr>
+          <p:cNvPr id="5" name="Rounded Rectangle 4"/>
           <p:cNvSpPr/>
           <p:nvPr/>
         </p:nvSpPr>
         <p:spPr>
           <a:xfrm>
-            <a:off x="2423160" y="3840480"/>
-            <a:ext cx="1645920" cy="347472"/>
+            <a:off x="6172200" y="1828800"/>
+            <a:ext cx="5074920" cy="2057400"/>
           </a:xfrm>
           <a:prstGeom prst="roundRect">
             <a:avLst/>
           </a:prstGeom>
           <a:solidFill>
-            <a:srgbClr val="0F172A"/>
+            <a:srgbClr val="0C1426"/>
           </a:solidFill>
           <a:ln>
             <a:solidFill>
@@ -3325,32 +3322,84 @@
           </a:fontRef>
         </p:style>
         <p:txBody>
-          <a:bodyPr rtlCol="0" anchor="t" wrap="square" tIns="12700" bIns="12700" lIns="50800" rIns="50800"/>
-          <a:lstStyle/>
-          <a:p>
-            <a:pPr algn="ctr"/>
-            <a:r>
-              <a:rPr sz="1100" b="1">
-                <a:solidFill>
-                  <a:srgbClr val="22D3EE"/>
-                </a:solidFill>
-                <a:latin typeface="Arial"/>
-              </a:rPr>
-              <a:t>架构视角</a:t>
-            </a:r>
-          </a:p>
-        </p:txBody>
-      </p:sp>
-      <p:sp>
-        <p:nvSpPr>
-          <p:cNvPr id="7" name="Rounded Rectangle 6"/>
+          <a:bodyPr rtlCol="0" anchor="t" wrap="square" tIns="50800" bIns="50800" lIns="101600" rIns="101600"/>
+          <a:lstStyle/>
+          <a:p>
+            <a:pPr algn="ctr">
+              <a:spcAft>
+                <a:spcPts val="600"/>
+              </a:spcAft>
+            </a:pPr>
+            <a:r>
+              <a:rPr sz="1700" b="0">
+                <a:solidFill>
+                  <a:srgbClr val="E2E8F0"/>
+                </a:solidFill>
+                <a:latin typeface="Arial"/>
+              </a:rPr>
+              <a:t>最终目标不是讲功能，而是形成一套可复用的使用方法：</a:t>
+            </a:r>
+          </a:p>
+          <a:p>
+            <a:pPr>
+              <a:spcAft>
+                <a:spcPts val="600"/>
+              </a:spcAft>
+            </a:pPr>
+            <a:r>
+              <a:rPr sz="1700" b="0">
+                <a:solidFill>
+                  <a:srgbClr val="E2E8F0"/>
+                </a:solidFill>
+                <a:latin typeface="Arial"/>
+              </a:rPr>
+              <a:t>目标 + 范围 + 约束 + 验证</a:t>
+            </a:r>
+          </a:p>
+          <a:p>
+            <a:pPr>
+              <a:spcAft>
+                <a:spcPts val="600"/>
+              </a:spcAft>
+            </a:pPr>
+            <a:r>
+              <a:rPr sz="1700" b="0">
+                <a:solidFill>
+                  <a:srgbClr val="E2E8F0"/>
+                </a:solidFill>
+                <a:latin typeface="Arial"/>
+              </a:rPr>
+              <a:t>先读代码，再做最小改动</a:t>
+            </a:r>
+          </a:p>
+          <a:p>
+            <a:pPr>
+              <a:spcAft>
+                <a:spcPts val="600"/>
+              </a:spcAft>
+            </a:pPr>
+            <a:r>
+              <a:rPr sz="1700" b="0">
+                <a:solidFill>
+                  <a:srgbClr val="E2E8F0"/>
+                </a:solidFill>
+                <a:latin typeface="Arial"/>
+              </a:rPr>
+              <a:t>把源码里的默认工作方式转成用户提示词</a:t>
+            </a:r>
+          </a:p>
+        </p:txBody>
+      </p:sp>
+      <p:sp>
+        <p:nvSpPr>
+          <p:cNvPr id="6" name="Rounded Rectangle 5"/>
           <p:cNvSpPr/>
           <p:nvPr/>
         </p:nvSpPr>
         <p:spPr>
           <a:xfrm>
-            <a:off x="4206240" y="3840480"/>
-            <a:ext cx="1600200" cy="347472"/>
+            <a:off x="868680" y="4251960"/>
+            <a:ext cx="1417320" cy="347472"/>
           </a:xfrm>
           <a:prstGeom prst="roundRect">
             <a:avLst/>
@@ -3390,7 +3439,281 @@
                 </a:solidFill>
                 <a:latin typeface="Arial"/>
               </a:rPr>
+              <a:t>源码依据</a:t>
+            </a:r>
+          </a:p>
+        </p:txBody>
+      </p:sp>
+      <p:sp>
+        <p:nvSpPr>
+          <p:cNvPr id="7" name="Rounded Rectangle 6"/>
+          <p:cNvSpPr/>
+          <p:nvPr/>
+        </p:nvSpPr>
+        <p:spPr>
+          <a:xfrm>
+            <a:off x="2423160" y="4251960"/>
+            <a:ext cx="1645920" cy="347472"/>
+          </a:xfrm>
+          <a:prstGeom prst="roundRect">
+            <a:avLst/>
+          </a:prstGeom>
+          <a:solidFill>
+            <a:srgbClr val="0F172A"/>
+          </a:solidFill>
+          <a:ln>
+            <a:solidFill>
+              <a:srgbClr val="22D3EE"/>
+            </a:solidFill>
+          </a:ln>
+        </p:spPr>
+        <p:style>
+          <a:lnRef idx="1">
+            <a:schemeClr val="accent1"/>
+          </a:lnRef>
+          <a:fillRef idx="3">
+            <a:schemeClr val="accent1"/>
+          </a:fillRef>
+          <a:effectRef idx="2">
+            <a:schemeClr val="accent1"/>
+          </a:effectRef>
+          <a:fontRef idx="minor">
+            <a:schemeClr val="lt1"/>
+          </a:fontRef>
+        </p:style>
+        <p:txBody>
+          <a:bodyPr rtlCol="0" anchor="t" wrap="square" tIns="12700" bIns="12700" lIns="50800" rIns="50800"/>
+          <a:lstStyle/>
+          <a:p>
+            <a:pPr algn="ctr"/>
+            <a:r>
+              <a:rPr sz="1100" b="1">
+                <a:solidFill>
+                  <a:srgbClr val="22D3EE"/>
+                </a:solidFill>
+                <a:latin typeface="Arial"/>
+              </a:rPr>
+              <a:t>架构视角</a:t>
+            </a:r>
+          </a:p>
+        </p:txBody>
+      </p:sp>
+      <p:sp>
+        <p:nvSpPr>
+          <p:cNvPr id="8" name="Rounded Rectangle 7"/>
+          <p:cNvSpPr/>
+          <p:nvPr/>
+        </p:nvSpPr>
+        <p:spPr>
+          <a:xfrm>
+            <a:off x="4206240" y="4251960"/>
+            <a:ext cx="1600200" cy="347472"/>
+          </a:xfrm>
+          <a:prstGeom prst="roundRect">
+            <a:avLst/>
+          </a:prstGeom>
+          <a:solidFill>
+            <a:srgbClr val="0F172A"/>
+          </a:solidFill>
+          <a:ln>
+            <a:solidFill>
+              <a:srgbClr val="22D3EE"/>
+            </a:solidFill>
+          </a:ln>
+        </p:spPr>
+        <p:style>
+          <a:lnRef idx="1">
+            <a:schemeClr val="accent1"/>
+          </a:lnRef>
+          <a:fillRef idx="3">
+            <a:schemeClr val="accent1"/>
+          </a:fillRef>
+          <a:effectRef idx="2">
+            <a:schemeClr val="accent1"/>
+          </a:effectRef>
+          <a:fontRef idx="minor">
+            <a:schemeClr val="lt1"/>
+          </a:fontRef>
+        </p:style>
+        <p:txBody>
+          <a:bodyPr rtlCol="0" anchor="t" wrap="square" tIns="12700" bIns="12700" lIns="50800" rIns="50800"/>
+          <a:lstStyle/>
+          <a:p>
+            <a:pPr algn="ctr"/>
+            <a:r>
+              <a:rPr sz="1100" b="1">
+                <a:solidFill>
+                  <a:srgbClr val="22D3EE"/>
+                </a:solidFill>
+                <a:latin typeface="Arial"/>
+              </a:rPr>
               <a:t>使用方法</a:t>
+            </a:r>
+          </a:p>
+        </p:txBody>
+      </p:sp>
+      <p:sp>
+        <p:nvSpPr>
+          <p:cNvPr id="9" name="Rounded Rectangle 8"/>
+          <p:cNvSpPr/>
+          <p:nvPr/>
+        </p:nvSpPr>
+        <p:spPr>
+          <a:xfrm>
+            <a:off x="5989320" y="4251960"/>
+            <a:ext cx="1783080" cy="347472"/>
+          </a:xfrm>
+          <a:prstGeom prst="roundRect">
+            <a:avLst/>
+          </a:prstGeom>
+          <a:solidFill>
+            <a:srgbClr val="0F172A"/>
+          </a:solidFill>
+          <a:ln>
+            <a:solidFill>
+              <a:srgbClr val="22D3EE"/>
+            </a:solidFill>
+          </a:ln>
+        </p:spPr>
+        <p:style>
+          <a:lnRef idx="1">
+            <a:schemeClr val="accent1"/>
+          </a:lnRef>
+          <a:fillRef idx="3">
+            <a:schemeClr val="accent1"/>
+          </a:fillRef>
+          <a:effectRef idx="2">
+            <a:schemeClr val="accent1"/>
+          </a:effectRef>
+          <a:fontRef idx="minor">
+            <a:schemeClr val="lt1"/>
+          </a:fontRef>
+        </p:style>
+        <p:txBody>
+          <a:bodyPr rtlCol="0" anchor="t" wrap="square" tIns="12700" bIns="12700" lIns="50800" rIns="50800"/>
+          <a:lstStyle/>
+          <a:p>
+            <a:pPr algn="ctr"/>
+            <a:r>
+              <a:rPr sz="1100" b="1">
+                <a:solidFill>
+                  <a:srgbClr val="22D3EE"/>
+                </a:solidFill>
+                <a:latin typeface="Arial"/>
+              </a:rPr>
+              <a:t>提示词技巧</a:t>
+            </a:r>
+          </a:p>
+        </p:txBody>
+      </p:sp>
+      <p:sp>
+        <p:nvSpPr>
+          <p:cNvPr id="10" name="Rounded Rectangle 9"/>
+          <p:cNvSpPr/>
+          <p:nvPr/>
+        </p:nvSpPr>
+        <p:spPr>
+          <a:xfrm>
+            <a:off x="7955279" y="4251960"/>
+            <a:ext cx="1645920" cy="347472"/>
+          </a:xfrm>
+          <a:prstGeom prst="roundRect">
+            <a:avLst/>
+          </a:prstGeom>
+          <a:solidFill>
+            <a:srgbClr val="0F172A"/>
+          </a:solidFill>
+          <a:ln>
+            <a:solidFill>
+              <a:srgbClr val="22D3EE"/>
+            </a:solidFill>
+          </a:ln>
+        </p:spPr>
+        <p:style>
+          <a:lnRef idx="1">
+            <a:schemeClr val="accent1"/>
+          </a:lnRef>
+          <a:fillRef idx="3">
+            <a:schemeClr val="accent1"/>
+          </a:fillRef>
+          <a:effectRef idx="2">
+            <a:schemeClr val="accent1"/>
+          </a:effectRef>
+          <a:fontRef idx="minor">
+            <a:schemeClr val="lt1"/>
+          </a:fontRef>
+        </p:style>
+        <p:txBody>
+          <a:bodyPr rtlCol="0" anchor="t" wrap="square" tIns="12700" bIns="12700" lIns="50800" rIns="50800"/>
+          <a:lstStyle/>
+          <a:p>
+            <a:pPr algn="ctr"/>
+            <a:r>
+              <a:rPr sz="1100" b="1">
+                <a:solidFill>
+                  <a:srgbClr val="22D3EE"/>
+                </a:solidFill>
+                <a:latin typeface="Arial"/>
+              </a:rPr>
+              <a:t>风险边界</a:t>
+            </a:r>
+          </a:p>
+        </p:txBody>
+      </p:sp>
+      <p:sp>
+        <p:nvSpPr>
+          <p:cNvPr id="11" name="Rounded Rectangle 10"/>
+          <p:cNvSpPr/>
+          <p:nvPr/>
+        </p:nvSpPr>
+        <p:spPr>
+          <a:xfrm>
+            <a:off x="868680" y="4892040"/>
+            <a:ext cx="10378440" cy="713232"/>
+          </a:xfrm>
+          <a:prstGeom prst="roundRect">
+            <a:avLst/>
+          </a:prstGeom>
+          <a:solidFill>
+            <a:srgbClr val="090F1E"/>
+          </a:solidFill>
+          <a:ln>
+            <a:solidFill>
+              <a:srgbClr val="22D3EE"/>
+            </a:solidFill>
+          </a:ln>
+        </p:spPr>
+        <p:style>
+          <a:lnRef idx="1">
+            <a:schemeClr val="accent1"/>
+          </a:lnRef>
+          <a:fillRef idx="3">
+            <a:schemeClr val="accent1"/>
+          </a:fillRef>
+          <a:effectRef idx="2">
+            <a:schemeClr val="accent1"/>
+          </a:effectRef>
+          <a:fontRef idx="minor">
+            <a:schemeClr val="lt1"/>
+          </a:fontRef>
+        </p:style>
+        <p:txBody>
+          <a:bodyPr rtlCol="0" anchor="t" wrap="square" tIns="50800" bIns="50800" lIns="101600" rIns="101600"/>
+          <a:lstStyle/>
+          <a:p>
+            <a:pPr algn="ctr">
+              <a:spcAft>
+                <a:spcPts val="600"/>
+              </a:spcAft>
+            </a:pPr>
+            <a:r>
+              <a:rPr sz="1500" b="0">
+                <a:solidFill>
+                  <a:srgbClr val="E2E8F0"/>
+                </a:solidFill>
+                <a:latin typeface="Arial"/>
+              </a:rPr>
+              <a:t>核心判断：Claude Code 不是自由聊天助手，而是一个围绕 Prompt Stack、Turn Loop 和 Tool Pipeline 运行的 terminal agent runtime。</a:t>
             </a:r>
           </a:p>
         </p:txBody>

</xml_diff>

<commit_message>
Refine presentation color theme
</commit_message>
<xml_diff>
--- a/docs/zh/09-Claude Code 使用技巧与注意事项.pptx
+++ b/docs/zh/09-Claude Code 使用技巧与注意事项.pptx
@@ -3098,7 +3098,7 @@
     <p:bg>
       <p:bgPr>
         <a:solidFill>
-          <a:srgbClr val="101828"/>
+          <a:srgbClr val="070C1C"/>
         </a:solidFill>
         <a:effectLst/>
       </p:bgPr>
@@ -3112,7 +3112,93 @@
       <p:grpSpPr/>
       <p:sp>
         <p:nvSpPr>
-          <p:cNvPr id="2" name="TextBox 1"/>
+          <p:cNvPr id="2" name="Rectangle 1"/>
+          <p:cNvSpPr/>
+          <p:nvPr/>
+        </p:nvSpPr>
+        <p:spPr>
+          <a:xfrm>
+            <a:off x="0" y="0"/>
+            <a:ext cx="12191695" cy="54864"/>
+          </a:xfrm>
+          <a:prstGeom prst="rect">
+            <a:avLst/>
+          </a:prstGeom>
+          <a:solidFill>
+            <a:srgbClr val="38BDF8"/>
+          </a:solidFill>
+          <a:ln>
+            <a:noFill/>
+          </a:ln>
+        </p:spPr>
+        <p:style>
+          <a:lnRef idx="1">
+            <a:schemeClr val="accent1"/>
+          </a:lnRef>
+          <a:fillRef idx="3">
+            <a:schemeClr val="accent1"/>
+          </a:fillRef>
+          <a:effectRef idx="2">
+            <a:schemeClr val="accent1"/>
+          </a:effectRef>
+          <a:fontRef idx="minor">
+            <a:schemeClr val="lt1"/>
+          </a:fontRef>
+        </p:style>
+        <p:txBody>
+          <a:bodyPr rtlCol="0" anchor="ctr"/>
+          <a:lstStyle/>
+          <a:p>
+            <a:pPr algn="ctr"/>
+          </a:p>
+        </p:txBody>
+      </p:sp>
+      <p:sp>
+        <p:nvSpPr>
+          <p:cNvPr id="3" name="Rectangle 2"/>
+          <p:cNvSpPr/>
+          <p:nvPr/>
+        </p:nvSpPr>
+        <p:spPr>
+          <a:xfrm>
+            <a:off x="0" y="6803136"/>
+            <a:ext cx="12191695" cy="54864"/>
+          </a:xfrm>
+          <a:prstGeom prst="rect">
+            <a:avLst/>
+          </a:prstGeom>
+          <a:solidFill>
+            <a:srgbClr val="A78BFA"/>
+          </a:solidFill>
+          <a:ln>
+            <a:noFill/>
+          </a:ln>
+        </p:spPr>
+        <p:style>
+          <a:lnRef idx="1">
+            <a:schemeClr val="accent1"/>
+          </a:lnRef>
+          <a:fillRef idx="3">
+            <a:schemeClr val="accent1"/>
+          </a:fillRef>
+          <a:effectRef idx="2">
+            <a:schemeClr val="accent1"/>
+          </a:effectRef>
+          <a:fontRef idx="minor">
+            <a:schemeClr val="lt1"/>
+          </a:fontRef>
+        </p:style>
+        <p:txBody>
+          <a:bodyPr rtlCol="0" anchor="ctr"/>
+          <a:lstStyle/>
+          <a:p>
+            <a:pPr algn="ctr"/>
+          </a:p>
+        </p:txBody>
+      </p:sp>
+      <p:sp>
+        <p:nvSpPr>
+          <p:cNvPr id="4" name="TextBox 3"/>
           <p:cNvSpPr txBox="1"/>
           <p:nvPr/>
         </p:nvSpPr>
@@ -3146,7 +3232,7 @@
       </p:sp>
       <p:sp>
         <p:nvSpPr>
-          <p:cNvPr id="3" name="TextBox 2"/>
+          <p:cNvPr id="5" name="TextBox 4"/>
           <p:cNvSpPr txBox="1"/>
           <p:nvPr/>
         </p:nvSpPr>
@@ -3180,7 +3266,7 @@
       </p:sp>
       <p:sp>
         <p:nvSpPr>
-          <p:cNvPr id="4" name="Rounded Rectangle 3"/>
+          <p:cNvPr id="6" name="Rounded Rectangle 5"/>
           <p:cNvSpPr/>
           <p:nvPr/>
         </p:nvSpPr>
@@ -3193,11 +3279,11 @@
             <a:avLst/>
           </a:prstGeom>
           <a:solidFill>
-            <a:srgbClr val="0C1426"/>
+            <a:srgbClr val="0A1224"/>
           </a:solidFill>
           <a:ln>
             <a:solidFill>
-              <a:srgbClr val="22D3EE"/>
+              <a:srgbClr val="38BDF8"/>
             </a:solidFill>
           </a:ln>
         </p:spPr>
@@ -3227,7 +3313,7 @@
             <a:r>
               <a:rPr sz="1700" b="0">
                 <a:solidFill>
-                  <a:srgbClr val="E2E8F0"/>
+                  <a:srgbClr val="DDE6F4"/>
                 </a:solidFill>
                 <a:latin typeface="Arial"/>
               </a:rPr>
@@ -3243,7 +3329,7 @@
             <a:r>
               <a:rPr sz="1700" b="0">
                 <a:solidFill>
-                  <a:srgbClr val="E2E8F0"/>
+                  <a:srgbClr val="DDE6F4"/>
                 </a:solidFill>
                 <a:latin typeface="Arial"/>
               </a:rPr>
@@ -3259,7 +3345,7 @@
             <a:r>
               <a:rPr sz="1700" b="0">
                 <a:solidFill>
-                  <a:srgbClr val="E2E8F0"/>
+                  <a:srgbClr val="DDE6F4"/>
                 </a:solidFill>
                 <a:latin typeface="Arial"/>
               </a:rPr>
@@ -3275,7 +3361,7 @@
             <a:r>
               <a:rPr sz="1700" b="0">
                 <a:solidFill>
-                  <a:srgbClr val="E2E8F0"/>
+                  <a:srgbClr val="DDE6F4"/>
                 </a:solidFill>
                 <a:latin typeface="Arial"/>
               </a:rPr>
@@ -3286,7 +3372,7 @@
       </p:sp>
       <p:sp>
         <p:nvSpPr>
-          <p:cNvPr id="5" name="Rounded Rectangle 4"/>
+          <p:cNvPr id="7" name="Rounded Rectangle 6"/>
           <p:cNvSpPr/>
           <p:nvPr/>
         </p:nvSpPr>
@@ -3299,11 +3385,11 @@
             <a:avLst/>
           </a:prstGeom>
           <a:solidFill>
-            <a:srgbClr val="0C1426"/>
+            <a:srgbClr val="0A1224"/>
           </a:solidFill>
           <a:ln>
             <a:solidFill>
-              <a:srgbClr val="22D3EE"/>
+              <a:srgbClr val="A78BFA"/>
             </a:solidFill>
           </a:ln>
         </p:spPr>
@@ -3333,7 +3419,7 @@
             <a:r>
               <a:rPr sz="1700" b="0">
                 <a:solidFill>
-                  <a:srgbClr val="E2E8F0"/>
+                  <a:srgbClr val="DDE6F4"/>
                 </a:solidFill>
                 <a:latin typeface="Arial"/>
               </a:rPr>
@@ -3349,7 +3435,7 @@
             <a:r>
               <a:rPr sz="1700" b="0">
                 <a:solidFill>
-                  <a:srgbClr val="E2E8F0"/>
+                  <a:srgbClr val="DDE6F4"/>
                 </a:solidFill>
                 <a:latin typeface="Arial"/>
               </a:rPr>
@@ -3365,7 +3451,7 @@
             <a:r>
               <a:rPr sz="1700" b="0">
                 <a:solidFill>
-                  <a:srgbClr val="E2E8F0"/>
+                  <a:srgbClr val="DDE6F4"/>
                 </a:solidFill>
                 <a:latin typeface="Arial"/>
               </a:rPr>
@@ -3381,7 +3467,7 @@
             <a:r>
               <a:rPr sz="1700" b="0">
                 <a:solidFill>
-                  <a:srgbClr val="E2E8F0"/>
+                  <a:srgbClr val="DDE6F4"/>
                 </a:solidFill>
                 <a:latin typeface="Arial"/>
               </a:rPr>
@@ -3392,7 +3478,7 @@
       </p:sp>
       <p:sp>
         <p:nvSpPr>
-          <p:cNvPr id="6" name="Rounded Rectangle 5"/>
+          <p:cNvPr id="8" name="Rounded Rectangle 7"/>
           <p:cNvSpPr/>
           <p:nvPr/>
         </p:nvSpPr>
@@ -3405,11 +3491,11 @@
             <a:avLst/>
           </a:prstGeom>
           <a:solidFill>
-            <a:srgbClr val="0F172A"/>
+            <a:srgbClr val="0C162E"/>
           </a:solidFill>
           <a:ln>
             <a:solidFill>
-              <a:srgbClr val="22D3EE"/>
+              <a:srgbClr val="38BDF8"/>
             </a:solidFill>
           </a:ln>
         </p:spPr>
@@ -3435,7 +3521,7 @@
             <a:r>
               <a:rPr sz="1100" b="1">
                 <a:solidFill>
-                  <a:srgbClr val="22D3EE"/>
+                  <a:srgbClr val="38BDF8"/>
                 </a:solidFill>
                 <a:latin typeface="Arial"/>
               </a:rPr>
@@ -3446,7 +3532,7 @@
       </p:sp>
       <p:sp>
         <p:nvSpPr>
-          <p:cNvPr id="7" name="Rounded Rectangle 6"/>
+          <p:cNvPr id="9" name="Rounded Rectangle 8"/>
           <p:cNvSpPr/>
           <p:nvPr/>
         </p:nvSpPr>
@@ -3459,11 +3545,11 @@
             <a:avLst/>
           </a:prstGeom>
           <a:solidFill>
-            <a:srgbClr val="0F172A"/>
+            <a:srgbClr val="1A1334"/>
           </a:solidFill>
           <a:ln>
             <a:solidFill>
-              <a:srgbClr val="22D3EE"/>
+              <a:srgbClr val="38BDF8"/>
             </a:solidFill>
           </a:ln>
         </p:spPr>
@@ -3489,7 +3575,7 @@
             <a:r>
               <a:rPr sz="1100" b="1">
                 <a:solidFill>
-                  <a:srgbClr val="22D3EE"/>
+                  <a:srgbClr val="A78BFA"/>
                 </a:solidFill>
                 <a:latin typeface="Arial"/>
               </a:rPr>
@@ -3500,7 +3586,7 @@
       </p:sp>
       <p:sp>
         <p:nvSpPr>
-          <p:cNvPr id="8" name="Rounded Rectangle 7"/>
+          <p:cNvPr id="10" name="Rounded Rectangle 9"/>
           <p:cNvSpPr/>
           <p:nvPr/>
         </p:nvSpPr>
@@ -3513,11 +3599,11 @@
             <a:avLst/>
           </a:prstGeom>
           <a:solidFill>
-            <a:srgbClr val="0F172A"/>
+            <a:srgbClr val="0C162E"/>
           </a:solidFill>
           <a:ln>
             <a:solidFill>
-              <a:srgbClr val="22D3EE"/>
+              <a:srgbClr val="38BDF8"/>
             </a:solidFill>
           </a:ln>
         </p:spPr>
@@ -3543,7 +3629,7 @@
             <a:r>
               <a:rPr sz="1100" b="1">
                 <a:solidFill>
-                  <a:srgbClr val="22D3EE"/>
+                  <a:srgbClr val="38BDF8"/>
                 </a:solidFill>
                 <a:latin typeface="Arial"/>
               </a:rPr>
@@ -3554,7 +3640,7 @@
       </p:sp>
       <p:sp>
         <p:nvSpPr>
-          <p:cNvPr id="9" name="Rounded Rectangle 8"/>
+          <p:cNvPr id="11" name="Rounded Rectangle 10"/>
           <p:cNvSpPr/>
           <p:nvPr/>
         </p:nvSpPr>
@@ -3567,11 +3653,11 @@
             <a:avLst/>
           </a:prstGeom>
           <a:solidFill>
-            <a:srgbClr val="0F172A"/>
+            <a:srgbClr val="1A1334"/>
           </a:solidFill>
           <a:ln>
             <a:solidFill>
-              <a:srgbClr val="22D3EE"/>
+              <a:srgbClr val="38BDF8"/>
             </a:solidFill>
           </a:ln>
         </p:spPr>
@@ -3597,7 +3683,7 @@
             <a:r>
               <a:rPr sz="1100" b="1">
                 <a:solidFill>
-                  <a:srgbClr val="22D3EE"/>
+                  <a:srgbClr val="A78BFA"/>
                 </a:solidFill>
                 <a:latin typeface="Arial"/>
               </a:rPr>
@@ -3608,7 +3694,7 @@
       </p:sp>
       <p:sp>
         <p:nvSpPr>
-          <p:cNvPr id="10" name="Rounded Rectangle 9"/>
+          <p:cNvPr id="12" name="Rounded Rectangle 11"/>
           <p:cNvSpPr/>
           <p:nvPr/>
         </p:nvSpPr>
@@ -3621,11 +3707,11 @@
             <a:avLst/>
           </a:prstGeom>
           <a:solidFill>
-            <a:srgbClr val="0F172A"/>
+            <a:srgbClr val="0C162E"/>
           </a:solidFill>
           <a:ln>
             <a:solidFill>
-              <a:srgbClr val="22D3EE"/>
+              <a:srgbClr val="38BDF8"/>
             </a:solidFill>
           </a:ln>
         </p:spPr>
@@ -3651,7 +3737,7 @@
             <a:r>
               <a:rPr sz="1100" b="1">
                 <a:solidFill>
-                  <a:srgbClr val="22D3EE"/>
+                  <a:srgbClr val="38BDF8"/>
                 </a:solidFill>
                 <a:latin typeface="Arial"/>
               </a:rPr>
@@ -3662,7 +3748,7 @@
       </p:sp>
       <p:sp>
         <p:nvSpPr>
-          <p:cNvPr id="11" name="Rounded Rectangle 10"/>
+          <p:cNvPr id="13" name="Rounded Rectangle 12"/>
           <p:cNvSpPr/>
           <p:nvPr/>
         </p:nvSpPr>
@@ -3675,11 +3761,11 @@
             <a:avLst/>
           </a:prstGeom>
           <a:solidFill>
-            <a:srgbClr val="090F1E"/>
+            <a:srgbClr val="080F21"/>
           </a:solidFill>
           <a:ln>
             <a:solidFill>
-              <a:srgbClr val="22D3EE"/>
+              <a:srgbClr val="A78BFA"/>
             </a:solidFill>
           </a:ln>
         </p:spPr>
@@ -3709,7 +3795,7 @@
             <a:r>
               <a:rPr sz="1500" b="0">
                 <a:solidFill>
-                  <a:srgbClr val="E2E8F0"/>
+                  <a:srgbClr val="DDE6F4"/>
                 </a:solidFill>
                 <a:latin typeface="Arial"/>
               </a:rPr>
@@ -3732,7 +3818,7 @@
     <p:bg>
       <p:bgPr>
         <a:solidFill>
-          <a:srgbClr val="020617"/>
+          <a:srgbClr val="040A18"/>
         </a:solidFill>
         <a:effectLst/>
       </p:bgPr>
@@ -3769,7 +3855,7 @@
             <a:r>
               <a:rPr sz="2400" b="1">
                 <a:solidFill>
-                  <a:srgbClr val="F1F5F9"/>
+                  <a:srgbClr val="F4F7FF"/>
                 </a:solidFill>
                 <a:latin typeface="Arial"/>
               </a:rPr>
@@ -3793,7 +3879,7 @@
             <a:avLst/>
           </a:prstGeom>
           <a:solidFill>
-            <a:srgbClr val="22D3EE"/>
+            <a:srgbClr val="38BDF8"/>
           </a:solidFill>
           <a:ln>
             <a:noFill/>
@@ -3836,11 +3922,11 @@
             <a:avLst/>
           </a:prstGeom>
           <a:solidFill>
-            <a:srgbClr val="0F172A"/>
+            <a:srgbClr val="0C162E"/>
           </a:solidFill>
           <a:ln>
             <a:solidFill>
-              <a:srgbClr val="22D3EE"/>
+              <a:srgbClr val="38BDF8"/>
             </a:solidFill>
           </a:ln>
         </p:spPr>
@@ -3870,7 +3956,7 @@
             <a:r>
               <a:rPr sz="1600" b="0">
                 <a:solidFill>
-                  <a:srgbClr val="E2E8F0"/>
+                  <a:srgbClr val="DDE6F4"/>
                 </a:solidFill>
                 <a:latin typeface="Arial"/>
               </a:rPr>
@@ -3894,11 +3980,11 @@
             <a:avLst/>
           </a:prstGeom>
           <a:solidFill>
-            <a:srgbClr val="0A1224"/>
+            <a:srgbClr val="091226"/>
           </a:solidFill>
           <a:ln>
             <a:solidFill>
-              <a:srgbClr val="22D3EE"/>
+              <a:srgbClr val="38BDF8"/>
             </a:solidFill>
           </a:ln>
         </p:spPr>
@@ -3939,11 +4025,11 @@
             <a:avLst/>
           </a:prstGeom>
           <a:solidFill>
-            <a:srgbClr val="0F172A"/>
+            <a:srgbClr val="0C162E"/>
           </a:solidFill>
           <a:ln>
             <a:solidFill>
-              <a:srgbClr val="0F172A"/>
+              <a:srgbClr val="0C162E"/>
             </a:solidFill>
           </a:ln>
         </p:spPr>
@@ -3969,7 +4055,7 @@
             <a:r>
               <a:rPr sz="1200" b="1">
                 <a:solidFill>
-                  <a:srgbClr val="22D3EE"/>
+                  <a:srgbClr val="38BDF8"/>
                 </a:solidFill>
                 <a:latin typeface="Arial"/>
               </a:rPr>
@@ -4008,7 +4094,7 @@
             <a:r>
               <a:rPr sz="1400" b="0">
                 <a:solidFill>
-                  <a:srgbClr val="E2E8F0"/>
+                  <a:srgbClr val="DDE6F4"/>
                 </a:solidFill>
                 <a:latin typeface="Arial"/>
               </a:rPr>
@@ -4024,7 +4110,7 @@
             <a:r>
               <a:rPr sz="1400" b="0">
                 <a:solidFill>
-                  <a:srgbClr val="E2E8F0"/>
+                  <a:srgbClr val="DDE6F4"/>
                 </a:solidFill>
                 <a:latin typeface="Arial"/>
               </a:rPr>
@@ -4048,11 +4134,11 @@
             <a:avLst/>
           </a:prstGeom>
           <a:solidFill>
-            <a:srgbClr val="0A1224"/>
+            <a:srgbClr val="091226"/>
           </a:solidFill>
           <a:ln>
             <a:solidFill>
-              <a:srgbClr val="22D3EE"/>
+              <a:srgbClr val="38BDF8"/>
             </a:solidFill>
           </a:ln>
         </p:spPr>
@@ -4093,11 +4179,11 @@
             <a:avLst/>
           </a:prstGeom>
           <a:solidFill>
-            <a:srgbClr val="0F172A"/>
+            <a:srgbClr val="0C162E"/>
           </a:solidFill>
           <a:ln>
             <a:solidFill>
-              <a:srgbClr val="0F172A"/>
+              <a:srgbClr val="0C162E"/>
             </a:solidFill>
           </a:ln>
         </p:spPr>
@@ -4123,7 +4209,7 @@
             <a:r>
               <a:rPr sz="1200" b="1">
                 <a:solidFill>
-                  <a:srgbClr val="22D3EE"/>
+                  <a:srgbClr val="38BDF8"/>
                 </a:solidFill>
                 <a:latin typeface="Arial"/>
               </a:rPr>
@@ -4162,7 +4248,7 @@
             <a:r>
               <a:rPr sz="1400" b="0">
                 <a:solidFill>
-                  <a:srgbClr val="E2E8F0"/>
+                  <a:srgbClr val="DDE6F4"/>
                 </a:solidFill>
                 <a:latin typeface="Arial"/>
               </a:rPr>
@@ -4178,7 +4264,7 @@
             <a:r>
               <a:rPr sz="1400" b="0">
                 <a:solidFill>
-                  <a:srgbClr val="E2E8F0"/>
+                  <a:srgbClr val="DDE6F4"/>
                 </a:solidFill>
                 <a:latin typeface="Arial"/>
               </a:rPr>
@@ -4202,11 +4288,11 @@
             <a:avLst/>
           </a:prstGeom>
           <a:solidFill>
-            <a:srgbClr val="0A1224"/>
+            <a:srgbClr val="091226"/>
           </a:solidFill>
           <a:ln>
             <a:solidFill>
-              <a:srgbClr val="22D3EE"/>
+              <a:srgbClr val="38BDF8"/>
             </a:solidFill>
           </a:ln>
         </p:spPr>
@@ -4247,11 +4333,11 @@
             <a:avLst/>
           </a:prstGeom>
           <a:solidFill>
-            <a:srgbClr val="0F172A"/>
+            <a:srgbClr val="0C162E"/>
           </a:solidFill>
           <a:ln>
             <a:solidFill>
-              <a:srgbClr val="0F172A"/>
+              <a:srgbClr val="0C162E"/>
             </a:solidFill>
           </a:ln>
         </p:spPr>
@@ -4277,7 +4363,7 @@
             <a:r>
               <a:rPr sz="1200" b="1">
                 <a:solidFill>
-                  <a:srgbClr val="22D3EE"/>
+                  <a:srgbClr val="38BDF8"/>
                 </a:solidFill>
                 <a:latin typeface="Arial"/>
               </a:rPr>
@@ -4316,7 +4402,7 @@
             <a:r>
               <a:rPr sz="1400" b="0">
                 <a:solidFill>
-                  <a:srgbClr val="E2E8F0"/>
+                  <a:srgbClr val="DDE6F4"/>
                 </a:solidFill>
                 <a:latin typeface="Arial"/>
               </a:rPr>
@@ -4332,7 +4418,7 @@
             <a:r>
               <a:rPr sz="1400" b="0">
                 <a:solidFill>
-                  <a:srgbClr val="E2E8F0"/>
+                  <a:srgbClr val="DDE6F4"/>
                 </a:solidFill>
                 <a:latin typeface="Arial"/>
               </a:rPr>
@@ -4356,11 +4442,11 @@
             <a:avLst/>
           </a:prstGeom>
           <a:solidFill>
-            <a:srgbClr val="030712"/>
+            <a:srgbClr val="060C1C"/>
           </a:solidFill>
           <a:ln>
             <a:solidFill>
-              <a:srgbClr val="22D3EE"/>
+              <a:srgbClr val="38BDF8"/>
             </a:solidFill>
           </a:ln>
         </p:spPr>
@@ -4386,7 +4472,7 @@
             <a:r>
               <a:rPr sz="1250" b="0">
                 <a:solidFill>
-                  <a:srgbClr val="C4FFEC"/>
+                  <a:srgbClr val="C5F4FF"/>
                 </a:solidFill>
                 <a:latin typeface="Courier New"/>
               </a:rPr>
@@ -4411,11 +4497,11 @@
             <a:avLst/>
           </a:prstGeom>
           <a:solidFill>
-            <a:srgbClr val="0D1426"/>
+            <a:srgbClr val="0F1830"/>
           </a:solidFill>
           <a:ln>
             <a:solidFill>
-              <a:srgbClr val="0D1426"/>
+              <a:srgbClr val="0F1830"/>
             </a:solidFill>
           </a:ln>
         </p:spPr>
@@ -4441,7 +4527,7 @@
             <a:r>
               <a:rPr sz="1000" b="1">
                 <a:solidFill>
-                  <a:srgbClr val="22D3EE"/>
+                  <a:srgbClr val="38BDF8"/>
                 </a:solidFill>
                 <a:latin typeface="Courier New"/>
               </a:rPr>
@@ -4476,7 +4562,7 @@
             <a:r>
               <a:rPr sz="1100" b="0">
                 <a:solidFill>
-                  <a:srgbClr val="94A3B8"/>
+                  <a:srgbClr val="899CBE"/>
                 </a:solidFill>
                 <a:latin typeface="Arial"/>
               </a:rPr>
@@ -4499,7 +4585,7 @@
     <p:bg>
       <p:bgPr>
         <a:solidFill>
-          <a:srgbClr val="020617"/>
+          <a:srgbClr val="040A18"/>
         </a:solidFill>
         <a:effectLst/>
       </p:bgPr>
@@ -4536,7 +4622,7 @@
             <a:r>
               <a:rPr sz="2400" b="1">
                 <a:solidFill>
-                  <a:srgbClr val="F1F5F9"/>
+                  <a:srgbClr val="F4F7FF"/>
                 </a:solidFill>
                 <a:latin typeface="Arial"/>
               </a:rPr>
@@ -4560,7 +4646,7 @@
             <a:avLst/>
           </a:prstGeom>
           <a:solidFill>
-            <a:srgbClr val="22D3EE"/>
+            <a:srgbClr val="38BDF8"/>
           </a:solidFill>
           <a:ln>
             <a:noFill/>
@@ -4603,11 +4689,11 @@
             <a:avLst/>
           </a:prstGeom>
           <a:solidFill>
-            <a:srgbClr val="0F172A"/>
+            <a:srgbClr val="0C162E"/>
           </a:solidFill>
           <a:ln>
             <a:solidFill>
-              <a:srgbClr val="22D3EE"/>
+              <a:srgbClr val="38BDF8"/>
             </a:solidFill>
           </a:ln>
         </p:spPr>
@@ -4637,7 +4723,7 @@
             <a:r>
               <a:rPr sz="1600" b="0">
                 <a:solidFill>
-                  <a:srgbClr val="E2E8F0"/>
+                  <a:srgbClr val="DDE6F4"/>
                 </a:solidFill>
                 <a:latin typeface="Arial"/>
               </a:rPr>
@@ -4661,11 +4747,11 @@
             <a:avLst/>
           </a:prstGeom>
           <a:solidFill>
-            <a:srgbClr val="0A1224"/>
+            <a:srgbClr val="091226"/>
           </a:solidFill>
           <a:ln>
             <a:solidFill>
-              <a:srgbClr val="22D3EE"/>
+              <a:srgbClr val="38BDF8"/>
             </a:solidFill>
           </a:ln>
         </p:spPr>
@@ -4706,11 +4792,11 @@
             <a:avLst/>
           </a:prstGeom>
           <a:solidFill>
-            <a:srgbClr val="0F172A"/>
+            <a:srgbClr val="0C162E"/>
           </a:solidFill>
           <a:ln>
             <a:solidFill>
-              <a:srgbClr val="0F172A"/>
+              <a:srgbClr val="0C162E"/>
             </a:solidFill>
           </a:ln>
         </p:spPr>
@@ -4736,7 +4822,7 @@
             <a:r>
               <a:rPr sz="1200" b="1">
                 <a:solidFill>
-                  <a:srgbClr val="22D3EE"/>
+                  <a:srgbClr val="38BDF8"/>
                 </a:solidFill>
                 <a:latin typeface="Arial"/>
               </a:rPr>
@@ -4775,7 +4861,7 @@
             <a:r>
               <a:rPr sz="1400" b="0">
                 <a:solidFill>
-                  <a:srgbClr val="E2E8F0"/>
+                  <a:srgbClr val="DDE6F4"/>
                 </a:solidFill>
                 <a:latin typeface="Arial"/>
               </a:rPr>
@@ -4791,7 +4877,7 @@
             <a:r>
               <a:rPr sz="1400" b="0">
                 <a:solidFill>
-                  <a:srgbClr val="E2E8F0"/>
+                  <a:srgbClr val="DDE6F4"/>
                 </a:solidFill>
                 <a:latin typeface="Arial"/>
               </a:rPr>
@@ -4815,11 +4901,11 @@
             <a:avLst/>
           </a:prstGeom>
           <a:solidFill>
-            <a:srgbClr val="0A1224"/>
+            <a:srgbClr val="091226"/>
           </a:solidFill>
           <a:ln>
             <a:solidFill>
-              <a:srgbClr val="22D3EE"/>
+              <a:srgbClr val="38BDF8"/>
             </a:solidFill>
           </a:ln>
         </p:spPr>
@@ -4860,11 +4946,11 @@
             <a:avLst/>
           </a:prstGeom>
           <a:solidFill>
-            <a:srgbClr val="0F172A"/>
+            <a:srgbClr val="0C162E"/>
           </a:solidFill>
           <a:ln>
             <a:solidFill>
-              <a:srgbClr val="0F172A"/>
+              <a:srgbClr val="0C162E"/>
             </a:solidFill>
           </a:ln>
         </p:spPr>
@@ -4890,7 +4976,7 @@
             <a:r>
               <a:rPr sz="1200" b="1">
                 <a:solidFill>
-                  <a:srgbClr val="22D3EE"/>
+                  <a:srgbClr val="38BDF8"/>
                 </a:solidFill>
                 <a:latin typeface="Arial"/>
               </a:rPr>
@@ -4929,7 +5015,7 @@
             <a:r>
               <a:rPr sz="1400" b="0">
                 <a:solidFill>
-                  <a:srgbClr val="E2E8F0"/>
+                  <a:srgbClr val="DDE6F4"/>
                 </a:solidFill>
                 <a:latin typeface="Arial"/>
               </a:rPr>
@@ -4945,7 +5031,7 @@
             <a:r>
               <a:rPr sz="1400" b="0">
                 <a:solidFill>
-                  <a:srgbClr val="E2E8F0"/>
+                  <a:srgbClr val="DDE6F4"/>
                 </a:solidFill>
                 <a:latin typeface="Arial"/>
               </a:rPr>
@@ -4969,11 +5055,11 @@
             <a:avLst/>
           </a:prstGeom>
           <a:solidFill>
-            <a:srgbClr val="0A1224"/>
+            <a:srgbClr val="091226"/>
           </a:solidFill>
           <a:ln>
             <a:solidFill>
-              <a:srgbClr val="22D3EE"/>
+              <a:srgbClr val="38BDF8"/>
             </a:solidFill>
           </a:ln>
         </p:spPr>
@@ -5014,11 +5100,11 @@
             <a:avLst/>
           </a:prstGeom>
           <a:solidFill>
-            <a:srgbClr val="0F172A"/>
+            <a:srgbClr val="0C162E"/>
           </a:solidFill>
           <a:ln>
             <a:solidFill>
-              <a:srgbClr val="0F172A"/>
+              <a:srgbClr val="0C162E"/>
             </a:solidFill>
           </a:ln>
         </p:spPr>
@@ -5044,7 +5130,7 @@
             <a:r>
               <a:rPr sz="1200" b="1">
                 <a:solidFill>
-                  <a:srgbClr val="22D3EE"/>
+                  <a:srgbClr val="38BDF8"/>
                 </a:solidFill>
                 <a:latin typeface="Arial"/>
               </a:rPr>
@@ -5083,7 +5169,7 @@
             <a:r>
               <a:rPr sz="1400" b="0">
                 <a:solidFill>
-                  <a:srgbClr val="E2E8F0"/>
+                  <a:srgbClr val="DDE6F4"/>
                 </a:solidFill>
                 <a:latin typeface="Arial"/>
               </a:rPr>
@@ -5099,7 +5185,7 @@
             <a:r>
               <a:rPr sz="1400" b="0">
                 <a:solidFill>
-                  <a:srgbClr val="E2E8F0"/>
+                  <a:srgbClr val="DDE6F4"/>
                 </a:solidFill>
                 <a:latin typeface="Arial"/>
               </a:rPr>
@@ -5123,11 +5209,11 @@
             <a:avLst/>
           </a:prstGeom>
           <a:solidFill>
-            <a:srgbClr val="030712"/>
+            <a:srgbClr val="060C1C"/>
           </a:solidFill>
           <a:ln>
             <a:solidFill>
-              <a:srgbClr val="22D3EE"/>
+              <a:srgbClr val="38BDF8"/>
             </a:solidFill>
           </a:ln>
         </p:spPr>
@@ -5153,7 +5239,7 @@
             <a:r>
               <a:rPr sz="1250" b="0">
                 <a:solidFill>
-                  <a:srgbClr val="C4FFEC"/>
+                  <a:srgbClr val="C5F4FF"/>
                 </a:solidFill>
                 <a:latin typeface="Courier New"/>
               </a:rPr>
@@ -5178,11 +5264,11 @@
             <a:avLst/>
           </a:prstGeom>
           <a:solidFill>
-            <a:srgbClr val="0D1426"/>
+            <a:srgbClr val="0F1830"/>
           </a:solidFill>
           <a:ln>
             <a:solidFill>
-              <a:srgbClr val="0D1426"/>
+              <a:srgbClr val="0F1830"/>
             </a:solidFill>
           </a:ln>
         </p:spPr>
@@ -5208,7 +5294,7 @@
             <a:r>
               <a:rPr sz="1000" b="1">
                 <a:solidFill>
-                  <a:srgbClr val="22D3EE"/>
+                  <a:srgbClr val="38BDF8"/>
                 </a:solidFill>
                 <a:latin typeface="Courier New"/>
               </a:rPr>
@@ -5243,7 +5329,7 @@
             <a:r>
               <a:rPr sz="1100" b="0">
                 <a:solidFill>
-                  <a:srgbClr val="94A3B8"/>
+                  <a:srgbClr val="899CBE"/>
                 </a:solidFill>
                 <a:latin typeface="Arial"/>
               </a:rPr>
@@ -5266,7 +5352,7 @@
     <p:bg>
       <p:bgPr>
         <a:solidFill>
-          <a:srgbClr val="020617"/>
+          <a:srgbClr val="040A18"/>
         </a:solidFill>
         <a:effectLst/>
       </p:bgPr>
@@ -5303,7 +5389,7 @@
             <a:r>
               <a:rPr sz="2400" b="1">
                 <a:solidFill>
-                  <a:srgbClr val="F1F5F9"/>
+                  <a:srgbClr val="F4F7FF"/>
                 </a:solidFill>
                 <a:latin typeface="Arial"/>
               </a:rPr>
@@ -5327,7 +5413,7 @@
             <a:avLst/>
           </a:prstGeom>
           <a:solidFill>
-            <a:srgbClr val="22D3EE"/>
+            <a:srgbClr val="38BDF8"/>
           </a:solidFill>
           <a:ln>
             <a:noFill/>
@@ -5370,11 +5456,11 @@
             <a:avLst/>
           </a:prstGeom>
           <a:solidFill>
-            <a:srgbClr val="0F172A"/>
+            <a:srgbClr val="0C162E"/>
           </a:solidFill>
           <a:ln>
             <a:solidFill>
-              <a:srgbClr val="22D3EE"/>
+              <a:srgbClr val="38BDF8"/>
             </a:solidFill>
           </a:ln>
         </p:spPr>
@@ -5404,7 +5490,7 @@
             <a:r>
               <a:rPr sz="1600" b="0">
                 <a:solidFill>
-                  <a:srgbClr val="E2E8F0"/>
+                  <a:srgbClr val="DDE6F4"/>
                 </a:solidFill>
                 <a:latin typeface="Arial"/>
               </a:rPr>
@@ -5428,11 +5514,11 @@
             <a:avLst/>
           </a:prstGeom>
           <a:solidFill>
-            <a:srgbClr val="0A1224"/>
+            <a:srgbClr val="091226"/>
           </a:solidFill>
           <a:ln>
             <a:solidFill>
-              <a:srgbClr val="22D3EE"/>
+              <a:srgbClr val="38BDF8"/>
             </a:solidFill>
           </a:ln>
         </p:spPr>
@@ -5473,11 +5559,11 @@
             <a:avLst/>
           </a:prstGeom>
           <a:solidFill>
-            <a:srgbClr val="0F172A"/>
+            <a:srgbClr val="0C162E"/>
           </a:solidFill>
           <a:ln>
             <a:solidFill>
-              <a:srgbClr val="0F172A"/>
+              <a:srgbClr val="0C162E"/>
             </a:solidFill>
           </a:ln>
         </p:spPr>
@@ -5503,7 +5589,7 @@
             <a:r>
               <a:rPr sz="1200" b="1">
                 <a:solidFill>
-                  <a:srgbClr val="22D3EE"/>
+                  <a:srgbClr val="38BDF8"/>
                 </a:solidFill>
                 <a:latin typeface="Arial"/>
               </a:rPr>
@@ -5542,7 +5628,7 @@
             <a:r>
               <a:rPr sz="1400" b="0">
                 <a:solidFill>
-                  <a:srgbClr val="E2E8F0"/>
+                  <a:srgbClr val="DDE6F4"/>
                 </a:solidFill>
                 <a:latin typeface="Arial"/>
               </a:rPr>
@@ -5558,7 +5644,7 @@
             <a:r>
               <a:rPr sz="1400" b="0">
                 <a:solidFill>
-                  <a:srgbClr val="E2E8F0"/>
+                  <a:srgbClr val="DDE6F4"/>
                 </a:solidFill>
                 <a:latin typeface="Arial"/>
               </a:rPr>
@@ -5582,11 +5668,11 @@
             <a:avLst/>
           </a:prstGeom>
           <a:solidFill>
-            <a:srgbClr val="0A1224"/>
+            <a:srgbClr val="091226"/>
           </a:solidFill>
           <a:ln>
             <a:solidFill>
-              <a:srgbClr val="22D3EE"/>
+              <a:srgbClr val="38BDF8"/>
             </a:solidFill>
           </a:ln>
         </p:spPr>
@@ -5627,11 +5713,11 @@
             <a:avLst/>
           </a:prstGeom>
           <a:solidFill>
-            <a:srgbClr val="0F172A"/>
+            <a:srgbClr val="0C162E"/>
           </a:solidFill>
           <a:ln>
             <a:solidFill>
-              <a:srgbClr val="0F172A"/>
+              <a:srgbClr val="0C162E"/>
             </a:solidFill>
           </a:ln>
         </p:spPr>
@@ -5657,7 +5743,7 @@
             <a:r>
               <a:rPr sz="1200" b="1">
                 <a:solidFill>
-                  <a:srgbClr val="22D3EE"/>
+                  <a:srgbClr val="38BDF8"/>
                 </a:solidFill>
                 <a:latin typeface="Arial"/>
               </a:rPr>
@@ -5696,7 +5782,7 @@
             <a:r>
               <a:rPr sz="1400" b="0">
                 <a:solidFill>
-                  <a:srgbClr val="E2E8F0"/>
+                  <a:srgbClr val="DDE6F4"/>
                 </a:solidFill>
                 <a:latin typeface="Arial"/>
               </a:rPr>
@@ -5712,7 +5798,7 @@
             <a:r>
               <a:rPr sz="1400" b="0">
                 <a:solidFill>
-                  <a:srgbClr val="E2E8F0"/>
+                  <a:srgbClr val="DDE6F4"/>
                 </a:solidFill>
                 <a:latin typeface="Arial"/>
               </a:rPr>
@@ -5736,11 +5822,11 @@
             <a:avLst/>
           </a:prstGeom>
           <a:solidFill>
-            <a:srgbClr val="0A1224"/>
+            <a:srgbClr val="091226"/>
           </a:solidFill>
           <a:ln>
             <a:solidFill>
-              <a:srgbClr val="22D3EE"/>
+              <a:srgbClr val="38BDF8"/>
             </a:solidFill>
           </a:ln>
         </p:spPr>
@@ -5781,11 +5867,11 @@
             <a:avLst/>
           </a:prstGeom>
           <a:solidFill>
-            <a:srgbClr val="0F172A"/>
+            <a:srgbClr val="0C162E"/>
           </a:solidFill>
           <a:ln>
             <a:solidFill>
-              <a:srgbClr val="0F172A"/>
+              <a:srgbClr val="0C162E"/>
             </a:solidFill>
           </a:ln>
         </p:spPr>
@@ -5811,7 +5897,7 @@
             <a:r>
               <a:rPr sz="1200" b="1">
                 <a:solidFill>
-                  <a:srgbClr val="22D3EE"/>
+                  <a:srgbClr val="38BDF8"/>
                 </a:solidFill>
                 <a:latin typeface="Arial"/>
               </a:rPr>
@@ -5850,7 +5936,7 @@
             <a:r>
               <a:rPr sz="1400" b="0">
                 <a:solidFill>
-                  <a:srgbClr val="E2E8F0"/>
+                  <a:srgbClr val="DDE6F4"/>
                 </a:solidFill>
                 <a:latin typeface="Arial"/>
               </a:rPr>
@@ -5866,7 +5952,7 @@
             <a:r>
               <a:rPr sz="1400" b="0">
                 <a:solidFill>
-                  <a:srgbClr val="E2E8F0"/>
+                  <a:srgbClr val="DDE6F4"/>
                 </a:solidFill>
                 <a:latin typeface="Arial"/>
               </a:rPr>
@@ -5890,11 +5976,11 @@
             <a:avLst/>
           </a:prstGeom>
           <a:solidFill>
-            <a:srgbClr val="030712"/>
+            <a:srgbClr val="060C1C"/>
           </a:solidFill>
           <a:ln>
             <a:solidFill>
-              <a:srgbClr val="22D3EE"/>
+              <a:srgbClr val="38BDF8"/>
             </a:solidFill>
           </a:ln>
         </p:spPr>
@@ -5920,7 +6006,7 @@
             <a:r>
               <a:rPr sz="1250" b="0">
                 <a:solidFill>
-                  <a:srgbClr val="C4FFEC"/>
+                  <a:srgbClr val="C5F4FF"/>
                 </a:solidFill>
                 <a:latin typeface="Courier New"/>
               </a:rPr>
@@ -5946,11 +6032,11 @@
             <a:avLst/>
           </a:prstGeom>
           <a:solidFill>
-            <a:srgbClr val="0D1426"/>
+            <a:srgbClr val="0F1830"/>
           </a:solidFill>
           <a:ln>
             <a:solidFill>
-              <a:srgbClr val="0D1426"/>
+              <a:srgbClr val="0F1830"/>
             </a:solidFill>
           </a:ln>
         </p:spPr>
@@ -5976,7 +6062,7 @@
             <a:r>
               <a:rPr sz="1000" b="1">
                 <a:solidFill>
-                  <a:srgbClr val="22D3EE"/>
+                  <a:srgbClr val="38BDF8"/>
                 </a:solidFill>
                 <a:latin typeface="Courier New"/>
               </a:rPr>
@@ -6011,7 +6097,7 @@
             <a:r>
               <a:rPr sz="1100" b="0">
                 <a:solidFill>
-                  <a:srgbClr val="94A3B8"/>
+                  <a:srgbClr val="899CBE"/>
                 </a:solidFill>
                 <a:latin typeface="Arial"/>
               </a:rPr>
@@ -6034,7 +6120,7 @@
     <p:bg>
       <p:bgPr>
         <a:solidFill>
-          <a:srgbClr val="020617"/>
+          <a:srgbClr val="040A18"/>
         </a:solidFill>
         <a:effectLst/>
       </p:bgPr>
@@ -6071,7 +6157,7 @@
             <a:r>
               <a:rPr sz="2400" b="1">
                 <a:solidFill>
-                  <a:srgbClr val="F1F5F9"/>
+                  <a:srgbClr val="F4F7FF"/>
                 </a:solidFill>
                 <a:latin typeface="Arial"/>
               </a:rPr>
@@ -6095,7 +6181,7 @@
             <a:avLst/>
           </a:prstGeom>
           <a:solidFill>
-            <a:srgbClr val="22D3EE"/>
+            <a:srgbClr val="38BDF8"/>
           </a:solidFill>
           <a:ln>
             <a:noFill/>
@@ -6138,11 +6224,11 @@
             <a:avLst/>
           </a:prstGeom>
           <a:solidFill>
-            <a:srgbClr val="0F172A"/>
+            <a:srgbClr val="0C162E"/>
           </a:solidFill>
           <a:ln>
             <a:solidFill>
-              <a:srgbClr val="22D3EE"/>
+              <a:srgbClr val="38BDF8"/>
             </a:solidFill>
           </a:ln>
         </p:spPr>
@@ -6172,7 +6258,7 @@
             <a:r>
               <a:rPr sz="1600" b="0">
                 <a:solidFill>
-                  <a:srgbClr val="E2E8F0"/>
+                  <a:srgbClr val="DDE6F4"/>
                 </a:solidFill>
                 <a:latin typeface="Arial"/>
               </a:rPr>
@@ -6211,7 +6297,7 @@
             <a:r>
               <a:rPr sz="1700" b="0">
                 <a:solidFill>
-                  <a:srgbClr val="E2E8F0"/>
+                  <a:srgbClr val="DDE6F4"/>
                 </a:solidFill>
                 <a:latin typeface="Arial"/>
               </a:rPr>
@@ -6227,7 +6313,7 @@
             <a:r>
               <a:rPr sz="1700" b="0">
                 <a:solidFill>
-                  <a:srgbClr val="E2E8F0"/>
+                  <a:srgbClr val="DDE6F4"/>
                 </a:solidFill>
                 <a:latin typeface="Arial"/>
               </a:rPr>
@@ -6243,7 +6329,7 @@
             <a:r>
               <a:rPr sz="1700" b="0">
                 <a:solidFill>
-                  <a:srgbClr val="E2E8F0"/>
+                  <a:srgbClr val="DDE6F4"/>
                 </a:solidFill>
                 <a:latin typeface="Arial"/>
               </a:rPr>
@@ -6267,11 +6353,11 @@
             <a:avLst/>
           </a:prstGeom>
           <a:solidFill>
-            <a:srgbClr val="030712"/>
+            <a:srgbClr val="060C1C"/>
           </a:solidFill>
           <a:ln>
             <a:solidFill>
-              <a:srgbClr val="22D3EE"/>
+              <a:srgbClr val="38BDF8"/>
             </a:solidFill>
           </a:ln>
         </p:spPr>
@@ -6297,7 +6383,7 @@
             <a:r>
               <a:rPr sz="1250" b="0">
                 <a:solidFill>
-                  <a:srgbClr val="C4FFEC"/>
+                  <a:srgbClr val="C5F4FF"/>
                 </a:solidFill>
                 <a:latin typeface="Courier New"/>
               </a:rPr>
@@ -6324,11 +6410,11 @@
             <a:avLst/>
           </a:prstGeom>
           <a:solidFill>
-            <a:srgbClr val="0D1426"/>
+            <a:srgbClr val="0F1830"/>
           </a:solidFill>
           <a:ln>
             <a:solidFill>
-              <a:srgbClr val="0D1426"/>
+              <a:srgbClr val="0F1830"/>
             </a:solidFill>
           </a:ln>
         </p:spPr>
@@ -6354,7 +6440,7 @@
             <a:r>
               <a:rPr sz="1000" b="1">
                 <a:solidFill>
-                  <a:srgbClr val="22D3EE"/>
+                  <a:srgbClr val="38BDF8"/>
                 </a:solidFill>
                 <a:latin typeface="Courier New"/>
               </a:rPr>
@@ -6389,7 +6475,7 @@
             <a:r>
               <a:rPr sz="1100" b="0">
                 <a:solidFill>
-                  <a:srgbClr val="94A3B8"/>
+                  <a:srgbClr val="899CBE"/>
                 </a:solidFill>
                 <a:latin typeface="Arial"/>
               </a:rPr>
@@ -6412,7 +6498,7 @@
     <p:bg>
       <p:bgPr>
         <a:solidFill>
-          <a:srgbClr val="020617"/>
+          <a:srgbClr val="040A18"/>
         </a:solidFill>
         <a:effectLst/>
       </p:bgPr>
@@ -6449,7 +6535,7 @@
             <a:r>
               <a:rPr sz="2400" b="1">
                 <a:solidFill>
-                  <a:srgbClr val="F1F5F9"/>
+                  <a:srgbClr val="F4F7FF"/>
                 </a:solidFill>
                 <a:latin typeface="Arial"/>
               </a:rPr>
@@ -6473,7 +6559,7 @@
             <a:avLst/>
           </a:prstGeom>
           <a:solidFill>
-            <a:srgbClr val="22D3EE"/>
+            <a:srgbClr val="38BDF8"/>
           </a:solidFill>
           <a:ln>
             <a:noFill/>
@@ -6516,11 +6602,11 @@
             <a:avLst/>
           </a:prstGeom>
           <a:solidFill>
-            <a:srgbClr val="0F172A"/>
+            <a:srgbClr val="0C162E"/>
           </a:solidFill>
           <a:ln>
             <a:solidFill>
-              <a:srgbClr val="22D3EE"/>
+              <a:srgbClr val="38BDF8"/>
             </a:solidFill>
           </a:ln>
         </p:spPr>
@@ -6550,7 +6636,7 @@
             <a:r>
               <a:rPr sz="1600" b="0">
                 <a:solidFill>
-                  <a:srgbClr val="E2E8F0"/>
+                  <a:srgbClr val="DDE6F4"/>
                 </a:solidFill>
                 <a:latin typeface="Arial"/>
               </a:rPr>
@@ -6589,7 +6675,7 @@
             <a:r>
               <a:rPr sz="1700" b="0">
                 <a:solidFill>
-                  <a:srgbClr val="E2E8F0"/>
+                  <a:srgbClr val="DDE6F4"/>
                 </a:solidFill>
                 <a:latin typeface="Arial"/>
               </a:rPr>
@@ -6605,7 +6691,7 @@
             <a:r>
               <a:rPr sz="1700" b="0">
                 <a:solidFill>
-                  <a:srgbClr val="E2E8F0"/>
+                  <a:srgbClr val="DDE6F4"/>
                 </a:solidFill>
                 <a:latin typeface="Arial"/>
               </a:rPr>
@@ -6621,7 +6707,7 @@
             <a:r>
               <a:rPr sz="1700" b="0">
                 <a:solidFill>
-                  <a:srgbClr val="E2E8F0"/>
+                  <a:srgbClr val="DDE6F4"/>
                 </a:solidFill>
                 <a:latin typeface="Arial"/>
               </a:rPr>
@@ -6637,7 +6723,7 @@
             <a:r>
               <a:rPr sz="1700" b="0">
                 <a:solidFill>
-                  <a:srgbClr val="E2E8F0"/>
+                  <a:srgbClr val="DDE6F4"/>
                 </a:solidFill>
                 <a:latin typeface="Arial"/>
               </a:rPr>
@@ -6661,11 +6747,11 @@
             <a:avLst/>
           </a:prstGeom>
           <a:solidFill>
-            <a:srgbClr val="030712"/>
+            <a:srgbClr val="060C1C"/>
           </a:solidFill>
           <a:ln>
             <a:solidFill>
-              <a:srgbClr val="22D3EE"/>
+              <a:srgbClr val="38BDF8"/>
             </a:solidFill>
           </a:ln>
         </p:spPr>
@@ -6691,7 +6777,7 @@
             <a:r>
               <a:rPr sz="1250" b="0">
                 <a:solidFill>
-                  <a:srgbClr val="C4FFEC"/>
+                  <a:srgbClr val="C5F4FF"/>
                 </a:solidFill>
                 <a:latin typeface="Courier New"/>
               </a:rPr>
@@ -6717,11 +6803,11 @@
             <a:avLst/>
           </a:prstGeom>
           <a:solidFill>
-            <a:srgbClr val="0D1426"/>
+            <a:srgbClr val="0F1830"/>
           </a:solidFill>
           <a:ln>
             <a:solidFill>
-              <a:srgbClr val="0D1426"/>
+              <a:srgbClr val="0F1830"/>
             </a:solidFill>
           </a:ln>
         </p:spPr>
@@ -6747,7 +6833,7 @@
             <a:r>
               <a:rPr sz="1000" b="1">
                 <a:solidFill>
-                  <a:srgbClr val="22D3EE"/>
+                  <a:srgbClr val="38BDF8"/>
                 </a:solidFill>
                 <a:latin typeface="Courier New"/>
               </a:rPr>
@@ -6782,7 +6868,7 @@
             <a:r>
               <a:rPr sz="1100" b="0">
                 <a:solidFill>
-                  <a:srgbClr val="94A3B8"/>
+                  <a:srgbClr val="899CBE"/>
                 </a:solidFill>
                 <a:latin typeface="Arial"/>
               </a:rPr>
@@ -6805,7 +6891,7 @@
     <p:bg>
       <p:bgPr>
         <a:solidFill>
-          <a:srgbClr val="020617"/>
+          <a:srgbClr val="040A18"/>
         </a:solidFill>
         <a:effectLst/>
       </p:bgPr>
@@ -6842,7 +6928,7 @@
             <a:r>
               <a:rPr sz="2400" b="1">
                 <a:solidFill>
-                  <a:srgbClr val="F1F5F9"/>
+                  <a:srgbClr val="F4F7FF"/>
                 </a:solidFill>
                 <a:latin typeface="Arial"/>
               </a:rPr>
@@ -6866,7 +6952,7 @@
             <a:avLst/>
           </a:prstGeom>
           <a:solidFill>
-            <a:srgbClr val="22D3EE"/>
+            <a:srgbClr val="38BDF8"/>
           </a:solidFill>
           <a:ln>
             <a:noFill/>
@@ -6909,11 +6995,11 @@
             <a:avLst/>
           </a:prstGeom>
           <a:solidFill>
-            <a:srgbClr val="0F172A"/>
+            <a:srgbClr val="0C162E"/>
           </a:solidFill>
           <a:ln>
             <a:solidFill>
-              <a:srgbClr val="22D3EE"/>
+              <a:srgbClr val="38BDF8"/>
             </a:solidFill>
           </a:ln>
         </p:spPr>
@@ -6943,7 +7029,7 @@
             <a:r>
               <a:rPr sz="1600" b="0">
                 <a:solidFill>
-                  <a:srgbClr val="E2E8F0"/>
+                  <a:srgbClr val="DDE6F4"/>
                 </a:solidFill>
                 <a:latin typeface="Arial"/>
               </a:rPr>
@@ -6982,7 +7068,7 @@
             <a:r>
               <a:rPr sz="1700" b="0">
                 <a:solidFill>
-                  <a:srgbClr val="E2E8F0"/>
+                  <a:srgbClr val="DDE6F4"/>
                 </a:solidFill>
                 <a:latin typeface="Arial"/>
               </a:rPr>
@@ -6998,7 +7084,7 @@
             <a:r>
               <a:rPr sz="1700" b="0">
                 <a:solidFill>
-                  <a:srgbClr val="E2E8F0"/>
+                  <a:srgbClr val="DDE6F4"/>
                 </a:solidFill>
                 <a:latin typeface="Arial"/>
               </a:rPr>
@@ -7014,7 +7100,7 @@
             <a:r>
               <a:rPr sz="1700" b="0">
                 <a:solidFill>
-                  <a:srgbClr val="E2E8F0"/>
+                  <a:srgbClr val="DDE6F4"/>
                 </a:solidFill>
                 <a:latin typeface="Arial"/>
               </a:rPr>
@@ -7030,7 +7116,7 @@
             <a:r>
               <a:rPr sz="1700" b="0">
                 <a:solidFill>
-                  <a:srgbClr val="E2E8F0"/>
+                  <a:srgbClr val="DDE6F4"/>
                 </a:solidFill>
                 <a:latin typeface="Arial"/>
               </a:rPr>
@@ -7046,7 +7132,7 @@
             <a:r>
               <a:rPr sz="1700" b="0">
                 <a:solidFill>
-                  <a:srgbClr val="E2E8F0"/>
+                  <a:srgbClr val="DDE6F4"/>
                 </a:solidFill>
                 <a:latin typeface="Arial"/>
               </a:rPr>
@@ -7062,7 +7148,7 @@
             <a:r>
               <a:rPr sz="1700" b="0">
                 <a:solidFill>
-                  <a:srgbClr val="E2E8F0"/>
+                  <a:srgbClr val="DDE6F4"/>
                 </a:solidFill>
                 <a:latin typeface="Arial"/>
               </a:rPr>
@@ -7085,7 +7171,7 @@
     <p:bg>
       <p:bgPr>
         <a:solidFill>
-          <a:srgbClr val="020617"/>
+          <a:srgbClr val="040A18"/>
         </a:solidFill>
         <a:effectLst/>
       </p:bgPr>
@@ -7122,7 +7208,7 @@
             <a:r>
               <a:rPr sz="2400" b="1">
                 <a:solidFill>
-                  <a:srgbClr val="F1F5F9"/>
+                  <a:srgbClr val="F4F7FF"/>
                 </a:solidFill>
                 <a:latin typeface="Arial"/>
               </a:rPr>
@@ -7156,7 +7242,7 @@
             <a:r>
               <a:rPr sz="1400" b="0">
                 <a:solidFill>
-                  <a:srgbClr val="94A3B8"/>
+                  <a:srgbClr val="899CBE"/>
                 </a:solidFill>
                 <a:latin typeface="Arial"/>
               </a:rPr>
@@ -7180,7 +7266,7 @@
             <a:avLst/>
           </a:prstGeom>
           <a:solidFill>
-            <a:srgbClr val="22D3EE"/>
+            <a:srgbClr val="38BDF8"/>
           </a:solidFill>
           <a:ln>
             <a:noFill/>
@@ -7223,11 +7309,11 @@
             <a:avLst/>
           </a:prstGeom>
           <a:solidFill>
-            <a:srgbClr val="0A1224"/>
+            <a:srgbClr val="091226"/>
           </a:solidFill>
           <a:ln w="22860">
             <a:solidFill>
-              <a:srgbClr val="22D3EE"/>
+              <a:srgbClr val="38BDF8"/>
             </a:solidFill>
           </a:ln>
         </p:spPr>
@@ -7253,7 +7339,7 @@
             <a:r>
               <a:rPr sz="2000" b="1">
                 <a:solidFill>
-                  <a:srgbClr val="22D3EE"/>
+                  <a:srgbClr val="38BDF8"/>
                 </a:solidFill>
                 <a:latin typeface="Arial"/>
               </a:rPr>
@@ -7269,7 +7355,7 @@
             <a:r>
               <a:rPr sz="1400" b="0">
                 <a:solidFill>
-                  <a:srgbClr val="E2E8F0"/>
+                  <a:srgbClr val="DDE6F4"/>
                 </a:solidFill>
                 <a:latin typeface="Arial"/>
               </a:rPr>
@@ -7294,11 +7380,11 @@
             <a:avLst/>
           </a:prstGeom>
           <a:solidFill>
-            <a:srgbClr val="0A1224"/>
+            <a:srgbClr val="091226"/>
           </a:solidFill>
           <a:ln w="22860">
             <a:solidFill>
-              <a:srgbClr val="22D3EE"/>
+              <a:srgbClr val="38BDF8"/>
             </a:solidFill>
           </a:ln>
         </p:spPr>
@@ -7324,7 +7410,7 @@
             <a:r>
               <a:rPr sz="2000" b="1">
                 <a:solidFill>
-                  <a:srgbClr val="22D3EE"/>
+                  <a:srgbClr val="38BDF8"/>
                 </a:solidFill>
                 <a:latin typeface="Arial"/>
               </a:rPr>
@@ -7340,7 +7426,7 @@
             <a:r>
               <a:rPr sz="1400" b="0">
                 <a:solidFill>
-                  <a:srgbClr val="E2E8F0"/>
+                  <a:srgbClr val="DDE6F4"/>
                 </a:solidFill>
                 <a:latin typeface="Arial"/>
               </a:rPr>
@@ -7365,11 +7451,11 @@
             <a:avLst/>
           </a:prstGeom>
           <a:solidFill>
-            <a:srgbClr val="0A1224"/>
+            <a:srgbClr val="091226"/>
           </a:solidFill>
           <a:ln w="22860">
             <a:solidFill>
-              <a:srgbClr val="22D3EE"/>
+              <a:srgbClr val="38BDF8"/>
             </a:solidFill>
           </a:ln>
         </p:spPr>
@@ -7395,7 +7481,7 @@
             <a:r>
               <a:rPr sz="2000" b="1">
                 <a:solidFill>
-                  <a:srgbClr val="22D3EE"/>
+                  <a:srgbClr val="38BDF8"/>
                 </a:solidFill>
                 <a:latin typeface="Arial"/>
               </a:rPr>
@@ -7411,7 +7497,7 @@
             <a:r>
               <a:rPr sz="1400" b="0">
                 <a:solidFill>
-                  <a:srgbClr val="E2E8F0"/>
+                  <a:srgbClr val="DDE6F4"/>
                 </a:solidFill>
                 <a:latin typeface="Arial"/>
               </a:rPr>
@@ -7436,11 +7522,11 @@
             <a:avLst/>
           </a:prstGeom>
           <a:solidFill>
-            <a:srgbClr val="0A1224"/>
+            <a:srgbClr val="091226"/>
           </a:solidFill>
           <a:ln w="22860">
             <a:solidFill>
-              <a:srgbClr val="22D3EE"/>
+              <a:srgbClr val="38BDF8"/>
             </a:solidFill>
           </a:ln>
         </p:spPr>
@@ -7466,7 +7552,7 @@
             <a:r>
               <a:rPr sz="2000" b="1">
                 <a:solidFill>
-                  <a:srgbClr val="22D3EE"/>
+                  <a:srgbClr val="38BDF8"/>
                 </a:solidFill>
                 <a:latin typeface="Arial"/>
               </a:rPr>
@@ -7482,7 +7568,7 @@
             <a:r>
               <a:rPr sz="1400" b="0">
                 <a:solidFill>
-                  <a:srgbClr val="E2E8F0"/>
+                  <a:srgbClr val="DDE6F4"/>
                 </a:solidFill>
                 <a:latin typeface="Arial"/>
               </a:rPr>
@@ -7507,11 +7593,11 @@
             <a:avLst/>
           </a:prstGeom>
           <a:solidFill>
-            <a:srgbClr val="0A1224"/>
+            <a:srgbClr val="091226"/>
           </a:solidFill>
           <a:ln w="22860">
             <a:solidFill>
-              <a:srgbClr val="22D3EE"/>
+              <a:srgbClr val="38BDF8"/>
             </a:solidFill>
           </a:ln>
         </p:spPr>
@@ -7537,7 +7623,7 @@
             <a:r>
               <a:rPr sz="2000" b="1">
                 <a:solidFill>
-                  <a:srgbClr val="22D3EE"/>
+                  <a:srgbClr val="38BDF8"/>
                 </a:solidFill>
                 <a:latin typeface="Arial"/>
               </a:rPr>
@@ -7553,7 +7639,7 @@
             <a:r>
               <a:rPr sz="1400" b="0">
                 <a:solidFill>
-                  <a:srgbClr val="E2E8F0"/>
+                  <a:srgbClr val="DDE6F4"/>
                 </a:solidFill>
                 <a:latin typeface="Arial"/>
               </a:rPr>
@@ -7578,7 +7664,7 @@
           </a:prstGeom>
           <a:ln w="15875">
             <a:solidFill>
-              <a:srgbClr val="22D3EE"/>
+              <a:srgbClr val="38BDF8"/>
             </a:solidFill>
           </a:ln>
         </p:spPr>
@@ -7613,7 +7699,7 @@
           </a:prstGeom>
           <a:ln w="15875">
             <a:solidFill>
-              <a:srgbClr val="22D3EE"/>
+              <a:srgbClr val="38BDF8"/>
             </a:solidFill>
           </a:ln>
         </p:spPr>
@@ -7648,7 +7734,7 @@
           </a:prstGeom>
           <a:ln w="15875">
             <a:solidFill>
-              <a:srgbClr val="22D3EE"/>
+              <a:srgbClr val="38BDF8"/>
             </a:solidFill>
           </a:ln>
         </p:spPr>
@@ -7683,7 +7769,7 @@
           </a:prstGeom>
           <a:ln w="15875">
             <a:solidFill>
-              <a:srgbClr val="22D3EE"/>
+              <a:srgbClr val="38BDF8"/>
             </a:solidFill>
           </a:ln>
         </p:spPr>
@@ -7717,11 +7803,11 @@
             <a:avLst/>
           </a:prstGeom>
           <a:solidFill>
-            <a:srgbClr val="0A1224"/>
+            <a:srgbClr val="091226"/>
           </a:solidFill>
           <a:ln w="22860">
             <a:solidFill>
-              <a:srgbClr val="22D3EE"/>
+              <a:srgbClr val="38BDF8"/>
             </a:solidFill>
           </a:ln>
         </p:spPr>
@@ -7747,7 +7833,7 @@
             <a:r>
               <a:rPr sz="2000" b="1">
                 <a:solidFill>
-                  <a:srgbClr val="22D3EE"/>
+                  <a:srgbClr val="38BDF8"/>
                 </a:solidFill>
                 <a:latin typeface="Arial"/>
               </a:rPr>
@@ -7763,7 +7849,7 @@
             <a:r>
               <a:rPr sz="1400" b="0">
                 <a:solidFill>
-                  <a:srgbClr val="E2E8F0"/>
+                  <a:srgbClr val="DDE6F4"/>
                 </a:solidFill>
                 <a:latin typeface="Arial"/>
               </a:rPr>
@@ -7788,11 +7874,11 @@
             <a:avLst/>
           </a:prstGeom>
           <a:solidFill>
-            <a:srgbClr val="0A1224"/>
+            <a:srgbClr val="091226"/>
           </a:solidFill>
           <a:ln w="22860">
             <a:solidFill>
-              <a:srgbClr val="22D3EE"/>
+              <a:srgbClr val="38BDF8"/>
             </a:solidFill>
           </a:ln>
         </p:spPr>
@@ -7818,7 +7904,7 @@
             <a:r>
               <a:rPr sz="2000" b="1">
                 <a:solidFill>
-                  <a:srgbClr val="22D3EE"/>
+                  <a:srgbClr val="38BDF8"/>
                 </a:solidFill>
                 <a:latin typeface="Arial"/>
               </a:rPr>
@@ -7834,7 +7920,7 @@
             <a:r>
               <a:rPr sz="1400" b="0">
                 <a:solidFill>
-                  <a:srgbClr val="E2E8F0"/>
+                  <a:srgbClr val="DDE6F4"/>
                 </a:solidFill>
                 <a:latin typeface="Arial"/>
               </a:rPr>
@@ -7859,11 +7945,11 @@
             <a:avLst/>
           </a:prstGeom>
           <a:solidFill>
-            <a:srgbClr val="0A1224"/>
+            <a:srgbClr val="091226"/>
           </a:solidFill>
           <a:ln w="22860">
             <a:solidFill>
-              <a:srgbClr val="22D3EE"/>
+              <a:srgbClr val="38BDF8"/>
             </a:solidFill>
           </a:ln>
         </p:spPr>
@@ -7889,7 +7975,7 @@
             <a:r>
               <a:rPr sz="2000" b="1">
                 <a:solidFill>
-                  <a:srgbClr val="22D3EE"/>
+                  <a:srgbClr val="38BDF8"/>
                 </a:solidFill>
                 <a:latin typeface="Arial"/>
               </a:rPr>
@@ -7905,7 +7991,7 @@
             <a:r>
               <a:rPr sz="1400" b="0">
                 <a:solidFill>
-                  <a:srgbClr val="E2E8F0"/>
+                  <a:srgbClr val="DDE6F4"/>
                 </a:solidFill>
                 <a:latin typeface="Arial"/>
               </a:rPr>
@@ -7930,7 +8016,7 @@
           </a:prstGeom>
           <a:ln w="15875">
             <a:solidFill>
-              <a:srgbClr val="22D3EE"/>
+              <a:srgbClr val="38BDF8"/>
             </a:solidFill>
           </a:ln>
         </p:spPr>
@@ -7965,7 +8051,7 @@
           </a:prstGeom>
           <a:ln w="15875">
             <a:solidFill>
-              <a:srgbClr val="22D3EE"/>
+              <a:srgbClr val="38BDF8"/>
             </a:solidFill>
           </a:ln>
         </p:spPr>
@@ -8000,7 +8086,7 @@
           </a:prstGeom>
           <a:ln w="15875">
             <a:solidFill>
-              <a:srgbClr val="22D3EE"/>
+              <a:srgbClr val="38BDF8"/>
             </a:solidFill>
           </a:ln>
         </p:spPr>
@@ -8034,11 +8120,11 @@
             <a:avLst/>
           </a:prstGeom>
           <a:solidFill>
-            <a:srgbClr val="0F172A"/>
+            <a:srgbClr val="0C162E"/>
           </a:solidFill>
           <a:ln>
             <a:solidFill>
-              <a:srgbClr val="22D3EE"/>
+              <a:srgbClr val="38BDF8"/>
             </a:solidFill>
           </a:ln>
         </p:spPr>
@@ -8068,7 +8154,7 @@
             <a:r>
               <a:rPr sz="1300" b="0">
                 <a:solidFill>
-                  <a:srgbClr val="E2E8F0"/>
+                  <a:srgbClr val="DDE6F4"/>
                 </a:solidFill>
                 <a:latin typeface="Arial"/>
               </a:rPr>
@@ -8091,7 +8177,7 @@
     <p:bg>
       <p:bgPr>
         <a:solidFill>
-          <a:srgbClr val="020617"/>
+          <a:srgbClr val="040A18"/>
         </a:solidFill>
         <a:effectLst/>
       </p:bgPr>
@@ -8128,7 +8214,7 @@
             <a:r>
               <a:rPr sz="2400" b="1">
                 <a:solidFill>
-                  <a:srgbClr val="F1F5F9"/>
+                  <a:srgbClr val="F4F7FF"/>
                 </a:solidFill>
                 <a:latin typeface="Arial"/>
               </a:rPr>
@@ -8152,7 +8238,7 @@
             <a:avLst/>
           </a:prstGeom>
           <a:solidFill>
-            <a:srgbClr val="22D3EE"/>
+            <a:srgbClr val="38BDF8"/>
           </a:solidFill>
           <a:ln>
             <a:noFill/>
@@ -8195,11 +8281,11 @@
             <a:avLst/>
           </a:prstGeom>
           <a:solidFill>
-            <a:srgbClr val="0F172A"/>
+            <a:srgbClr val="0C162E"/>
           </a:solidFill>
           <a:ln>
             <a:solidFill>
-              <a:srgbClr val="22D3EE"/>
+              <a:srgbClr val="38BDF8"/>
             </a:solidFill>
           </a:ln>
         </p:spPr>
@@ -8229,7 +8315,7 @@
             <a:r>
               <a:rPr sz="1600" b="0">
                 <a:solidFill>
-                  <a:srgbClr val="E2E8F0"/>
+                  <a:srgbClr val="DDE6F4"/>
                 </a:solidFill>
                 <a:latin typeface="Arial"/>
               </a:rPr>
@@ -8268,7 +8354,7 @@
             <a:r>
               <a:rPr sz="1700" b="0">
                 <a:solidFill>
-                  <a:srgbClr val="E2E8F0"/>
+                  <a:srgbClr val="DDE6F4"/>
                 </a:solidFill>
                 <a:latin typeface="Arial"/>
               </a:rPr>
@@ -8284,7 +8370,7 @@
             <a:r>
               <a:rPr sz="1700" b="0">
                 <a:solidFill>
-                  <a:srgbClr val="E2E8F0"/>
+                  <a:srgbClr val="DDE6F4"/>
                 </a:solidFill>
                 <a:latin typeface="Arial"/>
               </a:rPr>
@@ -8300,7 +8386,7 @@
             <a:r>
               <a:rPr sz="1700" b="0">
                 <a:solidFill>
-                  <a:srgbClr val="E2E8F0"/>
+                  <a:srgbClr val="DDE6F4"/>
                 </a:solidFill>
                 <a:latin typeface="Arial"/>
               </a:rPr>
@@ -8324,11 +8410,11 @@
             <a:avLst/>
           </a:prstGeom>
           <a:solidFill>
-            <a:srgbClr val="030712"/>
+            <a:srgbClr val="060C1C"/>
           </a:solidFill>
           <a:ln>
             <a:solidFill>
-              <a:srgbClr val="22D3EE"/>
+              <a:srgbClr val="38BDF8"/>
             </a:solidFill>
           </a:ln>
         </p:spPr>
@@ -8354,7 +8440,7 @@
             <a:r>
               <a:rPr sz="1250" b="0">
                 <a:solidFill>
-                  <a:srgbClr val="C4FFEC"/>
+                  <a:srgbClr val="C5F4FF"/>
                 </a:solidFill>
                 <a:latin typeface="Courier New"/>
               </a:rPr>
@@ -8378,11 +8464,11 @@
             <a:avLst/>
           </a:prstGeom>
           <a:solidFill>
-            <a:srgbClr val="0D1426"/>
+            <a:srgbClr val="0F1830"/>
           </a:solidFill>
           <a:ln>
             <a:solidFill>
-              <a:srgbClr val="0D1426"/>
+              <a:srgbClr val="0F1830"/>
             </a:solidFill>
           </a:ln>
         </p:spPr>
@@ -8408,7 +8494,7 @@
             <a:r>
               <a:rPr sz="1000" b="1">
                 <a:solidFill>
-                  <a:srgbClr val="22D3EE"/>
+                  <a:srgbClr val="38BDF8"/>
                 </a:solidFill>
                 <a:latin typeface="Courier New"/>
               </a:rPr>
@@ -8443,7 +8529,7 @@
             <a:r>
               <a:rPr sz="1100" b="0">
                 <a:solidFill>
-                  <a:srgbClr val="94A3B8"/>
+                  <a:srgbClr val="899CBE"/>
                 </a:solidFill>
                 <a:latin typeface="Arial"/>
               </a:rPr>
@@ -8466,7 +8552,7 @@
     <p:bg>
       <p:bgPr>
         <a:solidFill>
-          <a:srgbClr val="020617"/>
+          <a:srgbClr val="040A18"/>
         </a:solidFill>
         <a:effectLst/>
       </p:bgPr>
@@ -8503,7 +8589,7 @@
             <a:r>
               <a:rPr sz="2400" b="1">
                 <a:solidFill>
-                  <a:srgbClr val="F1F5F9"/>
+                  <a:srgbClr val="F4F7FF"/>
                 </a:solidFill>
                 <a:latin typeface="Arial"/>
               </a:rPr>
@@ -8537,7 +8623,7 @@
             <a:r>
               <a:rPr sz="1400" b="0">
                 <a:solidFill>
-                  <a:srgbClr val="94A3B8"/>
+                  <a:srgbClr val="899CBE"/>
                 </a:solidFill>
                 <a:latin typeface="Arial"/>
               </a:rPr>
@@ -8561,7 +8647,7 @@
             <a:avLst/>
           </a:prstGeom>
           <a:solidFill>
-            <a:srgbClr val="22D3EE"/>
+            <a:srgbClr val="38BDF8"/>
           </a:solidFill>
           <a:ln>
             <a:noFill/>
@@ -8604,11 +8690,11 @@
             <a:avLst/>
           </a:prstGeom>
           <a:solidFill>
-            <a:srgbClr val="0A1224"/>
+            <a:srgbClr val="091226"/>
           </a:solidFill>
           <a:ln>
             <a:solidFill>
-              <a:srgbClr val="22D3EE"/>
+              <a:srgbClr val="38BDF8"/>
             </a:solidFill>
           </a:ln>
         </p:spPr>
@@ -8649,11 +8735,11 @@
             <a:avLst/>
           </a:prstGeom>
           <a:solidFill>
-            <a:srgbClr val="0C1E38"/>
+            <a:srgbClr val="0F1F3C"/>
           </a:solidFill>
           <a:ln>
             <a:solidFill>
-              <a:srgbClr val="0C1E38"/>
+              <a:srgbClr val="0F1F3C"/>
             </a:solidFill>
           </a:ln>
         </p:spPr>
@@ -8679,7 +8765,7 @@
             <a:r>
               <a:rPr sz="1200" b="1">
                 <a:solidFill>
-                  <a:srgbClr val="22D3EE"/>
+                  <a:srgbClr val="38BDF8"/>
                 </a:solidFill>
                 <a:latin typeface="Arial"/>
               </a:rPr>
@@ -8718,7 +8804,7 @@
             <a:r>
               <a:rPr sz="1400" b="0">
                 <a:solidFill>
-                  <a:srgbClr val="E2E8F0"/>
+                  <a:srgbClr val="DDE6F4"/>
                 </a:solidFill>
                 <a:latin typeface="Arial"/>
               </a:rPr>
@@ -8734,7 +8820,7 @@
             <a:r>
               <a:rPr sz="1400" b="0">
                 <a:solidFill>
-                  <a:srgbClr val="E2E8F0"/>
+                  <a:srgbClr val="DDE6F4"/>
                 </a:solidFill>
                 <a:latin typeface="Arial"/>
               </a:rPr>
@@ -8758,11 +8844,11 @@
             <a:avLst/>
           </a:prstGeom>
           <a:solidFill>
-            <a:srgbClr val="0A1224"/>
+            <a:srgbClr val="091226"/>
           </a:solidFill>
           <a:ln>
             <a:solidFill>
-              <a:srgbClr val="22D3EE"/>
+              <a:srgbClr val="38BDF8"/>
             </a:solidFill>
           </a:ln>
         </p:spPr>
@@ -8803,11 +8889,11 @@
             <a:avLst/>
           </a:prstGeom>
           <a:solidFill>
-            <a:srgbClr val="0C1E38"/>
+            <a:srgbClr val="0F1F3C"/>
           </a:solidFill>
           <a:ln>
             <a:solidFill>
-              <a:srgbClr val="0C1E38"/>
+              <a:srgbClr val="0F1F3C"/>
             </a:solidFill>
           </a:ln>
         </p:spPr>
@@ -8833,7 +8919,7 @@
             <a:r>
               <a:rPr sz="1200" b="1">
                 <a:solidFill>
-                  <a:srgbClr val="22D3EE"/>
+                  <a:srgbClr val="38BDF8"/>
                 </a:solidFill>
                 <a:latin typeface="Arial"/>
               </a:rPr>
@@ -8872,7 +8958,7 @@
             <a:r>
               <a:rPr sz="1400" b="0">
                 <a:solidFill>
-                  <a:srgbClr val="E2E8F0"/>
+                  <a:srgbClr val="DDE6F4"/>
                 </a:solidFill>
                 <a:latin typeface="Arial"/>
               </a:rPr>
@@ -8888,7 +8974,7 @@
             <a:r>
               <a:rPr sz="1400" b="0">
                 <a:solidFill>
-                  <a:srgbClr val="E2E8F0"/>
+                  <a:srgbClr val="DDE6F4"/>
                 </a:solidFill>
                 <a:latin typeface="Arial"/>
               </a:rPr>
@@ -8912,11 +8998,11 @@
             <a:avLst/>
           </a:prstGeom>
           <a:solidFill>
-            <a:srgbClr val="0A1224"/>
+            <a:srgbClr val="091226"/>
           </a:solidFill>
           <a:ln>
             <a:solidFill>
-              <a:srgbClr val="22D3EE"/>
+              <a:srgbClr val="38BDF8"/>
             </a:solidFill>
           </a:ln>
         </p:spPr>
@@ -8957,11 +9043,11 @@
             <a:avLst/>
           </a:prstGeom>
           <a:solidFill>
-            <a:srgbClr val="0C1E38"/>
+            <a:srgbClr val="0F1F3C"/>
           </a:solidFill>
           <a:ln>
             <a:solidFill>
-              <a:srgbClr val="0C1E38"/>
+              <a:srgbClr val="0F1F3C"/>
             </a:solidFill>
           </a:ln>
         </p:spPr>
@@ -8987,7 +9073,7 @@
             <a:r>
               <a:rPr sz="1200" b="1">
                 <a:solidFill>
-                  <a:srgbClr val="22D3EE"/>
+                  <a:srgbClr val="38BDF8"/>
                 </a:solidFill>
                 <a:latin typeface="Arial"/>
               </a:rPr>
@@ -9026,7 +9112,7 @@
             <a:r>
               <a:rPr sz="1400" b="0">
                 <a:solidFill>
-                  <a:srgbClr val="E2E8F0"/>
+                  <a:srgbClr val="DDE6F4"/>
                 </a:solidFill>
                 <a:latin typeface="Arial"/>
               </a:rPr>
@@ -9042,7 +9128,7 @@
             <a:r>
               <a:rPr sz="1400" b="0">
                 <a:solidFill>
-                  <a:srgbClr val="E2E8F0"/>
+                  <a:srgbClr val="DDE6F4"/>
                 </a:solidFill>
                 <a:latin typeface="Arial"/>
               </a:rPr>
@@ -9066,11 +9152,11 @@
             <a:avLst/>
           </a:prstGeom>
           <a:solidFill>
-            <a:srgbClr val="0A1224"/>
+            <a:srgbClr val="091226"/>
           </a:solidFill>
           <a:ln>
             <a:solidFill>
-              <a:srgbClr val="22D3EE"/>
+              <a:srgbClr val="38BDF8"/>
             </a:solidFill>
           </a:ln>
         </p:spPr>
@@ -9111,11 +9197,11 @@
             <a:avLst/>
           </a:prstGeom>
           <a:solidFill>
-            <a:srgbClr val="0C1E38"/>
+            <a:srgbClr val="0F1F3C"/>
           </a:solidFill>
           <a:ln>
             <a:solidFill>
-              <a:srgbClr val="0C1E38"/>
+              <a:srgbClr val="0F1F3C"/>
             </a:solidFill>
           </a:ln>
         </p:spPr>
@@ -9141,7 +9227,7 @@
             <a:r>
               <a:rPr sz="1200" b="1">
                 <a:solidFill>
-                  <a:srgbClr val="22D3EE"/>
+                  <a:srgbClr val="38BDF8"/>
                 </a:solidFill>
                 <a:latin typeface="Arial"/>
               </a:rPr>
@@ -9180,7 +9266,7 @@
             <a:r>
               <a:rPr sz="1400" b="0">
                 <a:solidFill>
-                  <a:srgbClr val="E2E8F0"/>
+                  <a:srgbClr val="DDE6F4"/>
                 </a:solidFill>
                 <a:latin typeface="Arial"/>
               </a:rPr>
@@ -9196,7 +9282,7 @@
             <a:r>
               <a:rPr sz="1400" b="0">
                 <a:solidFill>
-                  <a:srgbClr val="E2E8F0"/>
+                  <a:srgbClr val="DDE6F4"/>
                 </a:solidFill>
                 <a:latin typeface="Arial"/>
               </a:rPr>
@@ -9220,11 +9306,11 @@
             <a:avLst/>
           </a:prstGeom>
           <a:solidFill>
-            <a:srgbClr val="0A1224"/>
+            <a:srgbClr val="091226"/>
           </a:solidFill>
           <a:ln>
             <a:solidFill>
-              <a:srgbClr val="22D3EE"/>
+              <a:srgbClr val="38BDF8"/>
             </a:solidFill>
           </a:ln>
         </p:spPr>
@@ -9265,11 +9351,11 @@
             <a:avLst/>
           </a:prstGeom>
           <a:solidFill>
-            <a:srgbClr val="0C1E38"/>
+            <a:srgbClr val="0F1F3C"/>
           </a:solidFill>
           <a:ln>
             <a:solidFill>
-              <a:srgbClr val="0C1E38"/>
+              <a:srgbClr val="0F1F3C"/>
             </a:solidFill>
           </a:ln>
         </p:spPr>
@@ -9295,7 +9381,7 @@
             <a:r>
               <a:rPr sz="1200" b="1">
                 <a:solidFill>
-                  <a:srgbClr val="22D3EE"/>
+                  <a:srgbClr val="38BDF8"/>
                 </a:solidFill>
                 <a:latin typeface="Arial"/>
               </a:rPr>
@@ -9334,7 +9420,7 @@
             <a:r>
               <a:rPr sz="1400" b="0">
                 <a:solidFill>
-                  <a:srgbClr val="E2E8F0"/>
+                  <a:srgbClr val="DDE6F4"/>
                 </a:solidFill>
                 <a:latin typeface="Arial"/>
               </a:rPr>
@@ -9350,7 +9436,7 @@
             <a:r>
               <a:rPr sz="1400" b="0">
                 <a:solidFill>
-                  <a:srgbClr val="E2E8F0"/>
+                  <a:srgbClr val="DDE6F4"/>
                 </a:solidFill>
                 <a:latin typeface="Arial"/>
               </a:rPr>
@@ -9374,11 +9460,11 @@
             <a:avLst/>
           </a:prstGeom>
           <a:solidFill>
-            <a:srgbClr val="0A1224"/>
+            <a:srgbClr val="091226"/>
           </a:solidFill>
           <a:ln>
             <a:solidFill>
-              <a:srgbClr val="22D3EE"/>
+              <a:srgbClr val="38BDF8"/>
             </a:solidFill>
           </a:ln>
         </p:spPr>
@@ -9419,11 +9505,11 @@
             <a:avLst/>
           </a:prstGeom>
           <a:solidFill>
-            <a:srgbClr val="0C1E38"/>
+            <a:srgbClr val="0F1F3C"/>
           </a:solidFill>
           <a:ln>
             <a:solidFill>
-              <a:srgbClr val="0C1E38"/>
+              <a:srgbClr val="0F1F3C"/>
             </a:solidFill>
           </a:ln>
         </p:spPr>
@@ -9449,7 +9535,7 @@
             <a:r>
               <a:rPr sz="1200" b="1">
                 <a:solidFill>
-                  <a:srgbClr val="22D3EE"/>
+                  <a:srgbClr val="38BDF8"/>
                 </a:solidFill>
                 <a:latin typeface="Arial"/>
               </a:rPr>
@@ -9488,7 +9574,7 @@
             <a:r>
               <a:rPr sz="1400" b="0">
                 <a:solidFill>
-                  <a:srgbClr val="E2E8F0"/>
+                  <a:srgbClr val="DDE6F4"/>
                 </a:solidFill>
                 <a:latin typeface="Arial"/>
               </a:rPr>
@@ -9504,7 +9590,7 @@
             <a:r>
               <a:rPr sz="1400" b="0">
                 <a:solidFill>
-                  <a:srgbClr val="E2E8F0"/>
+                  <a:srgbClr val="DDE6F4"/>
                 </a:solidFill>
                 <a:latin typeface="Arial"/>
               </a:rPr>
@@ -9528,11 +9614,11 @@
             <a:avLst/>
           </a:prstGeom>
           <a:solidFill>
-            <a:srgbClr val="0A1224"/>
+            <a:srgbClr val="091226"/>
           </a:solidFill>
           <a:ln>
             <a:solidFill>
-              <a:srgbClr val="22D3EE"/>
+              <a:srgbClr val="38BDF8"/>
             </a:solidFill>
           </a:ln>
         </p:spPr>
@@ -9573,11 +9659,11 @@
             <a:avLst/>
           </a:prstGeom>
           <a:solidFill>
-            <a:srgbClr val="0C1E38"/>
+            <a:srgbClr val="0F1F3C"/>
           </a:solidFill>
           <a:ln>
             <a:solidFill>
-              <a:srgbClr val="0C1E38"/>
+              <a:srgbClr val="0F1F3C"/>
             </a:solidFill>
           </a:ln>
         </p:spPr>
@@ -9603,7 +9689,7 @@
             <a:r>
               <a:rPr sz="1200" b="1">
                 <a:solidFill>
-                  <a:srgbClr val="22D3EE"/>
+                  <a:srgbClr val="38BDF8"/>
                 </a:solidFill>
                 <a:latin typeface="Arial"/>
               </a:rPr>
@@ -9642,7 +9728,7 @@
             <a:r>
               <a:rPr sz="1400" b="0">
                 <a:solidFill>
-                  <a:srgbClr val="E2E8F0"/>
+                  <a:srgbClr val="DDE6F4"/>
                 </a:solidFill>
                 <a:latin typeface="Arial"/>
               </a:rPr>
@@ -9658,7 +9744,7 @@
             <a:r>
               <a:rPr sz="1400" b="0">
                 <a:solidFill>
-                  <a:srgbClr val="E2E8F0"/>
+                  <a:srgbClr val="DDE6F4"/>
                 </a:solidFill>
                 <a:latin typeface="Arial"/>
               </a:rPr>
@@ -9683,7 +9769,7 @@
           </a:prstGeom>
           <a:ln w="15875">
             <a:solidFill>
-              <a:srgbClr val="22D3EE"/>
+              <a:srgbClr val="38BDF8"/>
             </a:solidFill>
           </a:ln>
         </p:spPr>
@@ -9718,7 +9804,7 @@
           </a:prstGeom>
           <a:ln w="15875">
             <a:solidFill>
-              <a:srgbClr val="22D3EE"/>
+              <a:srgbClr val="38BDF8"/>
             </a:solidFill>
           </a:ln>
         </p:spPr>
@@ -9753,7 +9839,7 @@
           </a:prstGeom>
           <a:ln w="15875">
             <a:solidFill>
-              <a:srgbClr val="22D3EE"/>
+              <a:srgbClr val="38BDF8"/>
             </a:solidFill>
           </a:ln>
         </p:spPr>
@@ -9788,7 +9874,7 @@
           </a:prstGeom>
           <a:ln w="15875">
             <a:solidFill>
-              <a:srgbClr val="22D3EE"/>
+              <a:srgbClr val="38BDF8"/>
             </a:solidFill>
           </a:ln>
         </p:spPr>
@@ -9823,7 +9909,7 @@
           </a:prstGeom>
           <a:ln w="15875">
             <a:solidFill>
-              <a:srgbClr val="22D3EE"/>
+              <a:srgbClr val="38BDF8"/>
             </a:solidFill>
           </a:ln>
         </p:spPr>
@@ -9858,7 +9944,7 @@
           </a:prstGeom>
           <a:ln w="15875">
             <a:solidFill>
-              <a:srgbClr val="22D3EE"/>
+              <a:srgbClr val="38BDF8"/>
             </a:solidFill>
           </a:ln>
         </p:spPr>
@@ -9892,11 +9978,11 @@
             <a:avLst/>
           </a:prstGeom>
           <a:solidFill>
-            <a:srgbClr val="0F172A"/>
+            <a:srgbClr val="0C162E"/>
           </a:solidFill>
           <a:ln>
             <a:solidFill>
-              <a:srgbClr val="22D3EE"/>
+              <a:srgbClr val="38BDF8"/>
             </a:solidFill>
           </a:ln>
         </p:spPr>
@@ -9926,7 +10012,7 @@
             <a:r>
               <a:rPr sz="1500" b="0">
                 <a:solidFill>
-                  <a:srgbClr val="E2E8F0"/>
+                  <a:srgbClr val="DDE6F4"/>
                 </a:solidFill>
                 <a:latin typeface="Arial"/>
               </a:rPr>
@@ -9961,7 +10047,7 @@
             <a:r>
               <a:rPr sz="1100" b="0">
                 <a:solidFill>
-                  <a:srgbClr val="94A3B8"/>
+                  <a:srgbClr val="899CBE"/>
                 </a:solidFill>
                 <a:latin typeface="Arial"/>
               </a:rPr>
@@ -9984,7 +10070,7 @@
     <p:bg>
       <p:bgPr>
         <a:solidFill>
-          <a:srgbClr val="020617"/>
+          <a:srgbClr val="040A18"/>
         </a:solidFill>
         <a:effectLst/>
       </p:bgPr>
@@ -10021,7 +10107,7 @@
             <a:r>
               <a:rPr sz="2400" b="1">
                 <a:solidFill>
-                  <a:srgbClr val="F1F5F9"/>
+                  <a:srgbClr val="F4F7FF"/>
                 </a:solidFill>
                 <a:latin typeface="Arial"/>
               </a:rPr>
@@ -10055,7 +10141,7 @@
             <a:r>
               <a:rPr sz="1400" b="0">
                 <a:solidFill>
-                  <a:srgbClr val="94A3B8"/>
+                  <a:srgbClr val="899CBE"/>
                 </a:solidFill>
                 <a:latin typeface="Arial"/>
               </a:rPr>
@@ -10079,7 +10165,7 @@
             <a:avLst/>
           </a:prstGeom>
           <a:solidFill>
-            <a:srgbClr val="22D3EE"/>
+            <a:srgbClr val="38BDF8"/>
           </a:solidFill>
           <a:ln>
             <a:noFill/>
@@ -10122,11 +10208,11 @@
             <a:avLst/>
           </a:prstGeom>
           <a:solidFill>
-            <a:srgbClr val="0A1224"/>
+            <a:srgbClr val="091226"/>
           </a:solidFill>
           <a:ln w="22860">
             <a:solidFill>
-              <a:srgbClr val="22D3EE"/>
+              <a:srgbClr val="38BDF8"/>
             </a:solidFill>
           </a:ln>
         </p:spPr>
@@ -10152,7 +10238,7 @@
             <a:r>
               <a:rPr sz="2000" b="1">
                 <a:solidFill>
-                  <a:srgbClr val="22D3EE"/>
+                  <a:srgbClr val="38BDF8"/>
                 </a:solidFill>
                 <a:latin typeface="Arial"/>
               </a:rPr>
@@ -10168,7 +10254,7 @@
             <a:r>
               <a:rPr sz="1400" b="0">
                 <a:solidFill>
-                  <a:srgbClr val="E2E8F0"/>
+                  <a:srgbClr val="DDE6F4"/>
                 </a:solidFill>
                 <a:latin typeface="Arial"/>
               </a:rPr>
@@ -10193,7 +10279,7 @@
           </a:prstGeom>
           <a:ln w="15240">
             <a:solidFill>
-              <a:srgbClr val="1E293B"/>
+              <a:srgbClr val="192848"/>
             </a:solidFill>
           </a:ln>
         </p:spPr>
@@ -10227,11 +10313,11 @@
             <a:avLst/>
           </a:prstGeom>
           <a:solidFill>
-            <a:srgbClr val="0A1224"/>
+            <a:srgbClr val="091226"/>
           </a:solidFill>
           <a:ln w="22860">
             <a:solidFill>
-              <a:srgbClr val="22D3EE"/>
+              <a:srgbClr val="38BDF8"/>
             </a:solidFill>
           </a:ln>
         </p:spPr>
@@ -10257,7 +10343,7 @@
             <a:r>
               <a:rPr sz="2000" b="1">
                 <a:solidFill>
-                  <a:srgbClr val="22D3EE"/>
+                  <a:srgbClr val="38BDF8"/>
                 </a:solidFill>
                 <a:latin typeface="Arial"/>
               </a:rPr>
@@ -10273,7 +10359,7 @@
             <a:r>
               <a:rPr sz="1400" b="0">
                 <a:solidFill>
-                  <a:srgbClr val="E2E8F0"/>
+                  <a:srgbClr val="DDE6F4"/>
                 </a:solidFill>
                 <a:latin typeface="Arial"/>
               </a:rPr>
@@ -10298,7 +10384,7 @@
           </a:prstGeom>
           <a:ln w="15240">
             <a:solidFill>
-              <a:srgbClr val="1E293B"/>
+              <a:srgbClr val="192848"/>
             </a:solidFill>
           </a:ln>
         </p:spPr>
@@ -10332,11 +10418,11 @@
             <a:avLst/>
           </a:prstGeom>
           <a:solidFill>
-            <a:srgbClr val="0A1224"/>
+            <a:srgbClr val="091226"/>
           </a:solidFill>
           <a:ln w="22860">
             <a:solidFill>
-              <a:srgbClr val="22D3EE"/>
+              <a:srgbClr val="38BDF8"/>
             </a:solidFill>
           </a:ln>
         </p:spPr>
@@ -10362,7 +10448,7 @@
             <a:r>
               <a:rPr sz="2000" b="1">
                 <a:solidFill>
-                  <a:srgbClr val="22D3EE"/>
+                  <a:srgbClr val="38BDF8"/>
                 </a:solidFill>
                 <a:latin typeface="Arial"/>
               </a:rPr>
@@ -10378,7 +10464,7 @@
             <a:r>
               <a:rPr sz="1400" b="0">
                 <a:solidFill>
-                  <a:srgbClr val="E2E8F0"/>
+                  <a:srgbClr val="DDE6F4"/>
                 </a:solidFill>
                 <a:latin typeface="Arial"/>
               </a:rPr>
@@ -10403,7 +10489,7 @@
           </a:prstGeom>
           <a:ln w="15240">
             <a:solidFill>
-              <a:srgbClr val="1E293B"/>
+              <a:srgbClr val="192848"/>
             </a:solidFill>
           </a:ln>
         </p:spPr>
@@ -10437,11 +10523,11 @@
             <a:avLst/>
           </a:prstGeom>
           <a:solidFill>
-            <a:srgbClr val="0A1224"/>
+            <a:srgbClr val="091226"/>
           </a:solidFill>
           <a:ln w="22860">
             <a:solidFill>
-              <a:srgbClr val="22D3EE"/>
+              <a:srgbClr val="38BDF8"/>
             </a:solidFill>
           </a:ln>
         </p:spPr>
@@ -10467,7 +10553,7 @@
             <a:r>
               <a:rPr sz="2000" b="1">
                 <a:solidFill>
-                  <a:srgbClr val="22D3EE"/>
+                  <a:srgbClr val="38BDF8"/>
                 </a:solidFill>
                 <a:latin typeface="Arial"/>
               </a:rPr>
@@ -10483,7 +10569,7 @@
             <a:r>
               <a:rPr sz="1400" b="0">
                 <a:solidFill>
-                  <a:srgbClr val="E2E8F0"/>
+                  <a:srgbClr val="DDE6F4"/>
                 </a:solidFill>
                 <a:latin typeface="Arial"/>
               </a:rPr>
@@ -10508,7 +10594,7 @@
           </a:prstGeom>
           <a:ln w="15240">
             <a:solidFill>
-              <a:srgbClr val="1E293B"/>
+              <a:srgbClr val="192848"/>
             </a:solidFill>
           </a:ln>
         </p:spPr>
@@ -10542,11 +10628,11 @@
             <a:avLst/>
           </a:prstGeom>
           <a:solidFill>
-            <a:srgbClr val="0A1224"/>
+            <a:srgbClr val="091226"/>
           </a:solidFill>
           <a:ln w="22860">
             <a:solidFill>
-              <a:srgbClr val="22D3EE"/>
+              <a:srgbClr val="38BDF8"/>
             </a:solidFill>
           </a:ln>
         </p:spPr>
@@ -10572,7 +10658,7 @@
             <a:r>
               <a:rPr sz="2000" b="1">
                 <a:solidFill>
-                  <a:srgbClr val="22D3EE"/>
+                  <a:srgbClr val="38BDF8"/>
                 </a:solidFill>
                 <a:latin typeface="Arial"/>
               </a:rPr>
@@ -10588,7 +10674,7 @@
             <a:r>
               <a:rPr sz="1400" b="0">
                 <a:solidFill>
-                  <a:srgbClr val="E2E8F0"/>
+                  <a:srgbClr val="DDE6F4"/>
                 </a:solidFill>
                 <a:latin typeface="Arial"/>
               </a:rPr>
@@ -10613,7 +10699,7 @@
           </a:prstGeom>
           <a:ln w="15240">
             <a:solidFill>
-              <a:srgbClr val="1E293B"/>
+              <a:srgbClr val="192848"/>
             </a:solidFill>
           </a:ln>
         </p:spPr>
@@ -10648,7 +10734,7 @@
           </a:prstGeom>
           <a:ln w="15875">
             <a:solidFill>
-              <a:srgbClr val="22D3EE"/>
+              <a:srgbClr val="38BDF8"/>
             </a:solidFill>
           </a:ln>
         </p:spPr>
@@ -10682,11 +10768,11 @@
             <a:avLst/>
           </a:prstGeom>
           <a:solidFill>
-            <a:srgbClr val="0C1E38"/>
+            <a:srgbClr val="0F1F3C"/>
           </a:solidFill>
           <a:ln>
             <a:solidFill>
-              <a:srgbClr val="22D3EE"/>
+              <a:srgbClr val="38BDF8"/>
             </a:solidFill>
           </a:ln>
         </p:spPr>
@@ -10716,7 +10802,7 @@
             <a:r>
               <a:rPr sz="1150" b="0">
                 <a:solidFill>
-                  <a:srgbClr val="E2E8F0"/>
+                  <a:srgbClr val="DDE6F4"/>
                 </a:solidFill>
                 <a:latin typeface="Arial"/>
               </a:rPr>
@@ -10741,7 +10827,7 @@
           </a:prstGeom>
           <a:ln w="15875">
             <a:solidFill>
-              <a:srgbClr val="22D3EE"/>
+              <a:srgbClr val="38BDF8"/>
             </a:solidFill>
           </a:ln>
         </p:spPr>
@@ -10775,11 +10861,11 @@
             <a:avLst/>
           </a:prstGeom>
           <a:solidFill>
-            <a:srgbClr val="0C1E38"/>
+            <a:srgbClr val="0F1F3C"/>
           </a:solidFill>
           <a:ln>
             <a:solidFill>
-              <a:srgbClr val="22D3EE"/>
+              <a:srgbClr val="38BDF8"/>
             </a:solidFill>
           </a:ln>
         </p:spPr>
@@ -10809,7 +10895,7 @@
             <a:r>
               <a:rPr sz="1150" b="0">
                 <a:solidFill>
-                  <a:srgbClr val="E2E8F0"/>
+                  <a:srgbClr val="DDE6F4"/>
                 </a:solidFill>
                 <a:latin typeface="Arial"/>
               </a:rPr>
@@ -10834,7 +10920,7 @@
           </a:prstGeom>
           <a:ln w="15875">
             <a:solidFill>
-              <a:srgbClr val="22D3EE"/>
+              <a:srgbClr val="38BDF8"/>
             </a:solidFill>
           </a:ln>
         </p:spPr>
@@ -10868,11 +10954,11 @@
             <a:avLst/>
           </a:prstGeom>
           <a:solidFill>
-            <a:srgbClr val="0C1E38"/>
+            <a:srgbClr val="0F1F3C"/>
           </a:solidFill>
           <a:ln>
             <a:solidFill>
-              <a:srgbClr val="22D3EE"/>
+              <a:srgbClr val="38BDF8"/>
             </a:solidFill>
           </a:ln>
         </p:spPr>
@@ -10902,7 +10988,7 @@
             <a:r>
               <a:rPr sz="1150" b="0">
                 <a:solidFill>
-                  <a:srgbClr val="E2E8F0"/>
+                  <a:srgbClr val="DDE6F4"/>
                 </a:solidFill>
                 <a:latin typeface="Arial"/>
               </a:rPr>
@@ -10927,7 +11013,7 @@
           </a:prstGeom>
           <a:ln w="15875">
             <a:solidFill>
-              <a:srgbClr val="22D3EE"/>
+              <a:srgbClr val="38BDF8"/>
             </a:solidFill>
           </a:ln>
         </p:spPr>
@@ -10961,11 +11047,11 @@
             <a:avLst/>
           </a:prstGeom>
           <a:solidFill>
-            <a:srgbClr val="0C1E38"/>
+            <a:srgbClr val="0F1F3C"/>
           </a:solidFill>
           <a:ln>
             <a:solidFill>
-              <a:srgbClr val="22D3EE"/>
+              <a:srgbClr val="38BDF8"/>
             </a:solidFill>
           </a:ln>
         </p:spPr>
@@ -10995,7 +11081,7 @@
             <a:r>
               <a:rPr sz="1150" b="0">
                 <a:solidFill>
-                  <a:srgbClr val="E2E8F0"/>
+                  <a:srgbClr val="DDE6F4"/>
                 </a:solidFill>
                 <a:latin typeface="Arial"/>
               </a:rPr>
@@ -11020,7 +11106,7 @@
           </a:prstGeom>
           <a:ln w="15875">
             <a:solidFill>
-              <a:srgbClr val="22D3EE"/>
+              <a:srgbClr val="38BDF8"/>
             </a:solidFill>
           </a:ln>
         </p:spPr>
@@ -11054,11 +11140,11 @@
             <a:avLst/>
           </a:prstGeom>
           <a:solidFill>
-            <a:srgbClr val="0C1E38"/>
+            <a:srgbClr val="0F1F3C"/>
           </a:solidFill>
           <a:ln>
             <a:solidFill>
-              <a:srgbClr val="22D3EE"/>
+              <a:srgbClr val="38BDF8"/>
             </a:solidFill>
           </a:ln>
         </p:spPr>
@@ -11088,7 +11174,7 @@
             <a:r>
               <a:rPr sz="1150" b="0">
                 <a:solidFill>
-                  <a:srgbClr val="E2E8F0"/>
+                  <a:srgbClr val="DDE6F4"/>
                 </a:solidFill>
                 <a:latin typeface="Arial"/>
               </a:rPr>
@@ -11113,7 +11199,7 @@
           </a:prstGeom>
           <a:ln w="15875">
             <a:solidFill>
-              <a:srgbClr val="22D3EE"/>
+              <a:srgbClr val="38BDF8"/>
             </a:solidFill>
           </a:ln>
         </p:spPr>
@@ -11147,11 +11233,11 @@
             <a:avLst/>
           </a:prstGeom>
           <a:solidFill>
-            <a:srgbClr val="0C1E38"/>
+            <a:srgbClr val="0F1F3C"/>
           </a:solidFill>
           <a:ln>
             <a:solidFill>
-              <a:srgbClr val="22D3EE"/>
+              <a:srgbClr val="38BDF8"/>
             </a:solidFill>
           </a:ln>
         </p:spPr>
@@ -11181,7 +11267,7 @@
             <a:r>
               <a:rPr sz="1150" b="0">
                 <a:solidFill>
-                  <a:srgbClr val="E2E8F0"/>
+                  <a:srgbClr val="DDE6F4"/>
                 </a:solidFill>
                 <a:latin typeface="Arial"/>
               </a:rPr>
@@ -11205,11 +11291,11 @@
             <a:avLst/>
           </a:prstGeom>
           <a:solidFill>
-            <a:srgbClr val="0F172A"/>
+            <a:srgbClr val="0C162E"/>
           </a:solidFill>
           <a:ln>
             <a:solidFill>
-              <a:srgbClr val="22D3EE"/>
+              <a:srgbClr val="38BDF8"/>
             </a:solidFill>
           </a:ln>
         </p:spPr>
@@ -11239,7 +11325,7 @@
             <a:r>
               <a:rPr sz="1300" b="0">
                 <a:solidFill>
-                  <a:srgbClr val="E2E8F0"/>
+                  <a:srgbClr val="DDE6F4"/>
                 </a:solidFill>
                 <a:latin typeface="Arial"/>
               </a:rPr>
@@ -11262,7 +11348,7 @@
     <p:bg>
       <p:bgPr>
         <a:solidFill>
-          <a:srgbClr val="020617"/>
+          <a:srgbClr val="040A18"/>
         </a:solidFill>
         <a:effectLst/>
       </p:bgPr>
@@ -11299,7 +11385,7 @@
             <a:r>
               <a:rPr sz="2400" b="1">
                 <a:solidFill>
-                  <a:srgbClr val="F1F5F9"/>
+                  <a:srgbClr val="F4F7FF"/>
                 </a:solidFill>
                 <a:latin typeface="Arial"/>
               </a:rPr>
@@ -11323,7 +11409,7 @@
             <a:avLst/>
           </a:prstGeom>
           <a:solidFill>
-            <a:srgbClr val="22D3EE"/>
+            <a:srgbClr val="38BDF8"/>
           </a:solidFill>
           <a:ln>
             <a:noFill/>
@@ -11366,11 +11452,11 @@
             <a:avLst/>
           </a:prstGeom>
           <a:solidFill>
-            <a:srgbClr val="0F172A"/>
+            <a:srgbClr val="0C162E"/>
           </a:solidFill>
           <a:ln>
             <a:solidFill>
-              <a:srgbClr val="22D3EE"/>
+              <a:srgbClr val="38BDF8"/>
             </a:solidFill>
           </a:ln>
         </p:spPr>
@@ -11400,7 +11486,7 @@
             <a:r>
               <a:rPr sz="1600" b="0">
                 <a:solidFill>
-                  <a:srgbClr val="E2E8F0"/>
+                  <a:srgbClr val="DDE6F4"/>
                 </a:solidFill>
                 <a:latin typeface="Arial"/>
               </a:rPr>
@@ -11439,7 +11525,7 @@
             <a:r>
               <a:rPr sz="1700" b="0">
                 <a:solidFill>
-                  <a:srgbClr val="E2E8F0"/>
+                  <a:srgbClr val="DDE6F4"/>
                 </a:solidFill>
                 <a:latin typeface="Arial"/>
               </a:rPr>
@@ -11455,7 +11541,7 @@
             <a:r>
               <a:rPr sz="1700" b="0">
                 <a:solidFill>
-                  <a:srgbClr val="E2E8F0"/>
+                  <a:srgbClr val="DDE6F4"/>
                 </a:solidFill>
                 <a:latin typeface="Arial"/>
               </a:rPr>
@@ -11471,7 +11557,7 @@
             <a:r>
               <a:rPr sz="1700" b="0">
                 <a:solidFill>
-                  <a:srgbClr val="E2E8F0"/>
+                  <a:srgbClr val="DDE6F4"/>
                 </a:solidFill>
                 <a:latin typeface="Arial"/>
               </a:rPr>
@@ -11487,7 +11573,7 @@
             <a:r>
               <a:rPr sz="1700" b="0">
                 <a:solidFill>
-                  <a:srgbClr val="E2E8F0"/>
+                  <a:srgbClr val="DDE6F4"/>
                 </a:solidFill>
                 <a:latin typeface="Arial"/>
               </a:rPr>
@@ -11503,7 +11589,7 @@
             <a:r>
               <a:rPr sz="1700" b="0">
                 <a:solidFill>
-                  <a:srgbClr val="E2E8F0"/>
+                  <a:srgbClr val="DDE6F4"/>
                 </a:solidFill>
                 <a:latin typeface="Arial"/>
               </a:rPr>
@@ -11527,11 +11613,11 @@
             <a:avLst/>
           </a:prstGeom>
           <a:solidFill>
-            <a:srgbClr val="030712"/>
+            <a:srgbClr val="060C1C"/>
           </a:solidFill>
           <a:ln>
             <a:solidFill>
-              <a:srgbClr val="22D3EE"/>
+              <a:srgbClr val="38BDF8"/>
             </a:solidFill>
           </a:ln>
         </p:spPr>
@@ -11557,7 +11643,7 @@
             <a:r>
               <a:rPr sz="1250" b="0">
                 <a:solidFill>
-                  <a:srgbClr val="C4FFEC"/>
+                  <a:srgbClr val="C5F4FF"/>
                 </a:solidFill>
                 <a:latin typeface="Courier New"/>
               </a:rPr>
@@ -11583,11 +11669,11 @@
             <a:avLst/>
           </a:prstGeom>
           <a:solidFill>
-            <a:srgbClr val="0D1426"/>
+            <a:srgbClr val="0F1830"/>
           </a:solidFill>
           <a:ln>
             <a:solidFill>
-              <a:srgbClr val="0D1426"/>
+              <a:srgbClr val="0F1830"/>
             </a:solidFill>
           </a:ln>
         </p:spPr>
@@ -11613,7 +11699,7 @@
             <a:r>
               <a:rPr sz="1000" b="1">
                 <a:solidFill>
-                  <a:srgbClr val="22D3EE"/>
+                  <a:srgbClr val="38BDF8"/>
                 </a:solidFill>
                 <a:latin typeface="Courier New"/>
               </a:rPr>
@@ -11648,7 +11734,7 @@
             <a:r>
               <a:rPr sz="1100" b="0">
                 <a:solidFill>
-                  <a:srgbClr val="94A3B8"/>
+                  <a:srgbClr val="899CBE"/>
                 </a:solidFill>
                 <a:latin typeface="Arial"/>
               </a:rPr>
@@ -11671,7 +11757,7 @@
     <p:bg>
       <p:bgPr>
         <a:solidFill>
-          <a:srgbClr val="020617"/>
+          <a:srgbClr val="040A18"/>
         </a:solidFill>
         <a:effectLst/>
       </p:bgPr>
@@ -11708,7 +11794,7 @@
             <a:r>
               <a:rPr sz="2400" b="1">
                 <a:solidFill>
-                  <a:srgbClr val="F1F5F9"/>
+                  <a:srgbClr val="F4F7FF"/>
                 </a:solidFill>
                 <a:latin typeface="Arial"/>
               </a:rPr>
@@ -11732,7 +11818,7 @@
             <a:avLst/>
           </a:prstGeom>
           <a:solidFill>
-            <a:srgbClr val="22D3EE"/>
+            <a:srgbClr val="38BDF8"/>
           </a:solidFill>
           <a:ln>
             <a:noFill/>
@@ -11775,11 +11861,11 @@
             <a:avLst/>
           </a:prstGeom>
           <a:solidFill>
-            <a:srgbClr val="0F172A"/>
+            <a:srgbClr val="0C162E"/>
           </a:solidFill>
           <a:ln>
             <a:solidFill>
-              <a:srgbClr val="22D3EE"/>
+              <a:srgbClr val="38BDF8"/>
             </a:solidFill>
           </a:ln>
         </p:spPr>
@@ -11809,7 +11895,7 @@
             <a:r>
               <a:rPr sz="1600" b="0">
                 <a:solidFill>
-                  <a:srgbClr val="E2E8F0"/>
+                  <a:srgbClr val="DDE6F4"/>
                 </a:solidFill>
                 <a:latin typeface="Arial"/>
               </a:rPr>
@@ -11833,11 +11919,11 @@
             <a:avLst/>
           </a:prstGeom>
           <a:solidFill>
-            <a:srgbClr val="0A1224"/>
+            <a:srgbClr val="091226"/>
           </a:solidFill>
           <a:ln>
             <a:solidFill>
-              <a:srgbClr val="22D3EE"/>
+              <a:srgbClr val="38BDF8"/>
             </a:solidFill>
           </a:ln>
         </p:spPr>
@@ -11878,11 +11964,11 @@
             <a:avLst/>
           </a:prstGeom>
           <a:solidFill>
-            <a:srgbClr val="0F172A"/>
+            <a:srgbClr val="0C162E"/>
           </a:solidFill>
           <a:ln>
             <a:solidFill>
-              <a:srgbClr val="0F172A"/>
+              <a:srgbClr val="0C162E"/>
             </a:solidFill>
           </a:ln>
         </p:spPr>
@@ -11908,7 +11994,7 @@
             <a:r>
               <a:rPr sz="1200" b="1">
                 <a:solidFill>
-                  <a:srgbClr val="22D3EE"/>
+                  <a:srgbClr val="38BDF8"/>
                 </a:solidFill>
                 <a:latin typeface="Arial"/>
               </a:rPr>
@@ -11947,7 +12033,7 @@
             <a:r>
               <a:rPr sz="1400" b="0">
                 <a:solidFill>
-                  <a:srgbClr val="E2E8F0"/>
+                  <a:srgbClr val="DDE6F4"/>
                 </a:solidFill>
                 <a:latin typeface="Arial"/>
               </a:rPr>
@@ -11963,7 +12049,7 @@
             <a:r>
               <a:rPr sz="1400" b="0">
                 <a:solidFill>
-                  <a:srgbClr val="E2E8F0"/>
+                  <a:srgbClr val="DDE6F4"/>
                 </a:solidFill>
                 <a:latin typeface="Arial"/>
               </a:rPr>
@@ -11979,7 +12065,7 @@
             <a:r>
               <a:rPr sz="1400" b="0">
                 <a:solidFill>
-                  <a:srgbClr val="E2E8F0"/>
+                  <a:srgbClr val="DDE6F4"/>
                 </a:solidFill>
                 <a:latin typeface="Arial"/>
               </a:rPr>
@@ -11995,7 +12081,7 @@
             <a:r>
               <a:rPr sz="1400" b="0">
                 <a:solidFill>
-                  <a:srgbClr val="E2E8F0"/>
+                  <a:srgbClr val="DDE6F4"/>
                 </a:solidFill>
                 <a:latin typeface="Arial"/>
               </a:rPr>
@@ -12019,11 +12105,11 @@
             <a:avLst/>
           </a:prstGeom>
           <a:solidFill>
-            <a:srgbClr val="0A1224"/>
+            <a:srgbClr val="091226"/>
           </a:solidFill>
           <a:ln>
             <a:solidFill>
-              <a:srgbClr val="22D3EE"/>
+              <a:srgbClr val="38BDF8"/>
             </a:solidFill>
           </a:ln>
         </p:spPr>
@@ -12064,11 +12150,11 @@
             <a:avLst/>
           </a:prstGeom>
           <a:solidFill>
-            <a:srgbClr val="0F172A"/>
+            <a:srgbClr val="0C162E"/>
           </a:solidFill>
           <a:ln>
             <a:solidFill>
-              <a:srgbClr val="0F172A"/>
+              <a:srgbClr val="0C162E"/>
             </a:solidFill>
           </a:ln>
         </p:spPr>
@@ -12094,7 +12180,7 @@
             <a:r>
               <a:rPr sz="1200" b="1">
                 <a:solidFill>
-                  <a:srgbClr val="22D3EE"/>
+                  <a:srgbClr val="38BDF8"/>
                 </a:solidFill>
                 <a:latin typeface="Arial"/>
               </a:rPr>
@@ -12133,7 +12219,7 @@
             <a:r>
               <a:rPr sz="1400" b="0">
                 <a:solidFill>
-                  <a:srgbClr val="E2E8F0"/>
+                  <a:srgbClr val="DDE6F4"/>
                 </a:solidFill>
                 <a:latin typeface="Arial"/>
               </a:rPr>
@@ -12149,7 +12235,7 @@
             <a:r>
               <a:rPr sz="1400" b="0">
                 <a:solidFill>
-                  <a:srgbClr val="E2E8F0"/>
+                  <a:srgbClr val="DDE6F4"/>
                 </a:solidFill>
                 <a:latin typeface="Arial"/>
               </a:rPr>
@@ -12173,11 +12259,11 @@
             <a:avLst/>
           </a:prstGeom>
           <a:solidFill>
-            <a:srgbClr val="0A1224"/>
+            <a:srgbClr val="091226"/>
           </a:solidFill>
           <a:ln>
             <a:solidFill>
-              <a:srgbClr val="22D3EE"/>
+              <a:srgbClr val="38BDF8"/>
             </a:solidFill>
           </a:ln>
         </p:spPr>
@@ -12218,11 +12304,11 @@
             <a:avLst/>
           </a:prstGeom>
           <a:solidFill>
-            <a:srgbClr val="0F172A"/>
+            <a:srgbClr val="0C162E"/>
           </a:solidFill>
           <a:ln>
             <a:solidFill>
-              <a:srgbClr val="0F172A"/>
+              <a:srgbClr val="0C162E"/>
             </a:solidFill>
           </a:ln>
         </p:spPr>
@@ -12248,7 +12334,7 @@
             <a:r>
               <a:rPr sz="1200" b="1">
                 <a:solidFill>
-                  <a:srgbClr val="22D3EE"/>
+                  <a:srgbClr val="38BDF8"/>
                 </a:solidFill>
                 <a:latin typeface="Arial"/>
               </a:rPr>
@@ -12287,7 +12373,7 @@
             <a:r>
               <a:rPr sz="1400" b="0">
                 <a:solidFill>
-                  <a:srgbClr val="E2E8F0"/>
+                  <a:srgbClr val="DDE6F4"/>
                 </a:solidFill>
                 <a:latin typeface="Arial"/>
               </a:rPr>
@@ -12303,7 +12389,7 @@
             <a:r>
               <a:rPr sz="1400" b="0">
                 <a:solidFill>
-                  <a:srgbClr val="E2E8F0"/>
+                  <a:srgbClr val="DDE6F4"/>
                 </a:solidFill>
                 <a:latin typeface="Arial"/>
               </a:rPr>
@@ -12327,11 +12413,11 @@
             <a:avLst/>
           </a:prstGeom>
           <a:solidFill>
-            <a:srgbClr val="030712"/>
+            <a:srgbClr val="060C1C"/>
           </a:solidFill>
           <a:ln>
             <a:solidFill>
-              <a:srgbClr val="22D3EE"/>
+              <a:srgbClr val="38BDF8"/>
             </a:solidFill>
           </a:ln>
         </p:spPr>
@@ -12357,7 +12443,7 @@
             <a:r>
               <a:rPr sz="1250" b="0">
                 <a:solidFill>
-                  <a:srgbClr val="C4FFEC"/>
+                  <a:srgbClr val="C5F4FF"/>
                 </a:solidFill>
                 <a:latin typeface="Courier New"/>
               </a:rPr>
@@ -12383,11 +12469,11 @@
             <a:avLst/>
           </a:prstGeom>
           <a:solidFill>
-            <a:srgbClr val="0D1426"/>
+            <a:srgbClr val="0F1830"/>
           </a:solidFill>
           <a:ln>
             <a:solidFill>
-              <a:srgbClr val="0D1426"/>
+              <a:srgbClr val="0F1830"/>
             </a:solidFill>
           </a:ln>
         </p:spPr>
@@ -12413,7 +12499,7 @@
             <a:r>
               <a:rPr sz="1000" b="1">
                 <a:solidFill>
-                  <a:srgbClr val="22D3EE"/>
+                  <a:srgbClr val="38BDF8"/>
                 </a:solidFill>
                 <a:latin typeface="Courier New"/>
               </a:rPr>
@@ -12448,7 +12534,7 @@
             <a:r>
               <a:rPr sz="1100" b="0">
                 <a:solidFill>
-                  <a:srgbClr val="94A3B8"/>
+                  <a:srgbClr val="899CBE"/>
                 </a:solidFill>
                 <a:latin typeface="Arial"/>
               </a:rPr>
@@ -12471,7 +12557,7 @@
     <p:bg>
       <p:bgPr>
         <a:solidFill>
-          <a:srgbClr val="020617"/>
+          <a:srgbClr val="040A18"/>
         </a:solidFill>
         <a:effectLst/>
       </p:bgPr>
@@ -12508,7 +12594,7 @@
             <a:r>
               <a:rPr sz="2400" b="1">
                 <a:solidFill>
-                  <a:srgbClr val="F1F5F9"/>
+                  <a:srgbClr val="F4F7FF"/>
                 </a:solidFill>
                 <a:latin typeface="Arial"/>
               </a:rPr>
@@ -12532,7 +12618,7 @@
             <a:avLst/>
           </a:prstGeom>
           <a:solidFill>
-            <a:srgbClr val="22D3EE"/>
+            <a:srgbClr val="38BDF8"/>
           </a:solidFill>
           <a:ln>
             <a:noFill/>
@@ -12575,11 +12661,11 @@
             <a:avLst/>
           </a:prstGeom>
           <a:solidFill>
-            <a:srgbClr val="0F172A"/>
+            <a:srgbClr val="0C162E"/>
           </a:solidFill>
           <a:ln>
             <a:solidFill>
-              <a:srgbClr val="22D3EE"/>
+              <a:srgbClr val="38BDF8"/>
             </a:solidFill>
           </a:ln>
         </p:spPr>
@@ -12609,7 +12695,7 @@
             <a:r>
               <a:rPr sz="1600" b="0">
                 <a:solidFill>
-                  <a:srgbClr val="E2E8F0"/>
+                  <a:srgbClr val="DDE6F4"/>
                 </a:solidFill>
                 <a:latin typeface="Arial"/>
               </a:rPr>
@@ -12633,11 +12719,11 @@
             <a:avLst/>
           </a:prstGeom>
           <a:solidFill>
-            <a:srgbClr val="0A1224"/>
+            <a:srgbClr val="091226"/>
           </a:solidFill>
           <a:ln>
             <a:solidFill>
-              <a:srgbClr val="22D3EE"/>
+              <a:srgbClr val="38BDF8"/>
             </a:solidFill>
           </a:ln>
         </p:spPr>
@@ -12678,11 +12764,11 @@
             <a:avLst/>
           </a:prstGeom>
           <a:solidFill>
-            <a:srgbClr val="0F172A"/>
+            <a:srgbClr val="0C162E"/>
           </a:solidFill>
           <a:ln>
             <a:solidFill>
-              <a:srgbClr val="0F172A"/>
+              <a:srgbClr val="0C162E"/>
             </a:solidFill>
           </a:ln>
         </p:spPr>
@@ -12708,7 +12794,7 @@
             <a:r>
               <a:rPr sz="1200" b="1">
                 <a:solidFill>
-                  <a:srgbClr val="22D3EE"/>
+                  <a:srgbClr val="38BDF8"/>
                 </a:solidFill>
                 <a:latin typeface="Arial"/>
               </a:rPr>
@@ -12747,7 +12833,7 @@
             <a:r>
               <a:rPr sz="1400" b="0">
                 <a:solidFill>
-                  <a:srgbClr val="E2E8F0"/>
+                  <a:srgbClr val="DDE6F4"/>
                 </a:solidFill>
                 <a:latin typeface="Arial"/>
               </a:rPr>
@@ -12763,7 +12849,7 @@
             <a:r>
               <a:rPr sz="1400" b="0">
                 <a:solidFill>
-                  <a:srgbClr val="E2E8F0"/>
+                  <a:srgbClr val="DDE6F4"/>
                 </a:solidFill>
                 <a:latin typeface="Arial"/>
               </a:rPr>
@@ -12787,11 +12873,11 @@
             <a:avLst/>
           </a:prstGeom>
           <a:solidFill>
-            <a:srgbClr val="0A1224"/>
+            <a:srgbClr val="091226"/>
           </a:solidFill>
           <a:ln>
             <a:solidFill>
-              <a:srgbClr val="22D3EE"/>
+              <a:srgbClr val="38BDF8"/>
             </a:solidFill>
           </a:ln>
         </p:spPr>
@@ -12832,11 +12918,11 @@
             <a:avLst/>
           </a:prstGeom>
           <a:solidFill>
-            <a:srgbClr val="0F172A"/>
+            <a:srgbClr val="0C162E"/>
           </a:solidFill>
           <a:ln>
             <a:solidFill>
-              <a:srgbClr val="0F172A"/>
+              <a:srgbClr val="0C162E"/>
             </a:solidFill>
           </a:ln>
         </p:spPr>
@@ -12862,7 +12948,7 @@
             <a:r>
               <a:rPr sz="1200" b="1">
                 <a:solidFill>
-                  <a:srgbClr val="22D3EE"/>
+                  <a:srgbClr val="38BDF8"/>
                 </a:solidFill>
                 <a:latin typeface="Arial"/>
               </a:rPr>
@@ -12901,7 +12987,7 @@
             <a:r>
               <a:rPr sz="1400" b="0">
                 <a:solidFill>
-                  <a:srgbClr val="E2E8F0"/>
+                  <a:srgbClr val="DDE6F4"/>
                 </a:solidFill>
                 <a:latin typeface="Arial"/>
               </a:rPr>
@@ -12917,7 +13003,7 @@
             <a:r>
               <a:rPr sz="1400" b="0">
                 <a:solidFill>
-                  <a:srgbClr val="E2E8F0"/>
+                  <a:srgbClr val="DDE6F4"/>
                 </a:solidFill>
                 <a:latin typeface="Arial"/>
               </a:rPr>
@@ -12941,11 +13027,11 @@
             <a:avLst/>
           </a:prstGeom>
           <a:solidFill>
-            <a:srgbClr val="0A1224"/>
+            <a:srgbClr val="091226"/>
           </a:solidFill>
           <a:ln>
             <a:solidFill>
-              <a:srgbClr val="22D3EE"/>
+              <a:srgbClr val="38BDF8"/>
             </a:solidFill>
           </a:ln>
         </p:spPr>
@@ -12986,11 +13072,11 @@
             <a:avLst/>
           </a:prstGeom>
           <a:solidFill>
-            <a:srgbClr val="0F172A"/>
+            <a:srgbClr val="0C162E"/>
           </a:solidFill>
           <a:ln>
             <a:solidFill>
-              <a:srgbClr val="0F172A"/>
+              <a:srgbClr val="0C162E"/>
             </a:solidFill>
           </a:ln>
         </p:spPr>
@@ -13016,7 +13102,7 @@
             <a:r>
               <a:rPr sz="1200" b="1">
                 <a:solidFill>
-                  <a:srgbClr val="22D3EE"/>
+                  <a:srgbClr val="38BDF8"/>
                 </a:solidFill>
                 <a:latin typeface="Arial"/>
               </a:rPr>
@@ -13055,7 +13141,7 @@
             <a:r>
               <a:rPr sz="1400" b="0">
                 <a:solidFill>
-                  <a:srgbClr val="E2E8F0"/>
+                  <a:srgbClr val="DDE6F4"/>
                 </a:solidFill>
                 <a:latin typeface="Arial"/>
               </a:rPr>
@@ -13071,7 +13157,7 @@
             <a:r>
               <a:rPr sz="1400" b="0">
                 <a:solidFill>
-                  <a:srgbClr val="E2E8F0"/>
+                  <a:srgbClr val="DDE6F4"/>
                 </a:solidFill>
                 <a:latin typeface="Arial"/>
               </a:rPr>
@@ -13095,11 +13181,11 @@
             <a:avLst/>
           </a:prstGeom>
           <a:solidFill>
-            <a:srgbClr val="030712"/>
+            <a:srgbClr val="060C1C"/>
           </a:solidFill>
           <a:ln>
             <a:solidFill>
-              <a:srgbClr val="22D3EE"/>
+              <a:srgbClr val="38BDF8"/>
             </a:solidFill>
           </a:ln>
         </p:spPr>
@@ -13125,7 +13211,7 @@
             <a:r>
               <a:rPr sz="1250" b="0">
                 <a:solidFill>
-                  <a:srgbClr val="C4FFEC"/>
+                  <a:srgbClr val="C5F4FF"/>
                 </a:solidFill>
                 <a:latin typeface="Courier New"/>
               </a:rPr>
@@ -13152,11 +13238,11 @@
             <a:avLst/>
           </a:prstGeom>
           <a:solidFill>
-            <a:srgbClr val="0D1426"/>
+            <a:srgbClr val="0F1830"/>
           </a:solidFill>
           <a:ln>
             <a:solidFill>
-              <a:srgbClr val="0D1426"/>
+              <a:srgbClr val="0F1830"/>
             </a:solidFill>
           </a:ln>
         </p:spPr>
@@ -13182,7 +13268,7 @@
             <a:r>
               <a:rPr sz="1000" b="1">
                 <a:solidFill>
-                  <a:srgbClr val="22D3EE"/>
+                  <a:srgbClr val="38BDF8"/>
                 </a:solidFill>
                 <a:latin typeface="Courier New"/>
               </a:rPr>
@@ -13217,7 +13303,7 @@
             <a:r>
               <a:rPr sz="1100" b="0">
                 <a:solidFill>
-                  <a:srgbClr val="94A3B8"/>
+                  <a:srgbClr val="899CBE"/>
                 </a:solidFill>
                 <a:latin typeface="Arial"/>
               </a:rPr>
@@ -13240,7 +13326,7 @@
     <p:bg>
       <p:bgPr>
         <a:solidFill>
-          <a:srgbClr val="020617"/>
+          <a:srgbClr val="040A18"/>
         </a:solidFill>
         <a:effectLst/>
       </p:bgPr>
@@ -13277,7 +13363,7 @@
             <a:r>
               <a:rPr sz="2400" b="1">
                 <a:solidFill>
-                  <a:srgbClr val="F1F5F9"/>
+                  <a:srgbClr val="F4F7FF"/>
                 </a:solidFill>
                 <a:latin typeface="Arial"/>
               </a:rPr>
@@ -13301,7 +13387,7 @@
             <a:avLst/>
           </a:prstGeom>
           <a:solidFill>
-            <a:srgbClr val="22D3EE"/>
+            <a:srgbClr val="38BDF8"/>
           </a:solidFill>
           <a:ln>
             <a:noFill/>
@@ -13344,11 +13430,11 @@
             <a:avLst/>
           </a:prstGeom>
           <a:solidFill>
-            <a:srgbClr val="0F172A"/>
+            <a:srgbClr val="0C162E"/>
           </a:solidFill>
           <a:ln>
             <a:solidFill>
-              <a:srgbClr val="22D3EE"/>
+              <a:srgbClr val="38BDF8"/>
             </a:solidFill>
           </a:ln>
         </p:spPr>
@@ -13378,7 +13464,7 @@
             <a:r>
               <a:rPr sz="1600" b="0">
                 <a:solidFill>
-                  <a:srgbClr val="E2E8F0"/>
+                  <a:srgbClr val="DDE6F4"/>
                 </a:solidFill>
                 <a:latin typeface="Arial"/>
               </a:rPr>
@@ -13402,11 +13488,11 @@
             <a:avLst/>
           </a:prstGeom>
           <a:solidFill>
-            <a:srgbClr val="0A1224"/>
+            <a:srgbClr val="091226"/>
           </a:solidFill>
           <a:ln>
             <a:solidFill>
-              <a:srgbClr val="22D3EE"/>
+              <a:srgbClr val="38BDF8"/>
             </a:solidFill>
           </a:ln>
         </p:spPr>
@@ -13447,11 +13533,11 @@
             <a:avLst/>
           </a:prstGeom>
           <a:solidFill>
-            <a:srgbClr val="0F172A"/>
+            <a:srgbClr val="0C162E"/>
           </a:solidFill>
           <a:ln>
             <a:solidFill>
-              <a:srgbClr val="0F172A"/>
+              <a:srgbClr val="0C162E"/>
             </a:solidFill>
           </a:ln>
         </p:spPr>
@@ -13477,7 +13563,7 @@
             <a:r>
               <a:rPr sz="1200" b="1">
                 <a:solidFill>
-                  <a:srgbClr val="22D3EE"/>
+                  <a:srgbClr val="38BDF8"/>
                 </a:solidFill>
                 <a:latin typeface="Arial"/>
               </a:rPr>
@@ -13516,7 +13602,7 @@
             <a:r>
               <a:rPr sz="1400" b="0">
                 <a:solidFill>
-                  <a:srgbClr val="E2E8F0"/>
+                  <a:srgbClr val="DDE6F4"/>
                 </a:solidFill>
                 <a:latin typeface="Arial"/>
               </a:rPr>
@@ -13532,7 +13618,7 @@
             <a:r>
               <a:rPr sz="1400" b="0">
                 <a:solidFill>
-                  <a:srgbClr val="E2E8F0"/>
+                  <a:srgbClr val="DDE6F4"/>
                 </a:solidFill>
                 <a:latin typeface="Arial"/>
               </a:rPr>
@@ -13548,7 +13634,7 @@
             <a:r>
               <a:rPr sz="1400" b="0">
                 <a:solidFill>
-                  <a:srgbClr val="E2E8F0"/>
+                  <a:srgbClr val="DDE6F4"/>
                 </a:solidFill>
                 <a:latin typeface="Arial"/>
               </a:rPr>
@@ -13572,11 +13658,11 @@
             <a:avLst/>
           </a:prstGeom>
           <a:solidFill>
-            <a:srgbClr val="0A1224"/>
+            <a:srgbClr val="091226"/>
           </a:solidFill>
           <a:ln>
             <a:solidFill>
-              <a:srgbClr val="22D3EE"/>
+              <a:srgbClr val="38BDF8"/>
             </a:solidFill>
           </a:ln>
         </p:spPr>
@@ -13617,11 +13703,11 @@
             <a:avLst/>
           </a:prstGeom>
           <a:solidFill>
-            <a:srgbClr val="0F172A"/>
+            <a:srgbClr val="0C162E"/>
           </a:solidFill>
           <a:ln>
             <a:solidFill>
-              <a:srgbClr val="0F172A"/>
+              <a:srgbClr val="0C162E"/>
             </a:solidFill>
           </a:ln>
         </p:spPr>
@@ -13647,7 +13733,7 @@
             <a:r>
               <a:rPr sz="1200" b="1">
                 <a:solidFill>
-                  <a:srgbClr val="22D3EE"/>
+                  <a:srgbClr val="38BDF8"/>
                 </a:solidFill>
                 <a:latin typeface="Arial"/>
               </a:rPr>
@@ -13686,7 +13772,7 @@
             <a:r>
               <a:rPr sz="1400" b="0">
                 <a:solidFill>
-                  <a:srgbClr val="E2E8F0"/>
+                  <a:srgbClr val="DDE6F4"/>
                 </a:solidFill>
                 <a:latin typeface="Arial"/>
               </a:rPr>
@@ -13702,7 +13788,7 @@
             <a:r>
               <a:rPr sz="1400" b="0">
                 <a:solidFill>
-                  <a:srgbClr val="E2E8F0"/>
+                  <a:srgbClr val="DDE6F4"/>
                 </a:solidFill>
                 <a:latin typeface="Arial"/>
               </a:rPr>
@@ -13726,11 +13812,11 @@
             <a:avLst/>
           </a:prstGeom>
           <a:solidFill>
-            <a:srgbClr val="0A1224"/>
+            <a:srgbClr val="091226"/>
           </a:solidFill>
           <a:ln>
             <a:solidFill>
-              <a:srgbClr val="22D3EE"/>
+              <a:srgbClr val="38BDF8"/>
             </a:solidFill>
           </a:ln>
         </p:spPr>
@@ -13771,11 +13857,11 @@
             <a:avLst/>
           </a:prstGeom>
           <a:solidFill>
-            <a:srgbClr val="0F172A"/>
+            <a:srgbClr val="0C162E"/>
           </a:solidFill>
           <a:ln>
             <a:solidFill>
-              <a:srgbClr val="0F172A"/>
+              <a:srgbClr val="0C162E"/>
             </a:solidFill>
           </a:ln>
         </p:spPr>
@@ -13801,7 +13887,7 @@
             <a:r>
               <a:rPr sz="1200" b="1">
                 <a:solidFill>
-                  <a:srgbClr val="22D3EE"/>
+                  <a:srgbClr val="38BDF8"/>
                 </a:solidFill>
                 <a:latin typeface="Arial"/>
               </a:rPr>
@@ -13840,7 +13926,7 @@
             <a:r>
               <a:rPr sz="1400" b="0">
                 <a:solidFill>
-                  <a:srgbClr val="E2E8F0"/>
+                  <a:srgbClr val="DDE6F4"/>
                 </a:solidFill>
                 <a:latin typeface="Arial"/>
               </a:rPr>
@@ -13856,7 +13942,7 @@
             <a:r>
               <a:rPr sz="1400" b="0">
                 <a:solidFill>
-                  <a:srgbClr val="E2E8F0"/>
+                  <a:srgbClr val="DDE6F4"/>
                 </a:solidFill>
                 <a:latin typeface="Arial"/>
               </a:rPr>
@@ -13880,11 +13966,11 @@
             <a:avLst/>
           </a:prstGeom>
           <a:solidFill>
-            <a:srgbClr val="030712"/>
+            <a:srgbClr val="060C1C"/>
           </a:solidFill>
           <a:ln>
             <a:solidFill>
-              <a:srgbClr val="22D3EE"/>
+              <a:srgbClr val="38BDF8"/>
             </a:solidFill>
           </a:ln>
         </p:spPr>
@@ -13910,7 +13996,7 @@
             <a:r>
               <a:rPr sz="1250" b="0">
                 <a:solidFill>
-                  <a:srgbClr val="C4FFEC"/>
+                  <a:srgbClr val="C5F4FF"/>
                 </a:solidFill>
                 <a:latin typeface="Courier New"/>
               </a:rPr>
@@ -13935,11 +14021,11 @@
             <a:avLst/>
           </a:prstGeom>
           <a:solidFill>
-            <a:srgbClr val="0D1426"/>
+            <a:srgbClr val="0F1830"/>
           </a:solidFill>
           <a:ln>
             <a:solidFill>
-              <a:srgbClr val="0D1426"/>
+              <a:srgbClr val="0F1830"/>
             </a:solidFill>
           </a:ln>
         </p:spPr>
@@ -13965,7 +14051,7 @@
             <a:r>
               <a:rPr sz="1000" b="1">
                 <a:solidFill>
-                  <a:srgbClr val="22D3EE"/>
+                  <a:srgbClr val="38BDF8"/>
                 </a:solidFill>
                 <a:latin typeface="Courier New"/>
               </a:rPr>
@@ -14000,7 +14086,7 @@
             <a:r>
               <a:rPr sz="1100" b="0">
                 <a:solidFill>
-                  <a:srgbClr val="94A3B8"/>
+                  <a:srgbClr val="899CBE"/>
                 </a:solidFill>
                 <a:latin typeface="Arial"/>
               </a:rPr>

</xml_diff>